<commit_message>
Add conceptual through-lines: per-deck slide + site section
- slides: new 'How this week connects' through-lines slide in every deck (now 8 slides each),
  tracing the course's recurring threads (beyond counting; every method is a choice; the
  readers you can and can't see; whose data and judgment; AI as instrument; images co-equal)
  and how each week advances them. Driven by THREADS in slides/export_slides.py.
- site: a 'The through-lines' section on the About page.
- Rebuilt export_slides.py and styled_pptx.js via shell (the editor kept truncating them);
  both compile, decks visual-QA'd, site 15 pages no-JS no-broken-links zero em-dashes.
</commit_message>
<xml_diff>
--- a/slides/pptx/week-01.pptx
+++ b/slides/pptx/week-01.pptx
@@ -12,9 +12,10 @@
     <p:sldId id="260" r:id="rId6"/>
     <p:sldId id="261" r:id="rId7"/>
     <p:sldId id="262" r:id="rId8"/>
+    <p:sldId id="263" r:id="rId9"/>
   </p:sldIdLst>
   <p:notesMasterIdLst>
-    <p:notesMasterId r:id="rId9"/>
+    <p:notesMasterId r:id="rId10"/>
   </p:notesMasterIdLst>
   <p:sldSz cx="12191695" cy="6858000"/>
   <p:notesSz cx="6858000" cy="12191695"/>
@@ -1078,6 +1079,94 @@
 </p:notes>
 </file>
 
+<file path=ppt/notesSlides/notesSlide8.xml><?xml version="1.0" encoding="utf-8"?>
+<p:notes xmlns:a="http://schemas.openxmlformats.org/drawingml/2006/main" xmlns:r="http://schemas.openxmlformats.org/officeDocument/2006/relationships" xmlns:p="http://schemas.openxmlformats.org/presentationml/2006/main">
+  <p:cSld>
+    <p:spTree>
+      <p:nvGrpSpPr>
+        <p:cNvPr id="1" name=""/>
+        <p:cNvGrpSpPr/>
+        <p:nvPr/>
+      </p:nvGrpSpPr>
+      <p:grpSpPr>
+        <a:xfrm>
+          <a:off x="0" y="0"/>
+          <a:ext cx="0" cy="0"/>
+          <a:chOff x="0" y="0"/>
+          <a:chExt cx="0" cy="0"/>
+        </a:xfrm>
+      </p:grpSpPr>
+      <p:sp>
+        <p:nvSpPr>
+          <p:cNvPr id="2" name="Slide Image Placeholder 1"/>
+          <p:cNvSpPr>
+            <a:spLocks noGrp="1" noRot="1" noChangeAspect="1"/>
+          </p:cNvSpPr>
+          <p:nvPr>
+            <p:ph type="sldImg"/>
+          </p:nvPr>
+        </p:nvSpPr>
+        <p:spPr/>
+      </p:sp>
+      <p:sp>
+        <p:nvSpPr>
+          <p:cNvPr id="3" name="Notes Placeholder 2"/>
+          <p:cNvSpPr>
+            <a:spLocks noGrp="1"/>
+          </p:cNvSpPr>
+          <p:nvPr>
+            <p:ph type="body" idx="1"/>
+          </p:nvPr>
+        </p:nvSpPr>
+        <p:spPr/>
+        <p:txBody>
+          <a:bodyPr/>
+          <a:lstStyle/>
+          <a:p>
+            <a:r>
+              <a:rPr lang="en-US" dirty="0"/>
+              <a:t/>
+            </a:r>
+            <a:endParaRPr lang="en-US" dirty="0"/>
+          </a:p>
+        </p:txBody>
+      </p:sp>
+      <p:sp>
+        <p:nvSpPr>
+          <p:cNvPr id="4" name="Slide Number Placeholder 3"/>
+          <p:cNvSpPr>
+            <a:spLocks noGrp="1"/>
+          </p:cNvSpPr>
+          <p:nvPr>
+            <p:ph type="sldNum" sz="quarter" idx="10"/>
+          </p:nvPr>
+        </p:nvSpPr>
+        <p:spPr/>
+        <p:txBody>
+          <a:bodyPr/>
+          <a:lstStyle/>
+          <a:p>
+            <a:fld id="{F7021451-1387-4CA6-816F-3879F97B5CBC}" type="slidenum">
+              <a:rPr lang="en-US"/>
+              <a:t>8</a:t>
+            </a:fld>
+            <a:endParaRPr lang="en-US"/>
+          </a:p>
+        </p:txBody>
+      </p:sp>
+    </p:spTree>
+    <p:extLst>
+      <p:ext uri="{BB962C8B-B14F-4D97-AF65-F5344CB8AC3E}">
+        <p14:creationId xmlns:p14="http://schemas.microsoft.com/office/powerpoint/2010/main" val="1024086991"/>
+      </p:ext>
+    </p:extLst>
+  </p:cSld>
+  <p:clrMapOvr>
+    <a:masterClrMapping/>
+  </p:clrMapOvr>
+</p:notes>
+</file>
+
 <file path=ppt/slideLayouts/slideLayout1.xml><?xml version="1.0" encoding="utf-8"?>
 <p:sldLayout xmlns:a="http://schemas.openxmlformats.org/drawingml/2006/main" xmlns:r="http://schemas.openxmlformats.org/officeDocument/2006/relationships" xmlns:p="http://schemas.openxmlformats.org/presentationml/2006/main" preserve="1">
   <p:cSld name="DEFAULT">
@@ -4090,6 +4179,548 @@
 <file path=ppt/slides/slide7.xml><?xml version="1.0" encoding="utf-8"?>
 <p:sld xmlns:a="http://schemas.openxmlformats.org/drawingml/2006/main" xmlns:r="http://schemas.openxmlformats.org/officeDocument/2006/relationships" xmlns:p="http://schemas.openxmlformats.org/presentationml/2006/main">
   <p:cSld name="Slide 7">
+    <p:bg>
+      <p:bgPr>
+        <a:solidFill>
+          <a:srgbClr val="FFFFFF"/>
+        </a:solidFill>
+      </p:bgPr>
+    </p:bg>
+    <p:spTree>
+      <p:nvGrpSpPr>
+        <p:cNvPr id="1" name=""/>
+        <p:cNvGrpSpPr/>
+        <p:nvPr/>
+      </p:nvGrpSpPr>
+      <p:grpSpPr>
+        <a:xfrm>
+          <a:off x="0" y="0"/>
+          <a:ext cx="0" cy="0"/>
+          <a:chOff x="0" y="0"/>
+          <a:chExt cx="0" cy="0"/>
+        </a:xfrm>
+      </p:grpSpPr>
+      <p:sp>
+        <p:nvSpPr>
+          <p:cNvPr id="2" name="Text 0"/>
+          <p:cNvSpPr/>
+          <p:nvPr/>
+        </p:nvSpPr>
+        <p:spPr>
+          <a:xfrm>
+            <a:off x="640080" y="640080"/>
+            <a:ext cx="10058400" cy="320040"/>
+          </a:xfrm>
+          <a:prstGeom prst="rect">
+            <a:avLst/>
+          </a:prstGeom>
+          <a:noFill/>
+          <a:ln/>
+        </p:spPr>
+        <p:txBody>
+          <a:bodyPr wrap="square" rtlCol="0" anchor="ctr"/>
+          <a:lstStyle/>
+          <a:p>
+            <a:pPr indent="0" marL="0">
+              <a:buNone/>
+            </a:pPr>
+            <a:r>
+              <a:rPr lang="en-US" sz="1300" b="1" spc="300" kern="0" dirty="0">
+                <a:solidFill>
+                  <a:srgbClr val="7A3B2E"/>
+                </a:solidFill>
+                <a:latin typeface="Calibri" pitchFamily="34" charset="0"/>
+                <a:ea typeface="Calibri" pitchFamily="34" charset="-122"/>
+                <a:cs typeface="Calibri" pitchFamily="34" charset="-120"/>
+              </a:rPr>
+              <a:t>HOW THIS WEEK CONNECTS</a:t>
+            </a:r>
+            <a:endParaRPr lang="en-US" sz="1300" dirty="0"/>
+          </a:p>
+        </p:txBody>
+      </p:sp>
+      <p:sp>
+        <p:nvSpPr>
+          <p:cNvPr id="3" name="Text 1"/>
+          <p:cNvSpPr/>
+          <p:nvPr/>
+        </p:nvSpPr>
+        <p:spPr>
+          <a:xfrm>
+            <a:off x="640080" y="987552"/>
+            <a:ext cx="10058400" cy="640080"/>
+          </a:xfrm>
+          <a:prstGeom prst="rect">
+            <a:avLst/>
+          </a:prstGeom>
+          <a:noFill/>
+          <a:ln/>
+        </p:spPr>
+        <p:txBody>
+          <a:bodyPr wrap="square" rtlCol="0" anchor="ctr"/>
+          <a:lstStyle/>
+          <a:p>
+            <a:pPr indent="0" marL="0">
+              <a:buNone/>
+            </a:pPr>
+            <a:r>
+              <a:rPr lang="en-US" sz="2800" b="1" dirty="0">
+                <a:solidFill>
+                  <a:srgbClr val="1A1A1A"/>
+                </a:solidFill>
+                <a:latin typeface="Cambria" pitchFamily="34" charset="0"/>
+                <a:ea typeface="Cambria" pitchFamily="34" charset="-122"/>
+                <a:cs typeface="Cambria" pitchFamily="34" charset="-120"/>
+              </a:rPr>
+              <a:t>The course's through-lines</a:t>
+            </a:r>
+            <a:endParaRPr lang="en-US" sz="2800" dirty="0"/>
+          </a:p>
+        </p:txBody>
+      </p:sp>
+      <p:sp>
+        <p:nvSpPr>
+          <p:cNvPr id="4" name="Shape 2"/>
+          <p:cNvSpPr/>
+          <p:nvPr/>
+        </p:nvSpPr>
+        <p:spPr>
+          <a:xfrm>
+            <a:off x="640080" y="2057400"/>
+            <a:ext cx="457200" cy="457200"/>
+          </a:xfrm>
+          <a:prstGeom prst="roundRect">
+            <a:avLst>
+              <a:gd name="adj" fmla="val 16000"/>
+            </a:avLst>
+          </a:prstGeom>
+          <a:solidFill>
+            <a:srgbClr val="7A3B2E"/>
+          </a:solidFill>
+          <a:ln/>
+        </p:spPr>
+      </p:sp>
+      <p:sp>
+        <p:nvSpPr>
+          <p:cNvPr id="5" name="Text 3"/>
+          <p:cNvSpPr/>
+          <p:nvPr/>
+        </p:nvSpPr>
+        <p:spPr>
+          <a:xfrm>
+            <a:off x="640080" y="2057400"/>
+            <a:ext cx="457200" cy="457200"/>
+          </a:xfrm>
+          <a:prstGeom prst="rect">
+            <a:avLst/>
+          </a:prstGeom>
+          <a:noFill/>
+          <a:ln/>
+        </p:spPr>
+        <p:txBody>
+          <a:bodyPr wrap="square" rtlCol="0" anchor="ctr"/>
+          <a:lstStyle/>
+          <a:p>
+            <a:pPr algn="ctr" indent="0" marL="0">
+              <a:buNone/>
+            </a:pPr>
+            <a:r>
+              <a:rPr lang="en-US" sz="2000" b="1" dirty="0">
+                <a:solidFill>
+                  <a:srgbClr val="FFFFFF"/>
+                </a:solidFill>
+                <a:latin typeface="Cambria" pitchFamily="34" charset="0"/>
+                <a:ea typeface="Cambria" pitchFamily="34" charset="-122"/>
+                <a:cs typeface="Cambria" pitchFamily="34" charset="-120"/>
+              </a:rPr>
+              <a:t>1</a:t>
+            </a:r>
+            <a:endParaRPr lang="en-US" sz="2000" dirty="0"/>
+          </a:p>
+        </p:txBody>
+      </p:sp>
+      <p:sp>
+        <p:nvSpPr>
+          <p:cNvPr id="6" name="Text 4"/>
+          <p:cNvSpPr/>
+          <p:nvPr/>
+        </p:nvSpPr>
+        <p:spPr>
+          <a:xfrm>
+            <a:off x="1371600" y="2020824"/>
+            <a:ext cx="10332720" cy="411480"/>
+          </a:xfrm>
+          <a:prstGeom prst="rect">
+            <a:avLst/>
+          </a:prstGeom>
+          <a:noFill/>
+          <a:ln/>
+        </p:spPr>
+        <p:txBody>
+          <a:bodyPr wrap="square" rtlCol="0" anchor="ctr"/>
+          <a:lstStyle/>
+          <a:p>
+            <a:pPr indent="0" marL="0">
+              <a:buNone/>
+            </a:pPr>
+            <a:r>
+              <a:rPr lang="en-US" sz="1900" b="1" dirty="0">
+                <a:solidFill>
+                  <a:srgbClr val="7A3B2E"/>
+                </a:solidFill>
+                <a:latin typeface="Cambria" pitchFamily="34" charset="0"/>
+                <a:ea typeface="Cambria" pitchFamily="34" charset="-122"/>
+                <a:cs typeface="Cambria" pitchFamily="34" charset="-120"/>
+              </a:rPr>
+              <a:t>Read work critically</a:t>
+            </a:r>
+            <a:endParaRPr lang="en-US" sz="1900" dirty="0"/>
+          </a:p>
+        </p:txBody>
+      </p:sp>
+      <p:sp>
+        <p:nvSpPr>
+          <p:cNvPr id="7" name="Text 5"/>
+          <p:cNvSpPr/>
+          <p:nvPr/>
+        </p:nvSpPr>
+        <p:spPr>
+          <a:xfrm>
+            <a:off x="1371600" y="2441448"/>
+            <a:ext cx="10332720" cy="914400"/>
+          </a:xfrm>
+          <a:prstGeom prst="rect">
+            <a:avLst/>
+          </a:prstGeom>
+          <a:noFill/>
+          <a:ln/>
+        </p:spPr>
+        <p:txBody>
+          <a:bodyPr wrap="square" rtlCol="0" anchor="t">
+            <a:spAutoFit/>
+          </a:bodyPr>
+          <a:lstStyle/>
+          <a:p>
+            <a:pPr indent="0" marL="0">
+              <a:lnSpc>
+                <a:spcPct val="112000"/>
+              </a:lnSpc>
+              <a:buNone/>
+            </a:pPr>
+            <a:r>
+              <a:rPr lang="en-US" sz="1450" dirty="0">
+                <a:solidFill>
+                  <a:srgbClr val="1A1A1A"/>
+                </a:solidFill>
+                <a:latin typeface="Calibri" pitchFamily="34" charset="0"/>
+                <a:ea typeface="Calibri" pitchFamily="34" charset="-122"/>
+                <a:cs typeface="Calibri" pitchFamily="34" charset="-120"/>
+              </a:rPr>
+              <a:t>Pockets is great and its choices are arguable. We admire and interrogate at once, the habit the whole course turns on.</a:t>
+            </a:r>
+            <a:endParaRPr lang="en-US" sz="1450" dirty="0"/>
+          </a:p>
+        </p:txBody>
+      </p:sp>
+      <p:sp>
+        <p:nvSpPr>
+          <p:cNvPr id="8" name="Shape 6"/>
+          <p:cNvSpPr/>
+          <p:nvPr/>
+        </p:nvSpPr>
+        <p:spPr>
+          <a:xfrm>
+            <a:off x="640080" y="3520440"/>
+            <a:ext cx="457200" cy="457200"/>
+          </a:xfrm>
+          <a:prstGeom prst="roundRect">
+            <a:avLst>
+              <a:gd name="adj" fmla="val 16000"/>
+            </a:avLst>
+          </a:prstGeom>
+          <a:solidFill>
+            <a:srgbClr val="3F6F5F"/>
+          </a:solidFill>
+          <a:ln/>
+        </p:spPr>
+      </p:sp>
+      <p:sp>
+        <p:nvSpPr>
+          <p:cNvPr id="9" name="Text 7"/>
+          <p:cNvSpPr/>
+          <p:nvPr/>
+        </p:nvSpPr>
+        <p:spPr>
+          <a:xfrm>
+            <a:off x="640080" y="3520440"/>
+            <a:ext cx="457200" cy="457200"/>
+          </a:xfrm>
+          <a:prstGeom prst="rect">
+            <a:avLst/>
+          </a:prstGeom>
+          <a:noFill/>
+          <a:ln/>
+        </p:spPr>
+        <p:txBody>
+          <a:bodyPr wrap="square" rtlCol="0" anchor="ctr"/>
+          <a:lstStyle/>
+          <a:p>
+            <a:pPr algn="ctr" indent="0" marL="0">
+              <a:buNone/>
+            </a:pPr>
+            <a:r>
+              <a:rPr lang="en-US" sz="2000" b="1" dirty="0">
+                <a:solidFill>
+                  <a:srgbClr val="FFFFFF"/>
+                </a:solidFill>
+                <a:latin typeface="Cambria" pitchFamily="34" charset="0"/>
+                <a:ea typeface="Cambria" pitchFamily="34" charset="-122"/>
+                <a:cs typeface="Cambria" pitchFamily="34" charset="-120"/>
+              </a:rPr>
+              <a:t>2</a:t>
+            </a:r>
+            <a:endParaRPr lang="en-US" sz="2000" dirty="0"/>
+          </a:p>
+        </p:txBody>
+      </p:sp>
+      <p:sp>
+        <p:nvSpPr>
+          <p:cNvPr id="10" name="Text 8"/>
+          <p:cNvSpPr/>
+          <p:nvPr/>
+        </p:nvSpPr>
+        <p:spPr>
+          <a:xfrm>
+            <a:off x="1371600" y="3483864"/>
+            <a:ext cx="10332720" cy="411480"/>
+          </a:xfrm>
+          <a:prstGeom prst="rect">
+            <a:avLst/>
+          </a:prstGeom>
+          <a:noFill/>
+          <a:ln/>
+        </p:spPr>
+        <p:txBody>
+          <a:bodyPr wrap="square" rtlCol="0" anchor="ctr"/>
+          <a:lstStyle/>
+          <a:p>
+            <a:pPr indent="0" marL="0">
+              <a:buNone/>
+            </a:pPr>
+            <a:r>
+              <a:rPr lang="en-US" sz="1900" b="1" dirty="0">
+                <a:solidFill>
+                  <a:srgbClr val="3F6F5F"/>
+                </a:solidFill>
+                <a:latin typeface="Cambria" pitchFamily="34" charset="0"/>
+                <a:ea typeface="Cambria" pitchFamily="34" charset="-122"/>
+                <a:cs typeface="Cambria" pitchFamily="34" charset="-120"/>
+              </a:rPr>
+              <a:t>Make something real</a:t>
+            </a:r>
+            <a:endParaRPr lang="en-US" sz="1900" dirty="0"/>
+          </a:p>
+        </p:txBody>
+      </p:sp>
+      <p:sp>
+        <p:nvSpPr>
+          <p:cNvPr id="11" name="Text 9"/>
+          <p:cNvSpPr/>
+          <p:nvPr/>
+        </p:nvSpPr>
+        <p:spPr>
+          <a:xfrm>
+            <a:off x="1371600" y="3904488"/>
+            <a:ext cx="10332720" cy="914400"/>
+          </a:xfrm>
+          <a:prstGeom prst="rect">
+            <a:avLst/>
+          </a:prstGeom>
+          <a:noFill/>
+          <a:ln/>
+        </p:spPr>
+        <p:txBody>
+          <a:bodyPr wrap="square" rtlCol="0" anchor="t">
+            <a:spAutoFit/>
+          </a:bodyPr>
+          <a:lstStyle/>
+          <a:p>
+            <a:pPr indent="0" marL="0">
+              <a:lnSpc>
+                <a:spcPct val="112000"/>
+              </a:lnSpc>
+              <a:buNone/>
+            </a:pPr>
+            <a:r>
+              <a:rPr lang="en-US" sz="1450" dirty="0">
+                <a:solidFill>
+                  <a:srgbClr val="1A1A1A"/>
+                </a:solidFill>
+                <a:latin typeface="Calibri" pitchFamily="34" charset="0"/>
+                <a:ea typeface="Calibri" pitchFamily="34" charset="-122"/>
+                <a:cs typeface="Calibri" pitchFamily="34" charset="-120"/>
+              </a:rPr>
+              <a:t>A complete investigation by the first break, before any theory.</a:t>
+            </a:r>
+            <a:endParaRPr lang="en-US" sz="1450" dirty="0"/>
+          </a:p>
+        </p:txBody>
+      </p:sp>
+      <p:sp>
+        <p:nvSpPr>
+          <p:cNvPr id="12" name="Shape 10"/>
+          <p:cNvSpPr/>
+          <p:nvPr/>
+        </p:nvSpPr>
+        <p:spPr>
+          <a:xfrm>
+            <a:off x="640080" y="4983480"/>
+            <a:ext cx="457200" cy="457200"/>
+          </a:xfrm>
+          <a:prstGeom prst="roundRect">
+            <a:avLst>
+              <a:gd name="adj" fmla="val 16000"/>
+            </a:avLst>
+          </a:prstGeom>
+          <a:solidFill>
+            <a:srgbClr val="B9852F"/>
+          </a:solidFill>
+          <a:ln/>
+        </p:spPr>
+      </p:sp>
+      <p:sp>
+        <p:nvSpPr>
+          <p:cNvPr id="13" name="Text 11"/>
+          <p:cNvSpPr/>
+          <p:nvPr/>
+        </p:nvSpPr>
+        <p:spPr>
+          <a:xfrm>
+            <a:off x="640080" y="4983480"/>
+            <a:ext cx="457200" cy="457200"/>
+          </a:xfrm>
+          <a:prstGeom prst="rect">
+            <a:avLst/>
+          </a:prstGeom>
+          <a:noFill/>
+          <a:ln/>
+        </p:spPr>
+        <p:txBody>
+          <a:bodyPr wrap="square" rtlCol="0" anchor="ctr"/>
+          <a:lstStyle/>
+          <a:p>
+            <a:pPr algn="ctr" indent="0" marL="0">
+              <a:buNone/>
+            </a:pPr>
+            <a:r>
+              <a:rPr lang="en-US" sz="2000" b="1" dirty="0">
+                <a:solidFill>
+                  <a:srgbClr val="FFFFFF"/>
+                </a:solidFill>
+                <a:latin typeface="Cambria" pitchFamily="34" charset="0"/>
+                <a:ea typeface="Cambria" pitchFamily="34" charset="-122"/>
+                <a:cs typeface="Cambria" pitchFamily="34" charset="-120"/>
+              </a:rPr>
+              <a:t>3</a:t>
+            </a:r>
+            <a:endParaRPr lang="en-US" sz="2000" dirty="0"/>
+          </a:p>
+        </p:txBody>
+      </p:sp>
+      <p:sp>
+        <p:nvSpPr>
+          <p:cNvPr id="14" name="Text 12"/>
+          <p:cNvSpPr/>
+          <p:nvPr/>
+        </p:nvSpPr>
+        <p:spPr>
+          <a:xfrm>
+            <a:off x="1371600" y="4946904"/>
+            <a:ext cx="10332720" cy="411480"/>
+          </a:xfrm>
+          <a:prstGeom prst="rect">
+            <a:avLst/>
+          </a:prstGeom>
+          <a:noFill/>
+          <a:ln/>
+        </p:spPr>
+        <p:txBody>
+          <a:bodyPr wrap="square" rtlCol="0" anchor="ctr"/>
+          <a:lstStyle/>
+          <a:p>
+            <a:pPr indent="0" marL="0">
+              <a:buNone/>
+            </a:pPr>
+            <a:r>
+              <a:rPr lang="en-US" sz="1900" b="1" dirty="0">
+                <a:solidFill>
+                  <a:srgbClr val="B9852F"/>
+                </a:solidFill>
+                <a:latin typeface="Cambria" pitchFamily="34" charset="0"/>
+                <a:ea typeface="Cambria" pitchFamily="34" charset="-122"/>
+                <a:cs typeface="Cambria" pitchFamily="34" charset="-120"/>
+              </a:rPr>
+              <a:t>Beyond counting (preview)</a:t>
+            </a:r>
+            <a:endParaRPr lang="en-US" sz="1900" dirty="0"/>
+          </a:p>
+        </p:txBody>
+      </p:sp>
+      <p:sp>
+        <p:nvSpPr>
+          <p:cNvPr id="15" name="Text 13"/>
+          <p:cNvSpPr/>
+          <p:nvPr/>
+        </p:nvSpPr>
+        <p:spPr>
+          <a:xfrm>
+            <a:off x="1371600" y="5367528"/>
+            <a:ext cx="10332720" cy="914400"/>
+          </a:xfrm>
+          <a:prstGeom prst="rect">
+            <a:avLst/>
+          </a:prstGeom>
+          <a:noFill/>
+          <a:ln/>
+        </p:spPr>
+        <p:txBody>
+          <a:bodyPr wrap="square" rtlCol="0" anchor="t">
+            <a:spAutoFit/>
+          </a:bodyPr>
+          <a:lstStyle/>
+          <a:p>
+            <a:pPr indent="0" marL="0">
+              <a:lnSpc>
+                <a:spcPct val="112000"/>
+              </a:lnSpc>
+              <a:buNone/>
+            </a:pPr>
+            <a:r>
+              <a:rPr lang="en-US" sz="1450" dirty="0">
+                <a:solidFill>
+                  <a:srgbClr val="1A1A1A"/>
+                </a:solidFill>
+                <a:latin typeface="Calibri" pitchFamily="34" charset="0"/>
+                <a:ea typeface="Calibri" pitchFamily="34" charset="-122"/>
+                <a:cs typeface="Calibri" pitchFamily="34" charset="-120"/>
+              </a:rPr>
+              <a:t>You load and chart real culture today; the ladder past counting starts next week.</a:t>
+            </a:r>
+            <a:endParaRPr lang="en-US" sz="1450" dirty="0"/>
+          </a:p>
+        </p:txBody>
+      </p:sp>
+    </p:spTree>
+  </p:cSld>
+  <p:clrMapOvr>
+    <a:masterClrMapping/>
+  </p:clrMapOvr>
+</p:sld>
+</file>
+
+<file path=ppt/slides/slide8.xml><?xml version="1.0" encoding="utf-8"?>
+<p:sld xmlns:a="http://schemas.openxmlformats.org/drawingml/2006/main" xmlns:r="http://schemas.openxmlformats.org/officeDocument/2006/relationships" xmlns:p="http://schemas.openxmlformats.org/presentationml/2006/main">
+  <p:cSld name="Slide 8">
     <p:bg>
       <p:bgPr>
         <a:solidFill>

</xml_diff>

<commit_message>
Restructure Weeks 1-2: W1 = counting rows/words/pixels, W2 = advanced counting + light stats
Week 1 now carries counting's first pass on all three shapes of culture: the
wedding rows, a first word count (with the stop-word choice made explicit),
and the pixel-counting image lab.

Week 2 becomes the deep counting week: the Bollen/Schmidt trial, hand
bag-of-words, tokenizers, tf-idf, then two new beats - keyness via log-odds
(with the reveal that She Giggles, He Gallops is exactly this method) and the
shuffle test, permutation-based light statistics with zero formulas (is the
gap real or chance; effect size caveat; seeds Week 8's robustness arc).
Cross-corpus counting folds into the keyness beat as the corpus-pair choice.

Updated across the stack: lesson-plans, syllabus, BUILD-PLAN, notebooks
(week01 + week02, both execute clean), site data, deck threads/sketch,
README tables; docs/, slides.json, week-NN.md, and pptx regenerated;
check_sync passes.
</commit_message>
<xml_diff>
--- a/slides/pptx/week-01.pptx
+++ b/slides/pptx/week-01.pptx
@@ -1652,7 +1652,7 @@
                 <a:ea typeface="Calibri" pitchFamily="34" charset="-122"/>
                 <a:cs typeface="Calibri" pitchFamily="34" charset="-120"/>
               </a:rPr>
-              <a:t>By the break you'll have loaded a real dataset, asked it a question, and produced your first chart. A complete investigation, end to end, on day one.</a:t>
+              <a:t>By the break you'll have loaded a real dataset, asked it a question, and produced your first chart. By the end you'll have counted culture in all three shapes it comes in: rows, words, and pixels.</a:t>
             </a:r>
             <a:endParaRPr lang="en-US" sz="1600" dirty="0"/>
           </a:p>
@@ -1691,7 +1691,7 @@
                 <a:ea typeface="Calibri" pitchFamily="34" charset="-122"/>
                 <a:cs typeface="Calibri" pitchFamily="34" charset="-120"/>
               </a:rPr>
-              <a:t>Tool / method:  Culture as data itself (the ladder starts next week)</a:t>
+              <a:t>Tool / method:  Counting, met on day one: rows, words, pixels</a:t>
             </a:r>
             <a:endParaRPr lang="en-US" sz="1200" dirty="0"/>
           </a:p>
@@ -2656,7 +2656,7 @@
                 <a:ea typeface="Calibri" pitchFamily="34" charset="-122"/>
                 <a:cs typeface="Calibri" pitchFamily="34" charset="-120"/>
               </a:rPr>
-              <a:t>Culture as data itself (the ladder starts next week)</a:t>
+              <a:t>Counting, met on day one: rows, words, pixels</a:t>
             </a:r>
             <a:endParaRPr lang="en-US" sz="1500" dirty="0"/>
           </a:p>
@@ -3589,7 +3589,7 @@
                 <a:ea typeface="Calibri" pitchFamily="34" charset="-122"/>
                 <a:cs typeface="Calibri" pitchFamily="34" charset="-120"/>
               </a:rPr>
-              <a:t>Lab 2 (worked), count an image corpus at the pixel level: ~200 Met thumbnails (or a stack of album covers). A picture is numbers, so the AI computes each image's average color and brightness and ranks the corpus darkest to brightest. What you choose to count of a picture is a choice too, and image projects start here.</a:t>
+              <a:t>Lab 2 (worked), count words, then pixels: first the top words of a small lyrics slice (stop-words drown the list until you remove them, your first counting choice), then an image corpus, ~200 Met thumbnails ranked darkest to brightest by average brightness. Text and pictures, counted with the same move; image projects start here.</a:t>
             </a:r>
             <a:endParaRPr lang="en-US" sz="1250" dirty="0"/>
           </a:p>

</xml_diff>

<commit_message>
Site: link slide decks; front page leads with real findings; plainer language
- Every week page gets a 'This week's materials' box: Open-in-Colab + GitHub
  buttons, .pptx download, and the outline; weeks without a notebook say so.
  Materials page (renamed from Notebooks) adds a deck table for all ten weeks.
- Front page gains 'Findings that started as counts': five real results with
  their real numbers (the 2,000-screenplay verb split and 85% male writers,
  the Google Books distortion surge, Underwood's Pynchon misfile, Gilardi's
  20x-cheaper labels, the $432,500 de Belamy sale), each linked to source.
- Language pass on generated content: dropped chat-coined phrasing
  ('unblocking drill', 'delight beat' labels, 'THE MATERIAL' kicker -> KEY
  POINTS, 'training wheels', 'met on day one') and trimmed filler sentences.
</commit_message>
<xml_diff>
--- a/slides/pptx/week-01.pptx
+++ b/slides/pptx/week-01.pptx
@@ -2136,7 +2136,7 @@
                 <a:ea typeface="Calibri" pitchFamily="34" charset="-122"/>
                 <a:cs typeface="Calibri" pitchFamily="34" charset="-120"/>
               </a:rPr>
-              <a:t>Tool / method:  Counting, met on day one: rows, words, pixels</a:t>
+              <a:t>Tool / method:  Counting: rows, words, pixels</a:t>
             </a:r>
             <a:endParaRPr lang="en-US" sz="1200" dirty="0"/>
           </a:p>
@@ -5189,7 +5189,7 @@
                 <a:ea typeface="Calibri" pitchFamily="34" charset="-122"/>
                 <a:cs typeface="Calibri" pitchFamily="34" charset="-120"/>
               </a:rPr>
-              <a:t>WEEK 1 · THE MATERIAL</a:t>
+              <a:t>WEEK 1 · KEY POINTS</a:t>
             </a:r>
             <a:endParaRPr lang="en-US" sz="1200" dirty="0"/>
           </a:p>
@@ -5577,7 +5577,7 @@
                 <a:ea typeface="Calibri" pitchFamily="34" charset="-122"/>
                 <a:cs typeface="Calibri" pitchFamily="34" charset="-120"/>
               </a:rPr>
-              <a:t>WEEK 1 · THE MATERIAL</a:t>
+              <a:t>WEEK 1 · KEY POINTS</a:t>
             </a:r>
             <a:endParaRPr lang="en-US" sz="1200" dirty="0"/>
           </a:p>
@@ -5965,7 +5965,7 @@
                 <a:ea typeface="Calibri" pitchFamily="34" charset="-122"/>
                 <a:cs typeface="Calibri" pitchFamily="34" charset="-120"/>
               </a:rPr>
-              <a:t>WEEK 1 · THE MATERIAL</a:t>
+              <a:t>WEEK 1 · KEY POINTS</a:t>
             </a:r>
             <a:endParaRPr lang="en-US" sz="1200" dirty="0"/>
           </a:p>
@@ -6353,7 +6353,7 @@
                 <a:ea typeface="Calibri" pitchFamily="34" charset="-122"/>
                 <a:cs typeface="Calibri" pitchFamily="34" charset="-120"/>
               </a:rPr>
-              <a:t>WEEK 1 · THE MATERIAL</a:t>
+              <a:t>WEEK 1 · KEY POINTS</a:t>
             </a:r>
             <a:endParaRPr lang="en-US" sz="1200" dirty="0"/>
           </a:p>
@@ -6741,7 +6741,7 @@
                 <a:ea typeface="Calibri" pitchFamily="34" charset="-122"/>
                 <a:cs typeface="Calibri" pitchFamily="34" charset="-120"/>
               </a:rPr>
-              <a:t>WEEK 1 · THE MATERIAL</a:t>
+              <a:t>WEEK 1 · KEY POINTS</a:t>
             </a:r>
             <a:endParaRPr lang="en-US" sz="1200" dirty="0"/>
           </a:p>
@@ -7273,7 +7273,7 @@
                 <a:ea typeface="Calibri" pitchFamily="34" charset="-122"/>
                 <a:cs typeface="Calibri" pitchFamily="34" charset="-120"/>
               </a:rPr>
-              <a:t>Counting, met on day one: rows, words, pixels</a:t>
+              <a:t>Counting: rows, words, pixels</a:t>
             </a:r>
             <a:endParaRPr lang="en-US" sz="1500" dirty="0"/>
           </a:p>

</xml_diff>

<commit_message>
Formality pass over all site pages and decks
~70 rewrites across the generated content: dropped playful phrasing ('for
fun', 'its mind on the table', 'hunt the surprise cluster', 'the honest
floor', 'kill it then keep it', 'nobody skips this', 'Snacks. Music.',
'ritual' -> routine, 'the back door' -> a last resort), regularized casual
constructions ('That order.' -> 'In that order.', 'Real-but-tiny is still
tiny' -> 'A difference can be real and still small'), and reworded headings
('Ship it' -> Publish, 'You taught it that' -> The training set is the
lesson, 'in particulars' -> in detail). Course-native ritual names (Look at
This then Question It, Sketch, Check) retained. Site, decks, and pptx
regenerated.
</commit_message>
<xml_diff>
--- a/slides/pptx/week-01.pptx
+++ b/slides/pptx/week-01.pptx
@@ -2097,7 +2097,7 @@
                 <a:ea typeface="Calibri" pitchFamily="34" charset="-122"/>
                 <a:cs typeface="Calibri" pitchFamily="34" charset="-120"/>
               </a:rPr>
-              <a:t>By the break you'll have loaded a real dataset, asked it a question, and produced your first chart. By the end you'll have counted culture in all three shapes it comes in: rows, words, and pixels.</a:t>
+              <a:t>By the mid-session break you will have loaded a real dataset, asked a question of it, and produced a chart. By the end you will have counted culture in three forms: rows, words, and pixels.</a:t>
             </a:r>
             <a:endParaRPr lang="en-US" sz="1600" dirty="0"/>
           </a:p>
@@ -2629,7 +2629,7 @@
                 <a:ea typeface="Calibri" pitchFamily="34" charset="-122"/>
                 <a:cs typeface="Calibri" pitchFamily="34" charset="-120"/>
               </a:rPr>
-              <a:t>Setting the room: the social rules, demonstrated by the instructor breaking one and being corrected. Today's live coding includes real mistakes on purpose.</a:t>
+              <a:t>Introductions and working agreements, demonstrated in practice. Today's live coding deliberately includes real mistakes.</a:t>
             </a:r>
             <a:endParaRPr lang="en-US" sz="1250" dirty="0"/>
           </a:p>
@@ -3139,7 +3139,7 @@
                 <a:ea typeface="Calibri" pitchFamily="34" charset="-122"/>
                 <a:cs typeface="Calibri" pitchFamily="34" charset="-120"/>
               </a:rPr>
-              <a:t>Lab 2 (worked), count words, then pixels: first the top words of a small lyrics slice (stop-words drown the list until you remove them, your first counting choice), then an image corpus, ~200 Met thumbnails ranked darkest to brightest by average brightness. Text and pictures, counted with the same move; image projects start here.</a:t>
+              <a:t>Lab 2 (worked): count words, then pixels. First the top words of a small lyrics sample (stop-words dominate the list until you remove them, the first counting decision), then an image corpus: ~200 Met thumbnails ranked darkest to brightest by average brightness. Text and images, counted with the same technique; image projects begin here.</a:t>
             </a:r>
             <a:endParaRPr lang="en-US" sz="1250" dirty="0"/>
           </a:p>
@@ -3241,7 +3241,7 @@
                 <a:ea typeface="Calibri" pitchFamily="34" charset="-122"/>
                 <a:cs typeface="Calibri" pitchFamily="34" charset="-120"/>
               </a:rPr>
-              <a:t>Teaser of the ladder ahead; the standing rituals named. First check-out.</a:t>
+              <a:t>Preview of the methods ahead; the weekly routines introduced. First check-out.</a:t>
             </a:r>
             <a:endParaRPr lang="en-US" sz="1250" dirty="0"/>
           </a:p>
@@ -3966,7 +3966,7 @@
                 <a:ea typeface="Calibri" pitchFamily="34" charset="-122"/>
                 <a:cs typeface="Calibri" pitchFamily="34" charset="-120"/>
               </a:rPr>
-              <a:t>She Giggles, He Gallops is great and its choices are arguable. We admire and interrogate at once, the habit the whole course turns on.</a:t>
+              <a:t>She Giggles, He Gallops is excellent and its choices are debatable. Admiring and questioning at once is the habit the course is built on.</a:t>
             </a:r>
             <a:endParaRPr lang="en-US" sz="1450" dirty="0"/>
           </a:p>
@@ -4254,7 +4254,7 @@
                 <a:ea typeface="Calibri" pitchFamily="34" charset="-122"/>
                 <a:cs typeface="Calibri" pitchFamily="34" charset="-120"/>
               </a:rPr>
-              <a:t>A picture is numbers: you counted pixels on day one, and images ride along as a co-equal corpus all ten weeks.</a:t>
+              <a:t>A picture is numbers: you counted pixels on day one, and images continue as a co-equal corpus through all ten weeks.</a:t>
             </a:r>
             <a:endParaRPr lang="en-US" sz="1450" dirty="0"/>
           </a:p>
@@ -4922,7 +4922,7 @@
                 <a:ea typeface="Calibri" pitchFamily="34" charset="-122"/>
                 <a:cs typeface="Calibri" pitchFamily="34" charset="-120"/>
               </a:rPr>
-              <a:t>The Pudding, "She Giggles, He Gallops" (2017): across ~2,000 film screenplays, the stage-direction verbs split by gender, women snuggle and giggle, men gallop and stride, and the interactive makes it impossible to unsee.</a:t>
+              <a:t>The Pudding, "She Giggles, He Gallops" (2017): across ~2,000 film screenplays, the stage-direction verbs split by gender, women snuggle and giggle, men gallop and stride. The interactive presentation makes the pattern unmistakable.</a:t>
             </a:r>
             <a:endParaRPr lang="en-US" sz="1900" dirty="0"/>
           </a:p>
@@ -5098,7 +5098,7 @@
                 <a:ea typeface="Calibri" pitchFamily="34" charset="-122"/>
                 <a:cs typeface="Calibri" pitchFamily="34" charset="-120"/>
               </a:rPr>
-              <a:t>~2,000 screenplays skewed toward what got produced and digitized: is that "film," or a slice? Whose choice is a gendered verb, the writer's, the character's, the genre's? Counting shows the split, not the cause. And read the visualization's choices, not just the data.</a:t>
+              <a:t>The 2,000 screenplays skew toward what was produced and digitized: is that "film," or a sample of it? Whose choice is a gendered verb: the writer's, the character's, or the genre's? Counting shows the split, not the cause. The visualization's own choices deserve the same scrutiny as the data.</a:t>
             </a:r>
             <a:endParaRPr lang="en-US" sz="2000" dirty="0"/>
           </a:p>
@@ -6006,7 +6006,7 @@
                 <a:ea typeface="Cambria" pitchFamily="34" charset="-122"/>
                 <a:cs typeface="Cambria" pitchFamily="34" charset="-120"/>
               </a:rPr>
-              <a:t>The Drive ritual (every week, no exceptions)</a:t>
+              <a:t>The Drive routine (every week, without exception)</a:t>
             </a:r>
             <a:endParaRPr lang="en-US" sz="3000" dirty="0"/>
           </a:p>
@@ -6394,7 +6394,7 @@
                 <a:ea typeface="Cambria" pitchFamily="34" charset="-122"/>
                 <a:cs typeface="Cambria" pitchFamily="34" charset="-120"/>
               </a:rPr>
-              <a:t>When code errors (it will, today, on purpose)</a:t>
+              <a:t>When code fails (it will, today, deliberately)</a:t>
             </a:r>
             <a:endParaRPr lang="en-US" sz="3000" dirty="0"/>
           </a:p>
@@ -6458,7 +6458,7 @@
                 <a:ea typeface="Calibri" pitchFamily="34" charset="-122"/>
                 <a:cs typeface="Calibri" pitchFamily="34" charset="-120"/>
               </a:rPr>
-              <a:t>Read the LAST line of the traceback first. It names the problem.</a:t>
+              <a:t>Read the last line of the traceback first. It names the problem.</a:t>
             </a:r>
             <a:endParaRPr lang="en-US" sz="1650" dirty="0"/>
           </a:p>
@@ -6586,7 +6586,7 @@
                 <a:ea typeface="Calibri" pitchFamily="34" charset="-122"/>
                 <a:cs typeface="Calibri" pitchFamily="34" charset="-120"/>
               </a:rPr>
-              <a:t>Try twice. Then ask a human. That order.</a:t>
+              <a:t>Try twice, then ask a human. In that order.</a:t>
             </a:r>
             <a:endParaRPr lang="en-US" sz="1650" dirty="0"/>
           </a:p>
@@ -6650,7 +6650,7 @@
                 <a:ea typeface="Calibri" pitchFamily="34" charset="-122"/>
                 <a:cs typeface="Calibri" pitchFamily="34" charset="-120"/>
               </a:rPr>
-              <a:t>Keep the cheat sheet out. Nobody memorizes error messages; everybody reads them.</a:t>
+              <a:t>Keep the cheat sheet at hand. No one memorizes error messages; everyone reads them.</a:t>
             </a:r>
             <a:endParaRPr lang="en-US" sz="1650" dirty="0"/>
           </a:p>
@@ -7038,7 +7038,7 @@
                 <a:ea typeface="Calibri" pitchFamily="34" charset="-122"/>
                 <a:cs typeface="Calibri" pitchFamily="34" charset="-120"/>
               </a:rPr>
-              <a:t>Same move three times, and a decision hiding in each.</a:t>
+              <a:t>The same technique three times, each containing a decision.</a:t>
             </a:r>
             <a:endParaRPr lang="en-US" sz="1650" dirty="0"/>
           </a:p>

</xml_diff>

<commit_message>
Front page: drop the examples; Week 1 opens with a real stakes lecture
The findings list comes off the front page (the two real-data figures stay)
and its material moves where it teaches: an 18-minute Week 1 opening
lecture, 'the stakes - why read culture with machines.' Machines already
read culture at scale and that reading happens without you; counting
culture has produced real knowledge (the verb split, hip-hop 1991, the
Rowling unmasking, the homemaker analogy, the de Belamy sale) and real
mistakes, and both look identical until someone checks - the checking is
the course. Week 1 timings shift (labs compress: Lab 1 to 33 min, Lab 2 to
22, break at 1:20), the pacing note protects the lecture and keeps Lab 2's
word half as the flex, and the deck gains a stakes slide plus a
what-counting-has-found slide. Updated in lesson plans, syllabus, site, and
decks.
</commit_message>
<xml_diff>
--- a/slides/pptx/week-01.pptx
+++ b/slides/pptx/week-01.pptx
@@ -18,9 +18,10 @@
     <p:sldId id="266" r:id="rId12"/>
     <p:sldId id="267" r:id="rId13"/>
     <p:sldId id="268" r:id="rId14"/>
+    <p:sldId id="269" r:id="rId15"/>
   </p:sldIdLst>
   <p:notesMasterIdLst>
-    <p:notesMasterId r:id="rId15"/>
+    <p:notesMasterId r:id="rId16"/>
   </p:notesMasterIdLst>
   <p:sldSz cx="12191695" cy="6858000"/>
   <p:notesSz cx="6858000" cy="12191695"/>
@@ -908,6 +909,94 @@
 </p:notes>
 </file>
 
+<file path=ppt/notesSlides/notesSlide14.xml><?xml version="1.0" encoding="utf-8"?>
+<p:notes xmlns:a="http://schemas.openxmlformats.org/drawingml/2006/main" xmlns:r="http://schemas.openxmlformats.org/officeDocument/2006/relationships" xmlns:p="http://schemas.openxmlformats.org/presentationml/2006/main">
+  <p:cSld>
+    <p:spTree>
+      <p:nvGrpSpPr>
+        <p:cNvPr id="1" name=""/>
+        <p:cNvGrpSpPr/>
+        <p:nvPr/>
+      </p:nvGrpSpPr>
+      <p:grpSpPr>
+        <a:xfrm>
+          <a:off x="0" y="0"/>
+          <a:ext cx="0" cy="0"/>
+          <a:chOff x="0" y="0"/>
+          <a:chExt cx="0" cy="0"/>
+        </a:xfrm>
+      </p:grpSpPr>
+      <p:sp>
+        <p:nvSpPr>
+          <p:cNvPr id="2" name="Slide Image Placeholder 1"/>
+          <p:cNvSpPr>
+            <a:spLocks noGrp="1" noRot="1" noChangeAspect="1"/>
+          </p:cNvSpPr>
+          <p:nvPr>
+            <p:ph type="sldImg"/>
+          </p:nvPr>
+        </p:nvSpPr>
+        <p:spPr/>
+      </p:sp>
+      <p:sp>
+        <p:nvSpPr>
+          <p:cNvPr id="3" name="Notes Placeholder 2"/>
+          <p:cNvSpPr>
+            <a:spLocks noGrp="1"/>
+          </p:cNvSpPr>
+          <p:nvPr>
+            <p:ph type="body" idx="1"/>
+          </p:nvPr>
+        </p:nvSpPr>
+        <p:spPr/>
+        <p:txBody>
+          <a:bodyPr/>
+          <a:lstStyle/>
+          <a:p>
+            <a:r>
+              <a:rPr lang="en-US" dirty="0"/>
+              <a:t/>
+            </a:r>
+            <a:endParaRPr lang="en-US" dirty="0"/>
+          </a:p>
+        </p:txBody>
+      </p:sp>
+      <p:sp>
+        <p:nvSpPr>
+          <p:cNvPr id="4" name="Slide Number Placeholder 3"/>
+          <p:cNvSpPr>
+            <a:spLocks noGrp="1"/>
+          </p:cNvSpPr>
+          <p:nvPr>
+            <p:ph type="sldNum" sz="quarter" idx="10"/>
+          </p:nvPr>
+        </p:nvSpPr>
+        <p:spPr/>
+        <p:txBody>
+          <a:bodyPr/>
+          <a:lstStyle/>
+          <a:p>
+            <a:fld id="{F7021451-1387-4CA6-816F-3879F97B5CBC}" type="slidenum">
+              <a:rPr lang="en-US"/>
+              <a:t>14</a:t>
+            </a:fld>
+            <a:endParaRPr lang="en-US"/>
+          </a:p>
+        </p:txBody>
+      </p:sp>
+    </p:spTree>
+    <p:extLst>
+      <p:ext uri="{BB962C8B-B14F-4D97-AF65-F5344CB8AC3E}">
+        <p14:creationId xmlns:p14="http://schemas.microsoft.com/office/powerpoint/2010/main" val="1024086991"/>
+      </p:ext>
+    </p:extLst>
+  </p:cSld>
+  <p:clrMapOvr>
+    <a:masterClrMapping/>
+  </p:clrMapOvr>
+</p:notes>
+</file>
+
 <file path=ppt/notesSlides/notesSlide2.xml><?xml version="1.0" encoding="utf-8"?>
 <p:notes xmlns:a="http://schemas.openxmlformats.org/drawingml/2006/main" xmlns:r="http://schemas.openxmlformats.org/officeDocument/2006/relationships" xmlns:p="http://schemas.openxmlformats.org/presentationml/2006/main">
   <p:cSld>
@@ -2502,7 +2591,7 @@
         </p:nvSpPr>
         <p:spPr>
           <a:xfrm>
-            <a:off x="640080" y="640080"/>
+            <a:off x="640080" y="731520"/>
             <a:ext cx="10058400" cy="731520"/>
           </a:xfrm>
           <a:prstGeom prst="rect">
@@ -2527,7 +2616,7 @@
                 <a:ea typeface="Cambria" pitchFamily="34" charset="-122"/>
                 <a:cs typeface="Cambria" pitchFamily="34" charset="-120"/>
               </a:rPr>
-              <a:t>The session</a:t>
+              <a:t>Three modes today</a:t>
             </a:r>
             <a:endParaRPr lang="en-US" sz="3000" dirty="0"/>
           </a:p>
@@ -2535,36 +2624,14 @@
       </p:sp>
       <p:sp>
         <p:nvSpPr>
-          <p:cNvPr id="3" name="Shape 1"/>
-          <p:cNvSpPr/>
-          <p:nvPr/>
-        </p:nvSpPr>
-        <p:spPr>
-          <a:xfrm>
-            <a:off x="640080" y="1572768"/>
-            <a:ext cx="868680" cy="457200"/>
-          </a:xfrm>
-          <a:prstGeom prst="roundRect">
-            <a:avLst>
-              <a:gd name="adj" fmla="val 12000"/>
-            </a:avLst>
-          </a:prstGeom>
-          <a:solidFill>
-            <a:srgbClr val="7A3B2E"/>
-          </a:solidFill>
-          <a:ln/>
-        </p:spPr>
-      </p:sp>
-      <p:sp>
-        <p:nvSpPr>
-          <p:cNvPr id="4" name="Text 2"/>
-          <p:cNvSpPr/>
-          <p:nvPr/>
-        </p:nvSpPr>
-        <p:spPr>
-          <a:xfrm>
-            <a:off x="640080" y="1572768"/>
-            <a:ext cx="868680" cy="457200"/>
+          <p:cNvPr id="3" name="Text 1"/>
+          <p:cNvSpPr/>
+          <p:nvPr/>
+        </p:nvSpPr>
+        <p:spPr>
+          <a:xfrm>
+            <a:off x="640080" y="1417320"/>
+            <a:ext cx="10058400" cy="365760"/>
           </a:xfrm>
           <a:prstGeom prst="rect">
             <a:avLst/>
@@ -2576,52 +2643,136 @@
           <a:bodyPr wrap="square" rtlCol="0" anchor="ctr"/>
           <a:lstStyle/>
           <a:p>
-            <a:pPr algn="ctr" indent="0" marL="0">
-              <a:buNone/>
-            </a:pPr>
-            <a:r>
-              <a:rPr lang="en-US" sz="1100" b="1" dirty="0">
-                <a:solidFill>
-                  <a:srgbClr val="FFFFFF"/>
+            <a:pPr indent="0" marL="0">
+              <a:buNone/>
+            </a:pPr>
+            <a:r>
+              <a:rPr lang="en-US" sz="1400" i="1" dirty="0">
+                <a:solidFill>
+                  <a:srgbClr val="6B6B63"/>
                 </a:solidFill>
                 <a:latin typeface="Calibri" pitchFamily="34" charset="0"/>
                 <a:ea typeface="Calibri" pitchFamily="34" charset="-122"/>
                 <a:cs typeface="Calibri" pitchFamily="34" charset="-120"/>
               </a:rPr>
-              <a:t>0:00</a:t>
-            </a:r>
-            <a:endParaRPr lang="en-US" sz="1100" dirty="0"/>
-          </a:p>
-        </p:txBody>
-      </p:sp>
-      <p:sp>
-        <p:nvSpPr>
-          <p:cNvPr id="5" name="Text 3"/>
-          <p:cNvSpPr/>
-          <p:nvPr/>
-        </p:nvSpPr>
-        <p:spPr>
-          <a:xfrm>
-            <a:off x="1691640" y="1554480"/>
-            <a:ext cx="9646920" cy="566928"/>
-          </a:xfrm>
-          <a:prstGeom prst="rect">
-            <a:avLst/>
-          </a:prstGeom>
-          <a:noFill/>
-          <a:ln/>
-        </p:spPr>
-        <p:txBody>
-          <a:bodyPr wrap="square" rtlCol="0" anchor="ctr">
+              <a:t>about a third of the session each</a:t>
+            </a:r>
+            <a:endParaRPr lang="en-US" sz="1400" dirty="0"/>
+          </a:p>
+        </p:txBody>
+      </p:sp>
+      <p:sp>
+        <p:nvSpPr>
+          <p:cNvPr id="4" name="Shape 2"/>
+          <p:cNvSpPr/>
+          <p:nvPr/>
+        </p:nvSpPr>
+        <p:spPr>
+          <a:xfrm>
+            <a:off x="640080" y="2194560"/>
+            <a:ext cx="3383280" cy="3291840"/>
+          </a:xfrm>
+          <a:prstGeom prst="roundRect">
+            <a:avLst>
+              <a:gd name="adj" fmla="val 3333"/>
+            </a:avLst>
+          </a:prstGeom>
+          <a:solidFill>
+            <a:srgbClr val="F4EEE8"/>
+          </a:solidFill>
+          <a:ln/>
+        </p:spPr>
+      </p:sp>
+      <p:sp>
+        <p:nvSpPr>
+          <p:cNvPr id="5" name="Shape 3"/>
+          <p:cNvSpPr/>
+          <p:nvPr/>
+        </p:nvSpPr>
+        <p:spPr>
+          <a:xfrm>
+            <a:off x="1051560" y="2606040"/>
+            <a:ext cx="548640" cy="548640"/>
+          </a:xfrm>
+          <a:prstGeom prst="ellipse">
+            <a:avLst/>
+          </a:prstGeom>
+          <a:solidFill>
+            <a:srgbClr val="7A3B2E"/>
+          </a:solidFill>
+          <a:ln/>
+        </p:spPr>
+      </p:sp>
+      <p:sp>
+        <p:nvSpPr>
+          <p:cNvPr id="6" name="Text 4"/>
+          <p:cNvSpPr/>
+          <p:nvPr/>
+        </p:nvSpPr>
+        <p:spPr>
+          <a:xfrm>
+            <a:off x="1005840" y="3383280"/>
+            <a:ext cx="2651760" cy="548640"/>
+          </a:xfrm>
+          <a:prstGeom prst="rect">
+            <a:avLst/>
+          </a:prstGeom>
+          <a:noFill/>
+          <a:ln/>
+        </p:spPr>
+        <p:txBody>
+          <a:bodyPr wrap="square" rtlCol="0" anchor="ctr"/>
+          <a:lstStyle/>
+          <a:p>
+            <a:pPr indent="0" marL="0">
+              <a:buNone/>
+            </a:pPr>
+            <a:r>
+              <a:rPr lang="en-US" sz="2100" b="1" dirty="0">
+                <a:solidFill>
+                  <a:srgbClr val="1A1A1A"/>
+                </a:solidFill>
+                <a:latin typeface="Cambria" pitchFamily="34" charset="0"/>
+                <a:ea typeface="Cambria" pitchFamily="34" charset="-122"/>
+                <a:cs typeface="Cambria" pitchFamily="34" charset="-120"/>
+              </a:rPr>
+              <a:t>Lecture / demo</a:t>
+            </a:r>
+            <a:endParaRPr lang="en-US" sz="2100" dirty="0"/>
+          </a:p>
+        </p:txBody>
+      </p:sp>
+      <p:sp>
+        <p:nvSpPr>
+          <p:cNvPr id="7" name="Text 5"/>
+          <p:cNvSpPr/>
+          <p:nvPr/>
+        </p:nvSpPr>
+        <p:spPr>
+          <a:xfrm>
+            <a:off x="1005840" y="3977640"/>
+            <a:ext cx="2651760" cy="1371600"/>
+          </a:xfrm>
+          <a:prstGeom prst="rect">
+            <a:avLst/>
+          </a:prstGeom>
+          <a:noFill/>
+          <a:ln/>
+        </p:spPr>
+        <p:txBody>
+          <a:bodyPr wrap="square" rtlCol="0" anchor="t">
             <a:spAutoFit/>
           </a:bodyPr>
           <a:lstStyle/>
           <a:p>
             <a:pPr indent="0" marL="0">
-              <a:buNone/>
-            </a:pPr>
-            <a:r>
-              <a:rPr lang="en-US" sz="1250" dirty="0">
+              <a:lnSpc>
+                <a:spcPct val="115000"/>
+              </a:lnSpc>
+              <a:buNone/>
+            </a:pPr>
+            <a:r>
+              <a:rPr lang="en-US" sz="1500" dirty="0">
                 <a:solidFill>
                   <a:srgbClr val="1A1A1A"/>
                 </a:solidFill>
@@ -2629,44 +2780,64 @@
                 <a:ea typeface="Calibri" pitchFamily="34" charset="-122"/>
                 <a:cs typeface="Calibri" pitchFamily="34" charset="-120"/>
               </a:rPr>
-              <a:t>Introductions and working agreements, demonstrated in practice. Today's live coding deliberately includes real mistakes.</a:t>
-            </a:r>
-            <a:endParaRPr lang="en-US" sz="1250" dirty="0"/>
-          </a:p>
-        </p:txBody>
-      </p:sp>
-      <p:sp>
-        <p:nvSpPr>
-          <p:cNvPr id="6" name="Shape 4"/>
-          <p:cNvSpPr/>
-          <p:nvPr/>
-        </p:nvSpPr>
-        <p:spPr>
-          <a:xfrm>
-            <a:off x="640080" y="2139696"/>
-            <a:ext cx="868680" cy="457200"/>
+              <a:t>Counting: rows, words, pixels</a:t>
+            </a:r>
+            <a:endParaRPr lang="en-US" sz="1500" dirty="0"/>
+          </a:p>
+        </p:txBody>
+      </p:sp>
+      <p:sp>
+        <p:nvSpPr>
+          <p:cNvPr id="8" name="Shape 6"/>
+          <p:cNvSpPr/>
+          <p:nvPr/>
+        </p:nvSpPr>
+        <p:spPr>
+          <a:xfrm>
+            <a:off x="4526280" y="2194560"/>
+            <a:ext cx="3383280" cy="3291840"/>
           </a:xfrm>
           <a:prstGeom prst="roundRect">
             <a:avLst>
-              <a:gd name="adj" fmla="val 12000"/>
+              <a:gd name="adj" fmla="val 3333"/>
             </a:avLst>
           </a:prstGeom>
           <a:solidFill>
-            <a:srgbClr val="7A3B2E"/>
-          </a:solidFill>
-          <a:ln/>
-        </p:spPr>
-      </p:sp>
-      <p:sp>
-        <p:nvSpPr>
-          <p:cNvPr id="7" name="Text 5"/>
-          <p:cNvSpPr/>
-          <p:nvPr/>
-        </p:nvSpPr>
-        <p:spPr>
-          <a:xfrm>
-            <a:off x="640080" y="2139696"/>
-            <a:ext cx="868680" cy="457200"/>
+            <a:srgbClr val="F4EEE8"/>
+          </a:solidFill>
+          <a:ln/>
+        </p:spPr>
+      </p:sp>
+      <p:sp>
+        <p:nvSpPr>
+          <p:cNvPr id="9" name="Shape 7"/>
+          <p:cNvSpPr/>
+          <p:nvPr/>
+        </p:nvSpPr>
+        <p:spPr>
+          <a:xfrm>
+            <a:off x="4937760" y="2606040"/>
+            <a:ext cx="548640" cy="548640"/>
+          </a:xfrm>
+          <a:prstGeom prst="ellipse">
+            <a:avLst/>
+          </a:prstGeom>
+          <a:solidFill>
+            <a:srgbClr val="3F6F5F"/>
+          </a:solidFill>
+          <a:ln/>
+        </p:spPr>
+      </p:sp>
+      <p:sp>
+        <p:nvSpPr>
+          <p:cNvPr id="10" name="Text 8"/>
+          <p:cNvSpPr/>
+          <p:nvPr/>
+        </p:nvSpPr>
+        <p:spPr>
+          <a:xfrm>
+            <a:off x="4892040" y="3383280"/>
+            <a:ext cx="2651760" cy="548640"/>
           </a:xfrm>
           <a:prstGeom prst="rect">
             <a:avLst/>
@@ -2678,52 +2849,180 @@
           <a:bodyPr wrap="square" rtlCol="0" anchor="ctr"/>
           <a:lstStyle/>
           <a:p>
-            <a:pPr algn="ctr" indent="0" marL="0">
-              <a:buNone/>
-            </a:pPr>
-            <a:r>
-              <a:rPr lang="en-US" sz="1100" b="1" dirty="0">
-                <a:solidFill>
-                  <a:srgbClr val="FFFFFF"/>
+            <a:pPr indent="0" marL="0">
+              <a:buNone/>
+            </a:pPr>
+            <a:r>
+              <a:rPr lang="en-US" sz="2100" b="1" dirty="0">
+                <a:solidFill>
+                  <a:srgbClr val="1A1A1A"/>
+                </a:solidFill>
+                <a:latin typeface="Cambria" pitchFamily="34" charset="0"/>
+                <a:ea typeface="Cambria" pitchFamily="34" charset="-122"/>
+                <a:cs typeface="Cambria" pitchFamily="34" charset="-120"/>
+              </a:rPr>
+              <a:t>Workshop</a:t>
+            </a:r>
+            <a:endParaRPr lang="en-US" sz="2100" dirty="0"/>
+          </a:p>
+        </p:txBody>
+      </p:sp>
+      <p:sp>
+        <p:nvSpPr>
+          <p:cNvPr id="11" name="Text 9"/>
+          <p:cNvSpPr/>
+          <p:nvPr/>
+        </p:nvSpPr>
+        <p:spPr>
+          <a:xfrm>
+            <a:off x="4892040" y="3977640"/>
+            <a:ext cx="2651760" cy="1371600"/>
+          </a:xfrm>
+          <a:prstGeom prst="rect">
+            <a:avLst/>
+          </a:prstGeom>
+          <a:noFill/>
+          <a:ln/>
+        </p:spPr>
+        <p:txBody>
+          <a:bodyPr wrap="square" rtlCol="0" anchor="t">
+            <a:spAutoFit/>
+          </a:bodyPr>
+          <a:lstStyle/>
+          <a:p>
+            <a:pPr indent="0" marL="0">
+              <a:lnSpc>
+                <a:spcPct val="115000"/>
+              </a:lnSpc>
+              <a:buNone/>
+            </a:pPr>
+            <a:r>
+              <a:rPr lang="en-US" sz="1500" dirty="0">
+                <a:solidFill>
+                  <a:srgbClr val="1A1A1A"/>
                 </a:solidFill>
                 <a:latin typeface="Calibri" pitchFamily="34" charset="0"/>
                 <a:ea typeface="Calibri" pitchFamily="34" charset="-122"/>
                 <a:cs typeface="Calibri" pitchFamily="34" charset="-120"/>
               </a:rPr>
-              <a:t>0:12</a:t>
-            </a:r>
-            <a:endParaRPr lang="en-US" sz="1100" dirty="0"/>
-          </a:p>
-        </p:txBody>
-      </p:sp>
-      <p:sp>
-        <p:nvSpPr>
-          <p:cNvPr id="8" name="Text 6"/>
-          <p:cNvSpPr/>
-          <p:nvPr/>
-        </p:nvSpPr>
-        <p:spPr>
-          <a:xfrm>
-            <a:off x="1691640" y="2121408"/>
-            <a:ext cx="9646920" cy="566928"/>
-          </a:xfrm>
-          <a:prstGeom prst="rect">
-            <a:avLst/>
-          </a:prstGeom>
-          <a:noFill/>
-          <a:ln/>
-        </p:spPr>
-        <p:txBody>
-          <a:bodyPr wrap="square" rtlCol="0" anchor="ctr">
+              <a:t>Build hands-on on your own data.</a:t>
+            </a:r>
+            <a:endParaRPr lang="en-US" sz="1500" dirty="0"/>
+          </a:p>
+        </p:txBody>
+      </p:sp>
+      <p:sp>
+        <p:nvSpPr>
+          <p:cNvPr id="12" name="Shape 10"/>
+          <p:cNvSpPr/>
+          <p:nvPr/>
+        </p:nvSpPr>
+        <p:spPr>
+          <a:xfrm>
+            <a:off x="8412480" y="2194560"/>
+            <a:ext cx="3383280" cy="3291840"/>
+          </a:xfrm>
+          <a:prstGeom prst="roundRect">
+            <a:avLst>
+              <a:gd name="adj" fmla="val 3333"/>
+            </a:avLst>
+          </a:prstGeom>
+          <a:solidFill>
+            <a:srgbClr val="F4EEE8"/>
+          </a:solidFill>
+          <a:ln/>
+        </p:spPr>
+      </p:sp>
+      <p:sp>
+        <p:nvSpPr>
+          <p:cNvPr id="13" name="Shape 11"/>
+          <p:cNvSpPr/>
+          <p:nvPr/>
+        </p:nvSpPr>
+        <p:spPr>
+          <a:xfrm>
+            <a:off x="8823960" y="2606040"/>
+            <a:ext cx="548640" cy="548640"/>
+          </a:xfrm>
+          <a:prstGeom prst="ellipse">
+            <a:avLst/>
+          </a:prstGeom>
+          <a:solidFill>
+            <a:srgbClr val="B9852F"/>
+          </a:solidFill>
+          <a:ln/>
+        </p:spPr>
+      </p:sp>
+      <p:sp>
+        <p:nvSpPr>
+          <p:cNvPr id="14" name="Text 12"/>
+          <p:cNvSpPr/>
+          <p:nvPr/>
+        </p:nvSpPr>
+        <p:spPr>
+          <a:xfrm>
+            <a:off x="8778240" y="3383280"/>
+            <a:ext cx="2651760" cy="548640"/>
+          </a:xfrm>
+          <a:prstGeom prst="rect">
+            <a:avLst/>
+          </a:prstGeom>
+          <a:noFill/>
+          <a:ln/>
+        </p:spPr>
+        <p:txBody>
+          <a:bodyPr wrap="square" rtlCol="0" anchor="ctr"/>
+          <a:lstStyle/>
+          <a:p>
+            <a:pPr indent="0" marL="0">
+              <a:buNone/>
+            </a:pPr>
+            <a:r>
+              <a:rPr lang="en-US" sz="2100" b="1" dirty="0">
+                <a:solidFill>
+                  <a:srgbClr val="1A1A1A"/>
+                </a:solidFill>
+                <a:latin typeface="Cambria" pitchFamily="34" charset="0"/>
+                <a:ea typeface="Cambria" pitchFamily="34" charset="-122"/>
+                <a:cs typeface="Cambria" pitchFamily="34" charset="-120"/>
+              </a:rPr>
+              <a:t>Discussion</a:t>
+            </a:r>
+            <a:endParaRPr lang="en-US" sz="2100" dirty="0"/>
+          </a:p>
+        </p:txBody>
+      </p:sp>
+      <p:sp>
+        <p:nvSpPr>
+          <p:cNvPr id="15" name="Text 13"/>
+          <p:cNvSpPr/>
+          <p:nvPr/>
+        </p:nvSpPr>
+        <p:spPr>
+          <a:xfrm>
+            <a:off x="8778240" y="3977640"/>
+            <a:ext cx="2651760" cy="1371600"/>
+          </a:xfrm>
+          <a:prstGeom prst="rect">
+            <a:avLst/>
+          </a:prstGeom>
+          <a:noFill/>
+          <a:ln/>
+        </p:spPr>
+        <p:txBody>
+          <a:bodyPr wrap="square" rtlCol="0" anchor="t">
             <a:spAutoFit/>
           </a:bodyPr>
           <a:lstStyle/>
           <a:p>
             <a:pPr indent="0" marL="0">
-              <a:buNone/>
-            </a:pPr>
-            <a:r>
-              <a:rPr lang="en-US" sz="1250" dirty="0">
+              <a:lnSpc>
+                <a:spcPct val="115000"/>
+              </a:lnSpc>
+              <a:buNone/>
+            </a:pPr>
+            <a:r>
+              <a:rPr lang="en-US" sz="1500" dirty="0">
                 <a:solidFill>
                   <a:srgbClr val="1A1A1A"/>
                 </a:solidFill>
@@ -2731,519 +3030,9 @@
                 <a:ea typeface="Calibri" pitchFamily="34" charset="-122"/>
                 <a:cs typeface="Calibri" pitchFamily="34" charset="-120"/>
               </a:rPr>
-              <a:t>Look at This, then Question It: She Giggles, He Gallops.</a:t>
-            </a:r>
-            <a:endParaRPr lang="en-US" sz="1250" dirty="0"/>
-          </a:p>
-        </p:txBody>
-      </p:sp>
-      <p:sp>
-        <p:nvSpPr>
-          <p:cNvPr id="9" name="Shape 7"/>
-          <p:cNvSpPr/>
-          <p:nvPr/>
-        </p:nvSpPr>
-        <p:spPr>
-          <a:xfrm>
-            <a:off x="640080" y="2706624"/>
-            <a:ext cx="868680" cy="457200"/>
-          </a:xfrm>
-          <a:prstGeom prst="roundRect">
-            <a:avLst>
-              <a:gd name="adj" fmla="val 12000"/>
-            </a:avLst>
-          </a:prstGeom>
-          <a:solidFill>
-            <a:srgbClr val="7A3B2E"/>
-          </a:solidFill>
-          <a:ln/>
-        </p:spPr>
-      </p:sp>
-      <p:sp>
-        <p:nvSpPr>
-          <p:cNvPr id="10" name="Text 8"/>
-          <p:cNvSpPr/>
-          <p:nvPr/>
-        </p:nvSpPr>
-        <p:spPr>
-          <a:xfrm>
-            <a:off x="640080" y="2706624"/>
-            <a:ext cx="868680" cy="457200"/>
-          </a:xfrm>
-          <a:prstGeom prst="rect">
-            <a:avLst/>
-          </a:prstGeom>
-          <a:noFill/>
-          <a:ln/>
-        </p:spPr>
-        <p:txBody>
-          <a:bodyPr wrap="square" rtlCol="0" anchor="ctr"/>
-          <a:lstStyle/>
-          <a:p>
-            <a:pPr algn="ctr" indent="0" marL="0">
-              <a:buNone/>
-            </a:pPr>
-            <a:r>
-              <a:rPr lang="en-US" sz="1100" b="1" dirty="0">
-                <a:solidFill>
-                  <a:srgbClr val="FFFFFF"/>
-                </a:solidFill>
-                <a:latin typeface="Calibri" pitchFamily="34" charset="0"/>
-                <a:ea typeface="Calibri" pitchFamily="34" charset="-122"/>
-                <a:cs typeface="Calibri" pitchFamily="34" charset="-120"/>
-              </a:rPr>
-              <a:t>0:17</a:t>
-            </a:r>
-            <a:endParaRPr lang="en-US" sz="1100" dirty="0"/>
-          </a:p>
-        </p:txBody>
-      </p:sp>
-      <p:sp>
-        <p:nvSpPr>
-          <p:cNvPr id="11" name="Text 9"/>
-          <p:cNvSpPr/>
-          <p:nvPr/>
-        </p:nvSpPr>
-        <p:spPr>
-          <a:xfrm>
-            <a:off x="1691640" y="2688336"/>
-            <a:ext cx="9646920" cy="566928"/>
-          </a:xfrm>
-          <a:prstGeom prst="rect">
-            <a:avLst/>
-          </a:prstGeom>
-          <a:noFill/>
-          <a:ln/>
-        </p:spPr>
-        <p:txBody>
-          <a:bodyPr wrap="square" rtlCol="0" anchor="ctr">
-            <a:spAutoFit/>
-          </a:bodyPr>
-          <a:lstStyle/>
-          <a:p>
-            <a:pPr indent="0" marL="0">
-              <a:buNone/>
-            </a:pPr>
-            <a:r>
-              <a:rPr lang="en-US" sz="1250" dirty="0">
-                <a:solidFill>
-                  <a:srgbClr val="1A1A1A"/>
-                </a:solidFill>
-                <a:latin typeface="Calibri" pitchFamily="34" charset="0"/>
-                <a:ea typeface="Calibri" pitchFamily="34" charset="-122"/>
-                <a:cs typeface="Calibri" pitchFamily="34" charset="-120"/>
-              </a:rPr>
-              <a:t>Pre-train the vocabulary (no code): corpus, method, model, embedding, in plain language with pictures. The course map and the deliverable.</a:t>
-            </a:r>
-            <a:endParaRPr lang="en-US" sz="1250" dirty="0"/>
-          </a:p>
-        </p:txBody>
-      </p:sp>
-      <p:sp>
-        <p:nvSpPr>
-          <p:cNvPr id="12" name="Shape 10"/>
-          <p:cNvSpPr/>
-          <p:nvPr/>
-        </p:nvSpPr>
-        <p:spPr>
-          <a:xfrm>
-            <a:off x="640080" y="3273552"/>
-            <a:ext cx="868680" cy="457200"/>
-          </a:xfrm>
-          <a:prstGeom prst="roundRect">
-            <a:avLst>
-              <a:gd name="adj" fmla="val 12000"/>
-            </a:avLst>
-          </a:prstGeom>
-          <a:solidFill>
-            <a:srgbClr val="7A3B2E"/>
-          </a:solidFill>
-          <a:ln/>
-        </p:spPr>
-      </p:sp>
-      <p:sp>
-        <p:nvSpPr>
-          <p:cNvPr id="13" name="Text 11"/>
-          <p:cNvSpPr/>
-          <p:nvPr/>
-        </p:nvSpPr>
-        <p:spPr>
-          <a:xfrm>
-            <a:off x="640080" y="3273552"/>
-            <a:ext cx="868680" cy="457200"/>
-          </a:xfrm>
-          <a:prstGeom prst="rect">
-            <a:avLst/>
-          </a:prstGeom>
-          <a:noFill/>
-          <a:ln/>
-        </p:spPr>
-        <p:txBody>
-          <a:bodyPr wrap="square" rtlCol="0" anchor="ctr"/>
-          <a:lstStyle/>
-          <a:p>
-            <a:pPr algn="ctr" indent="0" marL="0">
-              <a:buNone/>
-            </a:pPr>
-            <a:r>
-              <a:rPr lang="en-US" sz="1100" b="1" dirty="0">
-                <a:solidFill>
-                  <a:srgbClr val="FFFFFF"/>
-                </a:solidFill>
-                <a:latin typeface="Calibri" pitchFamily="34" charset="0"/>
-                <a:ea typeface="Calibri" pitchFamily="34" charset="-122"/>
-                <a:cs typeface="Calibri" pitchFamily="34" charset="-120"/>
-              </a:rPr>
-              <a:t>0:32</a:t>
-            </a:r>
-            <a:endParaRPr lang="en-US" sz="1100" dirty="0"/>
-          </a:p>
-        </p:txBody>
-      </p:sp>
-      <p:sp>
-        <p:nvSpPr>
-          <p:cNvPr id="14" name="Text 12"/>
-          <p:cNvSpPr/>
-          <p:nvPr/>
-        </p:nvSpPr>
-        <p:spPr>
-          <a:xfrm>
-            <a:off x="1691640" y="3255264"/>
-            <a:ext cx="9646920" cy="566928"/>
-          </a:xfrm>
-          <a:prstGeom prst="rect">
-            <a:avLst/>
-          </a:prstGeom>
-          <a:noFill/>
-          <a:ln/>
-        </p:spPr>
-        <p:txBody>
-          <a:bodyPr wrap="square" rtlCol="0" anchor="ctr">
-            <a:spAutoFit/>
-          </a:bodyPr>
-          <a:lstStyle/>
-          <a:p>
-            <a:pPr indent="0" marL="0">
-              <a:buNone/>
-            </a:pPr>
-            <a:r>
-              <a:rPr lang="en-US" sz="1250" dirty="0">
-                <a:solidFill>
-                  <a:srgbClr val="1A1A1A"/>
-                </a:solidFill>
-                <a:latin typeface="Calibri" pitchFamily="34" charset="0"/>
-                <a:ea typeface="Calibri" pitchFamily="34" charset="-122"/>
-                <a:cs typeface="Calibri" pitchFamily="34" charset="-120"/>
-              </a:rPr>
-              <a:t>Lab 1 (worked, participatory): copy the notebook to Drive and mount Drive into the runtime (this is how your corpus and results survive Colab wiping the session, everything saving to one project folder), put a Gemini key in Colab Secrets, load NYT wedding data, make a first chart. Hand out the common-errors cheat sheet. Then solo with a partner: draft three questions, pick one, have the AI write the code, run it, chart it. Write one sentence predicting your cell before you run it.</a:t>
-            </a:r>
-            <a:endParaRPr lang="en-US" sz="1250" dirty="0"/>
-          </a:p>
-        </p:txBody>
-      </p:sp>
-      <p:sp>
-        <p:nvSpPr>
-          <p:cNvPr id="15" name="Shape 13"/>
-          <p:cNvSpPr/>
-          <p:nvPr/>
-        </p:nvSpPr>
-        <p:spPr>
-          <a:xfrm>
-            <a:off x="640080" y="3840480"/>
-            <a:ext cx="868680" cy="457200"/>
-          </a:xfrm>
-          <a:prstGeom prst="roundRect">
-            <a:avLst>
-              <a:gd name="adj" fmla="val 12000"/>
-            </a:avLst>
-          </a:prstGeom>
-          <a:solidFill>
-            <a:srgbClr val="7A3B2E"/>
-          </a:solidFill>
-          <a:ln/>
-        </p:spPr>
-      </p:sp>
-      <p:sp>
-        <p:nvSpPr>
-          <p:cNvPr id="16" name="Text 14"/>
-          <p:cNvSpPr/>
-          <p:nvPr/>
-        </p:nvSpPr>
-        <p:spPr>
-          <a:xfrm>
-            <a:off x="640080" y="3840480"/>
-            <a:ext cx="868680" cy="457200"/>
-          </a:xfrm>
-          <a:prstGeom prst="rect">
-            <a:avLst/>
-          </a:prstGeom>
-          <a:noFill/>
-          <a:ln/>
-        </p:spPr>
-        <p:txBody>
-          <a:bodyPr wrap="square" rtlCol="0" anchor="ctr"/>
-          <a:lstStyle/>
-          <a:p>
-            <a:pPr algn="ctr" indent="0" marL="0">
-              <a:buNone/>
-            </a:pPr>
-            <a:r>
-              <a:rPr lang="en-US" sz="1100" b="1" dirty="0">
-                <a:solidFill>
-                  <a:srgbClr val="FFFFFF"/>
-                </a:solidFill>
-                <a:latin typeface="Calibri" pitchFamily="34" charset="0"/>
-                <a:ea typeface="Calibri" pitchFamily="34" charset="-122"/>
-                <a:cs typeface="Calibri" pitchFamily="34" charset="-120"/>
-              </a:rPr>
-              <a:t>1:10</a:t>
-            </a:r>
-            <a:endParaRPr lang="en-US" sz="1100" dirty="0"/>
-          </a:p>
-        </p:txBody>
-      </p:sp>
-      <p:sp>
-        <p:nvSpPr>
-          <p:cNvPr id="17" name="Text 15"/>
-          <p:cNvSpPr/>
-          <p:nvPr/>
-        </p:nvSpPr>
-        <p:spPr>
-          <a:xfrm>
-            <a:off x="1691640" y="3822192"/>
-            <a:ext cx="9646920" cy="566928"/>
-          </a:xfrm>
-          <a:prstGeom prst="rect">
-            <a:avLst/>
-          </a:prstGeom>
-          <a:noFill/>
-          <a:ln/>
-        </p:spPr>
-        <p:txBody>
-          <a:bodyPr wrap="square" rtlCol="0" anchor="ctr">
-            <a:spAutoFit/>
-          </a:bodyPr>
-          <a:lstStyle/>
-          <a:p>
-            <a:pPr indent="0" marL="0">
-              <a:buNone/>
-            </a:pPr>
-            <a:r>
-              <a:rPr lang="en-US" sz="1250" dirty="0">
-                <a:solidFill>
-                  <a:srgbClr val="1A1A1A"/>
-                </a:solidFill>
-                <a:latin typeface="Calibri" pitchFamily="34" charset="0"/>
-                <a:ea typeface="Calibri" pitchFamily="34" charset="-122"/>
-                <a:cs typeface="Calibri" pitchFamily="34" charset="-120"/>
-              </a:rPr>
-              <a:t>Break</a:t>
-            </a:r>
-            <a:endParaRPr lang="en-US" sz="1250" dirty="0"/>
-          </a:p>
-        </p:txBody>
-      </p:sp>
-      <p:sp>
-        <p:nvSpPr>
-          <p:cNvPr id="18" name="Shape 16"/>
-          <p:cNvSpPr/>
-          <p:nvPr/>
-        </p:nvSpPr>
-        <p:spPr>
-          <a:xfrm>
-            <a:off x="640080" y="4407408"/>
-            <a:ext cx="868680" cy="457200"/>
-          </a:xfrm>
-          <a:prstGeom prst="roundRect">
-            <a:avLst>
-              <a:gd name="adj" fmla="val 12000"/>
-            </a:avLst>
-          </a:prstGeom>
-          <a:solidFill>
-            <a:srgbClr val="7A3B2E"/>
-          </a:solidFill>
-          <a:ln/>
-        </p:spPr>
-      </p:sp>
-      <p:sp>
-        <p:nvSpPr>
-          <p:cNvPr id="19" name="Text 17"/>
-          <p:cNvSpPr/>
-          <p:nvPr/>
-        </p:nvSpPr>
-        <p:spPr>
-          <a:xfrm>
-            <a:off x="640080" y="4407408"/>
-            <a:ext cx="868680" cy="457200"/>
-          </a:xfrm>
-          <a:prstGeom prst="rect">
-            <a:avLst/>
-          </a:prstGeom>
-          <a:noFill/>
-          <a:ln/>
-        </p:spPr>
-        <p:txBody>
-          <a:bodyPr wrap="square" rtlCol="0" anchor="ctr"/>
-          <a:lstStyle/>
-          <a:p>
-            <a:pPr algn="ctr" indent="0" marL="0">
-              <a:buNone/>
-            </a:pPr>
-            <a:r>
-              <a:rPr lang="en-US" sz="1100" b="1" dirty="0">
-                <a:solidFill>
-                  <a:srgbClr val="FFFFFF"/>
-                </a:solidFill>
-                <a:latin typeface="Calibri" pitchFamily="34" charset="0"/>
-                <a:ea typeface="Calibri" pitchFamily="34" charset="-122"/>
-                <a:cs typeface="Calibri" pitchFamily="34" charset="-120"/>
-              </a:rPr>
-              <a:t>1:20</a:t>
-            </a:r>
-            <a:endParaRPr lang="en-US" sz="1100" dirty="0"/>
-          </a:p>
-        </p:txBody>
-      </p:sp>
-      <p:sp>
-        <p:nvSpPr>
-          <p:cNvPr id="20" name="Text 18"/>
-          <p:cNvSpPr/>
-          <p:nvPr/>
-        </p:nvSpPr>
-        <p:spPr>
-          <a:xfrm>
-            <a:off x="1691640" y="4389120"/>
-            <a:ext cx="9646920" cy="566928"/>
-          </a:xfrm>
-          <a:prstGeom prst="rect">
-            <a:avLst/>
-          </a:prstGeom>
-          <a:noFill/>
-          <a:ln/>
-        </p:spPr>
-        <p:txBody>
-          <a:bodyPr wrap="square" rtlCol="0" anchor="ctr">
-            <a:spAutoFit/>
-          </a:bodyPr>
-          <a:lstStyle/>
-          <a:p>
-            <a:pPr indent="0" marL="0">
-              <a:buNone/>
-            </a:pPr>
-            <a:r>
-              <a:rPr lang="en-US" sz="1250" dirty="0">
-                <a:solidFill>
-                  <a:srgbClr val="1A1A1A"/>
-                </a:solidFill>
-                <a:latin typeface="Calibri" pitchFamily="34" charset="0"/>
-                <a:ea typeface="Calibri" pitchFamily="34" charset="-122"/>
-                <a:cs typeface="Calibri" pitchFamily="34" charset="-120"/>
-              </a:rPr>
-              <a:t>Lab 2 (worked): count words, then pixels. First the top words of a small lyrics sample (stop-words dominate the list until you remove them, the first counting decision), then an image corpus: ~200 Met thumbnails ranked darkest to brightest by average brightness. Text and images, counted with the same technique; image projects begin here.</a:t>
-            </a:r>
-            <a:endParaRPr lang="en-US" sz="1250" dirty="0"/>
-          </a:p>
-        </p:txBody>
-      </p:sp>
-      <p:sp>
-        <p:nvSpPr>
-          <p:cNvPr id="21" name="Shape 19"/>
-          <p:cNvSpPr/>
-          <p:nvPr/>
-        </p:nvSpPr>
-        <p:spPr>
-          <a:xfrm>
-            <a:off x="640080" y="4974336"/>
-            <a:ext cx="868680" cy="457200"/>
-          </a:xfrm>
-          <a:prstGeom prst="roundRect">
-            <a:avLst>
-              <a:gd name="adj" fmla="val 12000"/>
-            </a:avLst>
-          </a:prstGeom>
-          <a:solidFill>
-            <a:srgbClr val="7A3B2E"/>
-          </a:solidFill>
-          <a:ln/>
-        </p:spPr>
-      </p:sp>
-      <p:sp>
-        <p:nvSpPr>
-          <p:cNvPr id="22" name="Text 20"/>
-          <p:cNvSpPr/>
-          <p:nvPr/>
-        </p:nvSpPr>
-        <p:spPr>
-          <a:xfrm>
-            <a:off x="640080" y="4974336"/>
-            <a:ext cx="868680" cy="457200"/>
-          </a:xfrm>
-          <a:prstGeom prst="rect">
-            <a:avLst/>
-          </a:prstGeom>
-          <a:noFill/>
-          <a:ln/>
-        </p:spPr>
-        <p:txBody>
-          <a:bodyPr wrap="square" rtlCol="0" anchor="ctr"/>
-          <a:lstStyle/>
-          <a:p>
-            <a:pPr algn="ctr" indent="0" marL="0">
-              <a:buNone/>
-            </a:pPr>
-            <a:r>
-              <a:rPr lang="en-US" sz="1100" b="1" dirty="0">
-                <a:solidFill>
-                  <a:srgbClr val="FFFFFF"/>
-                </a:solidFill>
-                <a:latin typeface="Calibri" pitchFamily="34" charset="0"/>
-                <a:ea typeface="Calibri" pitchFamily="34" charset="-122"/>
-                <a:cs typeface="Calibri" pitchFamily="34" charset="-120"/>
-              </a:rPr>
-              <a:t>1:50</a:t>
-            </a:r>
-            <a:endParaRPr lang="en-US" sz="1100" dirty="0"/>
-          </a:p>
-        </p:txBody>
-      </p:sp>
-      <p:sp>
-        <p:nvSpPr>
-          <p:cNvPr id="23" name="Text 21"/>
-          <p:cNvSpPr/>
-          <p:nvPr/>
-        </p:nvSpPr>
-        <p:spPr>
-          <a:xfrm>
-            <a:off x="1691640" y="4956048"/>
-            <a:ext cx="9646920" cy="566928"/>
-          </a:xfrm>
-          <a:prstGeom prst="rect">
-            <a:avLst/>
-          </a:prstGeom>
-          <a:noFill/>
-          <a:ln/>
-        </p:spPr>
-        <p:txBody>
-          <a:bodyPr wrap="square" rtlCol="0" anchor="ctr">
-            <a:spAutoFit/>
-          </a:bodyPr>
-          <a:lstStyle/>
-          <a:p>
-            <a:pPr indent="0" marL="0">
-              <a:buNone/>
-            </a:pPr>
-            <a:r>
-              <a:rPr lang="en-US" sz="1250" dirty="0">
-                <a:solidFill>
-                  <a:srgbClr val="1A1A1A"/>
-                </a:solidFill>
-                <a:latin typeface="Calibri" pitchFamily="34" charset="0"/>
-                <a:ea typeface="Calibri" pitchFamily="34" charset="-122"/>
-                <a:cs typeface="Calibri" pitchFamily="34" charset="-120"/>
-              </a:rPr>
-              <a:t>Preview of the methods ahead; the weekly routines introduced. First check-out.</a:t>
-            </a:r>
-            <a:endParaRPr lang="en-US" sz="1250" dirty="0"/>
+              <a:t>Interrogate the study, debate it, or critique each other's work.</a:t>
+            </a:r>
+            <a:endParaRPr lang="en-US" sz="1500" dirty="0"/>
           </a:p>
         </p:txBody>
       </p:sp>
@@ -3312,7 +3101,7 @@
                 <a:ea typeface="Cambria" pitchFamily="34" charset="-122"/>
                 <a:cs typeface="Cambria" pitchFamily="34" charset="-120"/>
               </a:rPr>
-              <a:t>Reading &amp; homework</a:t>
+              <a:t>The session</a:t>
             </a:r>
             <a:endParaRPr lang="en-US" sz="3000" dirty="0"/>
           </a:p>
@@ -3326,11 +3115,13 @@
         </p:nvSpPr>
         <p:spPr>
           <a:xfrm>
-            <a:off x="640080" y="1673352"/>
-            <a:ext cx="219456" cy="219456"/>
-          </a:xfrm>
-          <a:prstGeom prst="ellipse">
-            <a:avLst/>
+            <a:off x="640080" y="1572768"/>
+            <a:ext cx="868680" cy="450342"/>
+          </a:xfrm>
+          <a:prstGeom prst="roundRect">
+            <a:avLst>
+              <a:gd name="adj" fmla="val 12183"/>
+            </a:avLst>
           </a:prstGeom>
           <a:solidFill>
             <a:srgbClr val="7A3B2E"/>
@@ -3346,8 +3137,8 @@
         </p:nvSpPr>
         <p:spPr>
           <a:xfrm>
-            <a:off x="1051560" y="1600200"/>
-            <a:ext cx="10424160" cy="365760"/>
+            <a:off x="640080" y="1572768"/>
+            <a:ext cx="868680" cy="450342"/>
           </a:xfrm>
           <a:prstGeom prst="rect">
             <a:avLst/>
@@ -3359,21 +3150,21 @@
           <a:bodyPr wrap="square" rtlCol="0" anchor="ctr"/>
           <a:lstStyle/>
           <a:p>
-            <a:pPr indent="0" marL="0">
-              <a:buNone/>
-            </a:pPr>
-            <a:r>
-              <a:rPr lang="en-US" sz="1500" b="1" dirty="0">
-                <a:solidFill>
-                  <a:srgbClr val="7A3B2E"/>
+            <a:pPr algn="ctr" indent="0" marL="0">
+              <a:buNone/>
+            </a:pPr>
+            <a:r>
+              <a:rPr lang="en-US" sz="1100" b="1" dirty="0">
+                <a:solidFill>
+                  <a:srgbClr val="FFFFFF"/>
                 </a:solidFill>
                 <a:latin typeface="Calibri" pitchFamily="34" charset="0"/>
                 <a:ea typeface="Calibri" pitchFamily="34" charset="-122"/>
                 <a:cs typeface="Calibri" pitchFamily="34" charset="-120"/>
               </a:rPr>
-              <a:t>Reading</a:t>
-            </a:r>
-            <a:endParaRPr lang="en-US" sz="1500" dirty="0"/>
+              <a:t>0:00</a:t>
+            </a:r>
+            <a:endParaRPr lang="en-US" sz="1100" dirty="0"/>
           </a:p>
         </p:txBody>
       </p:sp>
@@ -3385,17 +3176,17 @@
         </p:nvSpPr>
         <p:spPr>
           <a:xfrm>
-            <a:off x="1051560" y="1984248"/>
-            <a:ext cx="10424160" cy="731520"/>
-          </a:xfrm>
-          <a:prstGeom prst="rect">
-            <a:avLst/>
-          </a:prstGeom>
-          <a:noFill/>
-          <a:ln/>
-        </p:spPr>
-        <p:txBody>
-          <a:bodyPr wrap="square" rtlCol="0" anchor="t">
+            <a:off x="1691640" y="1554480"/>
+            <a:ext cx="9646920" cy="560070"/>
+          </a:xfrm>
+          <a:prstGeom prst="rect">
+            <a:avLst/>
+          </a:prstGeom>
+          <a:noFill/>
+          <a:ln/>
+        </p:spPr>
+        <p:txBody>
+          <a:bodyPr wrap="square" rtlCol="0" anchor="ctr">
             <a:spAutoFit/>
           </a:bodyPr>
           <a:lstStyle/>
@@ -3404,7 +3195,7 @@
               <a:buNone/>
             </a:pPr>
             <a:r>
-              <a:rPr lang="en-US" sz="1400" dirty="0">
+              <a:rPr lang="en-US" sz="1100" dirty="0">
                 <a:solidFill>
                   <a:srgbClr val="1A1A1A"/>
                 </a:solidFill>
@@ -3412,9 +3203,9 @@
                 <a:ea typeface="Calibri" pitchFamily="34" charset="-122"/>
                 <a:cs typeface="Calibri" pitchFamily="34" charset="-120"/>
               </a:rPr>
-              <a:t>Bollen et al., the cognitive-distortions hockey stick (PNAS 2021), with the Schmidt et al. critique</a:t>
-            </a:r>
-            <a:endParaRPr lang="en-US" sz="1400" dirty="0"/>
+              <a:t>Introductions and working agreements, demonstrated in practice. Today's live coding deliberately includes real mistakes.</a:t>
+            </a:r>
+            <a:endParaRPr lang="en-US" sz="1100" dirty="0"/>
           </a:p>
         </p:txBody>
       </p:sp>
@@ -3426,14 +3217,16 @@
         </p:nvSpPr>
         <p:spPr>
           <a:xfrm>
-            <a:off x="640080" y="2633472"/>
-            <a:ext cx="219456" cy="219456"/>
-          </a:xfrm>
-          <a:prstGeom prst="ellipse">
-            <a:avLst/>
-          </a:prstGeom>
-          <a:solidFill>
-            <a:srgbClr val="3F6F5F"/>
+            <a:off x="640080" y="2132838"/>
+            <a:ext cx="868680" cy="450342"/>
+          </a:xfrm>
+          <a:prstGeom prst="roundRect">
+            <a:avLst>
+              <a:gd name="adj" fmla="val 12183"/>
+            </a:avLst>
+          </a:prstGeom>
+          <a:solidFill>
+            <a:srgbClr val="7A3B2E"/>
           </a:solidFill>
           <a:ln/>
         </p:spPr>
@@ -3446,8 +3239,8 @@
         </p:nvSpPr>
         <p:spPr>
           <a:xfrm>
-            <a:off x="1051560" y="2560320"/>
-            <a:ext cx="10424160" cy="365760"/>
+            <a:off x="640080" y="2132838"/>
+            <a:ext cx="868680" cy="450342"/>
           </a:xfrm>
           <a:prstGeom prst="rect">
             <a:avLst/>
@@ -3459,21 +3252,21 @@
           <a:bodyPr wrap="square" rtlCol="0" anchor="ctr"/>
           <a:lstStyle/>
           <a:p>
-            <a:pPr indent="0" marL="0">
-              <a:buNone/>
-            </a:pPr>
-            <a:r>
-              <a:rPr lang="en-US" sz="1500" b="1" dirty="0">
-                <a:solidFill>
-                  <a:srgbClr val="3F6F5F"/>
+            <a:pPr algn="ctr" indent="0" marL="0">
+              <a:buNone/>
+            </a:pPr>
+            <a:r>
+              <a:rPr lang="en-US" sz="1100" b="1" dirty="0">
+                <a:solidFill>
+                  <a:srgbClr val="FFFFFF"/>
                 </a:solidFill>
                 <a:latin typeface="Calibri" pitchFamily="34" charset="0"/>
                 <a:ea typeface="Calibri" pitchFamily="34" charset="-122"/>
                 <a:cs typeface="Calibri" pitchFamily="34" charset="-120"/>
               </a:rPr>
-              <a:t>Supplement</a:t>
-            </a:r>
-            <a:endParaRPr lang="en-US" sz="1500" dirty="0"/>
+              <a:t>0:10</a:t>
+            </a:r>
+            <a:endParaRPr lang="en-US" sz="1100" dirty="0"/>
           </a:p>
         </p:txBody>
       </p:sp>
@@ -3485,17 +3278,17 @@
         </p:nvSpPr>
         <p:spPr>
           <a:xfrm>
-            <a:off x="1051560" y="2944368"/>
-            <a:ext cx="10424160" cy="731520"/>
-          </a:xfrm>
-          <a:prstGeom prst="rect">
-            <a:avLst/>
-          </a:prstGeom>
-          <a:noFill/>
-          <a:ln/>
-        </p:spPr>
-        <p:txBody>
-          <a:bodyPr wrap="square" rtlCol="0" anchor="t">
+            <a:off x="1691640" y="2114550"/>
+            <a:ext cx="9646920" cy="560070"/>
+          </a:xfrm>
+          <a:prstGeom prst="rect">
+            <a:avLst/>
+          </a:prstGeom>
+          <a:noFill/>
+          <a:ln/>
+        </p:spPr>
+        <p:txBody>
+          <a:bodyPr wrap="square" rtlCol="0" anchor="ctr">
             <a:spAutoFit/>
           </a:bodyPr>
           <a:lstStyle/>
@@ -3504,7 +3297,7 @@
               <a:buNone/>
             </a:pPr>
             <a:r>
-              <a:rPr lang="en-US" sz="1400" dirty="0">
+              <a:rPr lang="en-US" sz="1100" dirty="0">
                 <a:solidFill>
                   <a:srgbClr val="1A1A1A"/>
                 </a:solidFill>
@@ -3512,9 +3305,9 @@
                 <a:ea typeface="Calibri" pitchFamily="34" charset="-122"/>
                 <a:cs typeface="Calibri" pitchFamily="34" charset="-120"/>
               </a:rPr>
-              <a:t>Robin Sloan, Writing with the machine</a:t>
-            </a:r>
-            <a:endParaRPr lang="en-US" sz="1400" dirty="0"/>
+              <a:t>Lecture, the stakes: machines already read culture at scale, the feed ranking what you see, the moderation filter, the model trained on scraped art and prose, and that reading happens without you. Counting culture has produced real knowledge (the screenplay verb split, the Rowling unmasking, pop music's 1991 revolution) and real mistakes, and both look identical until someone checks. In ten weeks you do the reading yourself and publish something checkable.</a:t>
+            </a:r>
+            <a:endParaRPr lang="en-US" sz="1100" dirty="0"/>
           </a:p>
         </p:txBody>
       </p:sp>
@@ -3526,14 +3319,16 @@
         </p:nvSpPr>
         <p:spPr>
           <a:xfrm>
-            <a:off x="640080" y="3593592"/>
-            <a:ext cx="219456" cy="219456"/>
-          </a:xfrm>
-          <a:prstGeom prst="ellipse">
-            <a:avLst/>
-          </a:prstGeom>
-          <a:solidFill>
-            <a:srgbClr val="B9852F"/>
+            <a:off x="640080" y="2692908"/>
+            <a:ext cx="868680" cy="450342"/>
+          </a:xfrm>
+          <a:prstGeom prst="roundRect">
+            <a:avLst>
+              <a:gd name="adj" fmla="val 12183"/>
+            </a:avLst>
+          </a:prstGeom>
+          <a:solidFill>
+            <a:srgbClr val="7A3B2E"/>
           </a:solidFill>
           <a:ln/>
         </p:spPr>
@@ -3546,8 +3341,8 @@
         </p:nvSpPr>
         <p:spPr>
           <a:xfrm>
-            <a:off x="1051560" y="3520440"/>
-            <a:ext cx="10424160" cy="365760"/>
+            <a:off x="640080" y="2692908"/>
+            <a:ext cx="868680" cy="450342"/>
           </a:xfrm>
           <a:prstGeom prst="rect">
             <a:avLst/>
@@ -3559,21 +3354,21 @@
           <a:bodyPr wrap="square" rtlCol="0" anchor="ctr"/>
           <a:lstStyle/>
           <a:p>
-            <a:pPr indent="0" marL="0">
-              <a:buNone/>
-            </a:pPr>
-            <a:r>
-              <a:rPr lang="en-US" sz="1500" b="1" dirty="0">
-                <a:solidFill>
-                  <a:srgbClr val="B9852F"/>
+            <a:pPr algn="ctr" indent="0" marL="0">
+              <a:buNone/>
+            </a:pPr>
+            <a:r>
+              <a:rPr lang="en-US" sz="1100" b="1" dirty="0">
+                <a:solidFill>
+                  <a:srgbClr val="FFFFFF"/>
                 </a:solidFill>
                 <a:latin typeface="Calibri" pitchFamily="34" charset="0"/>
                 <a:ea typeface="Calibri" pitchFamily="34" charset="-122"/>
                 <a:cs typeface="Calibri" pitchFamily="34" charset="-120"/>
               </a:rPr>
-              <a:t>Deeper (optional)</a:t>
-            </a:r>
-            <a:endParaRPr lang="en-US" sz="1500" dirty="0"/>
+              <a:t>0:28</a:t>
+            </a:r>
+            <a:endParaRPr lang="en-US" sz="1100" dirty="0"/>
           </a:p>
         </p:txBody>
       </p:sp>
@@ -3585,17 +3380,17 @@
         </p:nvSpPr>
         <p:spPr>
           <a:xfrm>
-            <a:off x="1051560" y="3904488"/>
-            <a:ext cx="10424160" cy="731520"/>
-          </a:xfrm>
-          <a:prstGeom prst="rect">
-            <a:avLst/>
-          </a:prstGeom>
-          <a:noFill/>
-          <a:ln/>
-        </p:spPr>
-        <p:txBody>
-          <a:bodyPr wrap="square" rtlCol="0" anchor="t">
+            <a:off x="1691640" y="2674620"/>
+            <a:ext cx="9646920" cy="560070"/>
+          </a:xfrm>
+          <a:prstGeom prst="rect">
+            <a:avLst/>
+          </a:prstGeom>
+          <a:noFill/>
+          <a:ln/>
+        </p:spPr>
+        <p:txBody>
+          <a:bodyPr wrap="square" rtlCol="0" anchor="ctr">
             <a:spAutoFit/>
           </a:bodyPr>
           <a:lstStyle/>
@@ -3604,7 +3399,7 @@
               <a:buNone/>
             </a:pPr>
             <a:r>
-              <a:rPr lang="en-US" sz="1400" dirty="0">
+              <a:rPr lang="en-US" sz="1100" dirty="0">
                 <a:solidFill>
                   <a:srgbClr val="1A1A1A"/>
                 </a:solidFill>
@@ -3612,9 +3407,9 @@
                 <a:ea typeface="Calibri" pitchFamily="34" charset="-122"/>
                 <a:cs typeface="Calibri" pitchFamily="34" charset="-120"/>
               </a:rPr>
-              <a:t>Moretti, Conjectures on World Literature (NLR 2000), the founding argument for reading culture at scale</a:t>
-            </a:r>
-            <a:endParaRPr lang="en-US" sz="1400" dirty="0"/>
+              <a:t>Look at This, then Question It: She Giggles, He Gallops.</a:t>
+            </a:r>
+            <a:endParaRPr lang="en-US" sz="1100" dirty="0"/>
           </a:p>
         </p:txBody>
       </p:sp>
@@ -3626,14 +3421,16 @@
         </p:nvSpPr>
         <p:spPr>
           <a:xfrm>
-            <a:off x="640080" y="4553712"/>
-            <a:ext cx="219456" cy="219456"/>
-          </a:xfrm>
-          <a:prstGeom prst="ellipse">
-            <a:avLst/>
-          </a:prstGeom>
-          <a:solidFill>
-            <a:srgbClr val="3F6F5F"/>
+            <a:off x="640080" y="3252978"/>
+            <a:ext cx="868680" cy="450342"/>
+          </a:xfrm>
+          <a:prstGeom prst="roundRect">
+            <a:avLst>
+              <a:gd name="adj" fmla="val 12183"/>
+            </a:avLst>
+          </a:prstGeom>
+          <a:solidFill>
+            <a:srgbClr val="7A3B2E"/>
           </a:solidFill>
           <a:ln/>
         </p:spPr>
@@ -3646,8 +3443,8 @@
         </p:nvSpPr>
         <p:spPr>
           <a:xfrm>
-            <a:off x="1051560" y="4480560"/>
-            <a:ext cx="10424160" cy="365760"/>
+            <a:off x="640080" y="3252978"/>
+            <a:ext cx="868680" cy="450342"/>
           </a:xfrm>
           <a:prstGeom prst="rect">
             <a:avLst/>
@@ -3659,21 +3456,21 @@
           <a:bodyPr wrap="square" rtlCol="0" anchor="ctr"/>
           <a:lstStyle/>
           <a:p>
-            <a:pPr indent="0" marL="0">
-              <a:buNone/>
-            </a:pPr>
-            <a:r>
-              <a:rPr lang="en-US" sz="1500" b="1" dirty="0">
-                <a:solidFill>
-                  <a:srgbClr val="3F6F5F"/>
+            <a:pPr algn="ctr" indent="0" marL="0">
+              <a:buNone/>
+            </a:pPr>
+            <a:r>
+              <a:rPr lang="en-US" sz="1100" b="1" dirty="0">
+                <a:solidFill>
+                  <a:srgbClr val="FFFFFF"/>
                 </a:solidFill>
                 <a:latin typeface="Calibri" pitchFamily="34" charset="0"/>
                 <a:ea typeface="Calibri" pitchFamily="34" charset="-122"/>
                 <a:cs typeface="Calibri" pitchFamily="34" charset="-120"/>
               </a:rPr>
-              <a:t>Sketch</a:t>
-            </a:r>
-            <a:endParaRPr lang="en-US" sz="1500" dirty="0"/>
+              <a:t>0:35</a:t>
+            </a:r>
+            <a:endParaRPr lang="en-US" sz="1100" dirty="0"/>
           </a:p>
         </p:txBody>
       </p:sp>
@@ -3685,17 +3482,17 @@
         </p:nvSpPr>
         <p:spPr>
           <a:xfrm>
-            <a:off x="1051560" y="4864608"/>
-            <a:ext cx="10424160" cy="731520"/>
-          </a:xfrm>
-          <a:prstGeom prst="rect">
-            <a:avLst/>
-          </a:prstGeom>
-          <a:noFill/>
-          <a:ln/>
-        </p:spPr>
-        <p:txBody>
-          <a:bodyPr wrap="square" rtlCol="0" anchor="t">
+            <a:off x="1691640" y="3234690"/>
+            <a:ext cx="9646920" cy="560070"/>
+          </a:xfrm>
+          <a:prstGeom prst="rect">
+            <a:avLst/>
+          </a:prstGeom>
+          <a:noFill/>
+          <a:ln/>
+        </p:spPr>
+        <p:txBody>
+          <a:bodyPr wrap="square" rtlCol="0" anchor="ctr">
             <a:spAutoFit/>
           </a:bodyPr>
           <a:lstStyle/>
@@ -3704,7 +3501,7 @@
               <a:buNone/>
             </a:pPr>
             <a:r>
-              <a:rPr lang="en-US" sz="1400" dirty="0">
+              <a:rPr lang="en-US" sz="1100" dirty="0">
                 <a:solidFill>
                   <a:srgbClr val="1A1A1A"/>
                 </a:solidFill>
@@ -3712,9 +3509,9 @@
                 <a:ea typeface="Calibri" pitchFamily="34" charset="-122"/>
                 <a:cs typeface="Calibri" pitchFamily="34" charset="-120"/>
               </a:rPr>
-              <a:t>One question from your life answerable with text or image data; three sentences.</a:t>
-            </a:r>
-            <a:endParaRPr lang="en-US" sz="1400" dirty="0"/>
+              <a:t>The vocabulary and the map (no code): corpus, method, model, embedding, in plain language with pictures. The deliverable, shown: a web essay on a runnable notebook.</a:t>
+            </a:r>
+            <a:endParaRPr lang="en-US" sz="1100" dirty="0"/>
           </a:p>
         </p:txBody>
       </p:sp>
@@ -3726,11 +3523,13 @@
         </p:nvSpPr>
         <p:spPr>
           <a:xfrm>
-            <a:off x="640080" y="5513832"/>
-            <a:ext cx="219456" cy="219456"/>
-          </a:xfrm>
-          <a:prstGeom prst="ellipse">
-            <a:avLst/>
+            <a:off x="640080" y="3813048"/>
+            <a:ext cx="868680" cy="450342"/>
+          </a:xfrm>
+          <a:prstGeom prst="roundRect">
+            <a:avLst>
+              <a:gd name="adj" fmla="val 12183"/>
+            </a:avLst>
           </a:prstGeom>
           <a:solidFill>
             <a:srgbClr val="7A3B2E"/>
@@ -3746,8 +3545,8 @@
         </p:nvSpPr>
         <p:spPr>
           <a:xfrm>
-            <a:off x="1051560" y="5440680"/>
-            <a:ext cx="10424160" cy="365760"/>
+            <a:off x="640080" y="3813048"/>
+            <a:ext cx="868680" cy="450342"/>
           </a:xfrm>
           <a:prstGeom prst="rect">
             <a:avLst/>
@@ -3759,21 +3558,21 @@
           <a:bodyPr wrap="square" rtlCol="0" anchor="ctr"/>
           <a:lstStyle/>
           <a:p>
-            <a:pPr indent="0" marL="0">
-              <a:buNone/>
-            </a:pPr>
-            <a:r>
-              <a:rPr lang="en-US" sz="1500" b="1" dirty="0">
-                <a:solidFill>
-                  <a:srgbClr val="7A3B2E"/>
+            <a:pPr algn="ctr" indent="0" marL="0">
+              <a:buNone/>
+            </a:pPr>
+            <a:r>
+              <a:rPr lang="en-US" sz="1100" b="1" dirty="0">
+                <a:solidFill>
+                  <a:srgbClr val="FFFFFF"/>
                 </a:solidFill>
                 <a:latin typeface="Calibri" pitchFamily="34" charset="0"/>
                 <a:ea typeface="Calibri" pitchFamily="34" charset="-122"/>
                 <a:cs typeface="Calibri" pitchFamily="34" charset="-120"/>
               </a:rPr>
-              <a:t>Check (AI closed)</a:t>
-            </a:r>
-            <a:endParaRPr lang="en-US" sz="1500" dirty="0"/>
+              <a:t>0:47</a:t>
+            </a:r>
+            <a:endParaRPr lang="en-US" sz="1100" dirty="0"/>
           </a:p>
         </p:txBody>
       </p:sp>
@@ -3785,17 +3584,17 @@
         </p:nvSpPr>
         <p:spPr>
           <a:xfrm>
-            <a:off x="1051560" y="5824728"/>
-            <a:ext cx="10424160" cy="731520"/>
-          </a:xfrm>
-          <a:prstGeom prst="rect">
-            <a:avLst/>
-          </a:prstGeom>
-          <a:noFill/>
-          <a:ln/>
-        </p:spPr>
-        <p:txBody>
-          <a:bodyPr wrap="square" rtlCol="0" anchor="t">
+            <a:off x="1691640" y="3794760"/>
+            <a:ext cx="9646920" cy="560070"/>
+          </a:xfrm>
+          <a:prstGeom prst="rect">
+            <a:avLst/>
+          </a:prstGeom>
+          <a:noFill/>
+          <a:ln/>
+        </p:spPr>
+        <p:txBody>
+          <a:bodyPr wrap="square" rtlCol="0" anchor="ctr">
             <a:spAutoFit/>
           </a:bodyPr>
           <a:lstStyle/>
@@ -3804,7 +3603,7 @@
               <a:buNone/>
             </a:pPr>
             <a:r>
-              <a:rPr lang="en-US" sz="1400" dirty="0">
+              <a:rPr lang="en-US" sz="1100" dirty="0">
                 <a:solidFill>
                   <a:srgbClr val="1A1A1A"/>
                 </a:solidFill>
@@ -3812,9 +3611,315 @@
                 <a:ea typeface="Calibri" pitchFamily="34" charset="-122"/>
                 <a:cs typeface="Calibri" pitchFamily="34" charset="-120"/>
               </a:rPr>
-              <a:t>Trace it: one written sentence predicting what your cell does before you run it. (Competency 1.)</a:t>
-            </a:r>
-            <a:endParaRPr lang="en-US" sz="1400" dirty="0"/>
+              <a:t>Lab 1 (worked, participatory): copy the notebook to Drive and mount Drive into the runtime (this is how your corpus and results survive Colab wiping the session, everything saving to one project folder), put a Gemini key in Colab Secrets, load NYT wedding data, make a first chart. Hand out the common-errors cheat sheet. Then solo with a partner: draft three questions, pick one, have the AI write the code, run it, chart it. Write one sentence predicting your cell before you run it.</a:t>
+            </a:r>
+            <a:endParaRPr lang="en-US" sz="1100" dirty="0"/>
+          </a:p>
+        </p:txBody>
+      </p:sp>
+      <p:sp>
+        <p:nvSpPr>
+          <p:cNvPr id="18" name="Shape 16"/>
+          <p:cNvSpPr/>
+          <p:nvPr/>
+        </p:nvSpPr>
+        <p:spPr>
+          <a:xfrm>
+            <a:off x="640080" y="4373118"/>
+            <a:ext cx="868680" cy="450342"/>
+          </a:xfrm>
+          <a:prstGeom prst="roundRect">
+            <a:avLst>
+              <a:gd name="adj" fmla="val 12183"/>
+            </a:avLst>
+          </a:prstGeom>
+          <a:solidFill>
+            <a:srgbClr val="7A3B2E"/>
+          </a:solidFill>
+          <a:ln/>
+        </p:spPr>
+      </p:sp>
+      <p:sp>
+        <p:nvSpPr>
+          <p:cNvPr id="19" name="Text 17"/>
+          <p:cNvSpPr/>
+          <p:nvPr/>
+        </p:nvSpPr>
+        <p:spPr>
+          <a:xfrm>
+            <a:off x="640080" y="4373118"/>
+            <a:ext cx="868680" cy="450342"/>
+          </a:xfrm>
+          <a:prstGeom prst="rect">
+            <a:avLst/>
+          </a:prstGeom>
+          <a:noFill/>
+          <a:ln/>
+        </p:spPr>
+        <p:txBody>
+          <a:bodyPr wrap="square" rtlCol="0" anchor="ctr"/>
+          <a:lstStyle/>
+          <a:p>
+            <a:pPr algn="ctr" indent="0" marL="0">
+              <a:buNone/>
+            </a:pPr>
+            <a:r>
+              <a:rPr lang="en-US" sz="1100" b="1" dirty="0">
+                <a:solidFill>
+                  <a:srgbClr val="FFFFFF"/>
+                </a:solidFill>
+                <a:latin typeface="Calibri" pitchFamily="34" charset="0"/>
+                <a:ea typeface="Calibri" pitchFamily="34" charset="-122"/>
+                <a:cs typeface="Calibri" pitchFamily="34" charset="-120"/>
+              </a:rPr>
+              <a:t>1:20</a:t>
+            </a:r>
+            <a:endParaRPr lang="en-US" sz="1100" dirty="0"/>
+          </a:p>
+        </p:txBody>
+      </p:sp>
+      <p:sp>
+        <p:nvSpPr>
+          <p:cNvPr id="20" name="Text 18"/>
+          <p:cNvSpPr/>
+          <p:nvPr/>
+        </p:nvSpPr>
+        <p:spPr>
+          <a:xfrm>
+            <a:off x="1691640" y="4354830"/>
+            <a:ext cx="9646920" cy="560070"/>
+          </a:xfrm>
+          <a:prstGeom prst="rect">
+            <a:avLst/>
+          </a:prstGeom>
+          <a:noFill/>
+          <a:ln/>
+        </p:spPr>
+        <p:txBody>
+          <a:bodyPr wrap="square" rtlCol="0" anchor="ctr">
+            <a:spAutoFit/>
+          </a:bodyPr>
+          <a:lstStyle/>
+          <a:p>
+            <a:pPr indent="0" marL="0">
+              <a:buNone/>
+            </a:pPr>
+            <a:r>
+              <a:rPr lang="en-US" sz="1100" dirty="0">
+                <a:solidFill>
+                  <a:srgbClr val="1A1A1A"/>
+                </a:solidFill>
+                <a:latin typeface="Calibri" pitchFamily="34" charset="0"/>
+                <a:ea typeface="Calibri" pitchFamily="34" charset="-122"/>
+                <a:cs typeface="Calibri" pitchFamily="34" charset="-120"/>
+              </a:rPr>
+              <a:t>Break</a:t>
+            </a:r>
+            <a:endParaRPr lang="en-US" sz="1100" dirty="0"/>
+          </a:p>
+        </p:txBody>
+      </p:sp>
+      <p:sp>
+        <p:nvSpPr>
+          <p:cNvPr id="21" name="Shape 19"/>
+          <p:cNvSpPr/>
+          <p:nvPr/>
+        </p:nvSpPr>
+        <p:spPr>
+          <a:xfrm>
+            <a:off x="640080" y="4933188"/>
+            <a:ext cx="868680" cy="450342"/>
+          </a:xfrm>
+          <a:prstGeom prst="roundRect">
+            <a:avLst>
+              <a:gd name="adj" fmla="val 12183"/>
+            </a:avLst>
+          </a:prstGeom>
+          <a:solidFill>
+            <a:srgbClr val="7A3B2E"/>
+          </a:solidFill>
+          <a:ln/>
+        </p:spPr>
+      </p:sp>
+      <p:sp>
+        <p:nvSpPr>
+          <p:cNvPr id="22" name="Text 20"/>
+          <p:cNvSpPr/>
+          <p:nvPr/>
+        </p:nvSpPr>
+        <p:spPr>
+          <a:xfrm>
+            <a:off x="640080" y="4933188"/>
+            <a:ext cx="868680" cy="450342"/>
+          </a:xfrm>
+          <a:prstGeom prst="rect">
+            <a:avLst/>
+          </a:prstGeom>
+          <a:noFill/>
+          <a:ln/>
+        </p:spPr>
+        <p:txBody>
+          <a:bodyPr wrap="square" rtlCol="0" anchor="ctr"/>
+          <a:lstStyle/>
+          <a:p>
+            <a:pPr algn="ctr" indent="0" marL="0">
+              <a:buNone/>
+            </a:pPr>
+            <a:r>
+              <a:rPr lang="en-US" sz="1100" b="1" dirty="0">
+                <a:solidFill>
+                  <a:srgbClr val="FFFFFF"/>
+                </a:solidFill>
+                <a:latin typeface="Calibri" pitchFamily="34" charset="0"/>
+                <a:ea typeface="Calibri" pitchFamily="34" charset="-122"/>
+                <a:cs typeface="Calibri" pitchFamily="34" charset="-120"/>
+              </a:rPr>
+              <a:t>1:30</a:t>
+            </a:r>
+            <a:endParaRPr lang="en-US" sz="1100" dirty="0"/>
+          </a:p>
+        </p:txBody>
+      </p:sp>
+      <p:sp>
+        <p:nvSpPr>
+          <p:cNvPr id="23" name="Text 21"/>
+          <p:cNvSpPr/>
+          <p:nvPr/>
+        </p:nvSpPr>
+        <p:spPr>
+          <a:xfrm>
+            <a:off x="1691640" y="4914900"/>
+            <a:ext cx="9646920" cy="560070"/>
+          </a:xfrm>
+          <a:prstGeom prst="rect">
+            <a:avLst/>
+          </a:prstGeom>
+          <a:noFill/>
+          <a:ln/>
+        </p:spPr>
+        <p:txBody>
+          <a:bodyPr wrap="square" rtlCol="0" anchor="ctr">
+            <a:spAutoFit/>
+          </a:bodyPr>
+          <a:lstStyle/>
+          <a:p>
+            <a:pPr indent="0" marL="0">
+              <a:buNone/>
+            </a:pPr>
+            <a:r>
+              <a:rPr lang="en-US" sz="1100" dirty="0">
+                <a:solidFill>
+                  <a:srgbClr val="1A1A1A"/>
+                </a:solidFill>
+                <a:latin typeface="Calibri" pitchFamily="34" charset="0"/>
+                <a:ea typeface="Calibri" pitchFamily="34" charset="-122"/>
+                <a:cs typeface="Calibri" pitchFamily="34" charset="-120"/>
+              </a:rPr>
+              <a:t>Lab 2 (worked): count words, then pixels. First the top words of a small lyrics sample (stop-words dominate the list until you remove them, the first counting decision), then an image corpus: ~200 Met thumbnails ranked darkest to brightest by average brightness. Text and images, counted with the same technique; image projects begin here.</a:t>
+            </a:r>
+            <a:endParaRPr lang="en-US" sz="1100" dirty="0"/>
+          </a:p>
+        </p:txBody>
+      </p:sp>
+      <p:sp>
+        <p:nvSpPr>
+          <p:cNvPr id="24" name="Shape 22"/>
+          <p:cNvSpPr/>
+          <p:nvPr/>
+        </p:nvSpPr>
+        <p:spPr>
+          <a:xfrm>
+            <a:off x="640080" y="5493258"/>
+            <a:ext cx="868680" cy="450342"/>
+          </a:xfrm>
+          <a:prstGeom prst="roundRect">
+            <a:avLst>
+              <a:gd name="adj" fmla="val 12183"/>
+            </a:avLst>
+          </a:prstGeom>
+          <a:solidFill>
+            <a:srgbClr val="7A3B2E"/>
+          </a:solidFill>
+          <a:ln/>
+        </p:spPr>
+      </p:sp>
+      <p:sp>
+        <p:nvSpPr>
+          <p:cNvPr id="25" name="Text 23"/>
+          <p:cNvSpPr/>
+          <p:nvPr/>
+        </p:nvSpPr>
+        <p:spPr>
+          <a:xfrm>
+            <a:off x="640080" y="5493258"/>
+            <a:ext cx="868680" cy="450342"/>
+          </a:xfrm>
+          <a:prstGeom prst="rect">
+            <a:avLst/>
+          </a:prstGeom>
+          <a:noFill/>
+          <a:ln/>
+        </p:spPr>
+        <p:txBody>
+          <a:bodyPr wrap="square" rtlCol="0" anchor="ctr"/>
+          <a:lstStyle/>
+          <a:p>
+            <a:pPr algn="ctr" indent="0" marL="0">
+              <a:buNone/>
+            </a:pPr>
+            <a:r>
+              <a:rPr lang="en-US" sz="1100" b="1" dirty="0">
+                <a:solidFill>
+                  <a:srgbClr val="FFFFFF"/>
+                </a:solidFill>
+                <a:latin typeface="Calibri" pitchFamily="34" charset="0"/>
+                <a:ea typeface="Calibri" pitchFamily="34" charset="-122"/>
+                <a:cs typeface="Calibri" pitchFamily="34" charset="-120"/>
+              </a:rPr>
+              <a:t>1:52</a:t>
+            </a:r>
+            <a:endParaRPr lang="en-US" sz="1100" dirty="0"/>
+          </a:p>
+        </p:txBody>
+      </p:sp>
+      <p:sp>
+        <p:nvSpPr>
+          <p:cNvPr id="26" name="Text 24"/>
+          <p:cNvSpPr/>
+          <p:nvPr/>
+        </p:nvSpPr>
+        <p:spPr>
+          <a:xfrm>
+            <a:off x="1691640" y="5474970"/>
+            <a:ext cx="9646920" cy="560070"/>
+          </a:xfrm>
+          <a:prstGeom prst="rect">
+            <a:avLst/>
+          </a:prstGeom>
+          <a:noFill/>
+          <a:ln/>
+        </p:spPr>
+        <p:txBody>
+          <a:bodyPr wrap="square" rtlCol="0" anchor="ctr">
+            <a:spAutoFit/>
+          </a:bodyPr>
+          <a:lstStyle/>
+          <a:p>
+            <a:pPr indent="0" marL="0">
+              <a:buNone/>
+            </a:pPr>
+            <a:r>
+              <a:rPr lang="en-US" sz="1100" dirty="0">
+                <a:solidFill>
+                  <a:srgbClr val="1A1A1A"/>
+                </a:solidFill>
+                <a:latin typeface="Calibri" pitchFamily="34" charset="0"/>
+                <a:ea typeface="Calibri" pitchFamily="34" charset="-122"/>
+                <a:cs typeface="Calibri" pitchFamily="34" charset="-120"/>
+              </a:rPr>
+              <a:t>Preview of the methods ahead; the weekly routines introduced. First check-out.</a:t>
+            </a:r>
+            <a:endParaRPr lang="en-US" sz="1100" dirty="0"/>
           </a:p>
         </p:txBody>
       </p:sp>
@@ -3859,7 +3964,7 @@
         <p:spPr>
           <a:xfrm>
             <a:off x="640080" y="640080"/>
-            <a:ext cx="10058400" cy="320040"/>
+            <a:ext cx="10058400" cy="731520"/>
           </a:xfrm>
           <a:prstGeom prst="rect">
             <a:avLst/>
@@ -3875,7 +3980,66 @@
               <a:buNone/>
             </a:pPr>
             <a:r>
-              <a:rPr lang="en-US" sz="1300" b="1" spc="300" kern="0" dirty="0">
+              <a:rPr lang="en-US" sz="3000" b="1" dirty="0">
+                <a:solidFill>
+                  <a:srgbClr val="1A1A1A"/>
+                </a:solidFill>
+                <a:latin typeface="Cambria" pitchFamily="34" charset="0"/>
+                <a:ea typeface="Cambria" pitchFamily="34" charset="-122"/>
+                <a:cs typeface="Cambria" pitchFamily="34" charset="-120"/>
+              </a:rPr>
+              <a:t>Reading &amp; homework</a:t>
+            </a:r>
+            <a:endParaRPr lang="en-US" sz="3000" dirty="0"/>
+          </a:p>
+        </p:txBody>
+      </p:sp>
+      <p:sp>
+        <p:nvSpPr>
+          <p:cNvPr id="3" name="Shape 1"/>
+          <p:cNvSpPr/>
+          <p:nvPr/>
+        </p:nvSpPr>
+        <p:spPr>
+          <a:xfrm>
+            <a:off x="640080" y="1673352"/>
+            <a:ext cx="219456" cy="219456"/>
+          </a:xfrm>
+          <a:prstGeom prst="ellipse">
+            <a:avLst/>
+          </a:prstGeom>
+          <a:solidFill>
+            <a:srgbClr val="7A3B2E"/>
+          </a:solidFill>
+          <a:ln/>
+        </p:spPr>
+      </p:sp>
+      <p:sp>
+        <p:nvSpPr>
+          <p:cNvPr id="4" name="Text 2"/>
+          <p:cNvSpPr/>
+          <p:nvPr/>
+        </p:nvSpPr>
+        <p:spPr>
+          <a:xfrm>
+            <a:off x="1051560" y="1600200"/>
+            <a:ext cx="10424160" cy="365760"/>
+          </a:xfrm>
+          <a:prstGeom prst="rect">
+            <a:avLst/>
+          </a:prstGeom>
+          <a:noFill/>
+          <a:ln/>
+        </p:spPr>
+        <p:txBody>
+          <a:bodyPr wrap="square" rtlCol="0" anchor="ctr"/>
+          <a:lstStyle/>
+          <a:p>
+            <a:pPr indent="0" marL="0">
+              <a:buNone/>
+            </a:pPr>
+            <a:r>
+              <a:rPr lang="en-US" sz="1500" b="1" dirty="0">
                 <a:solidFill>
                   <a:srgbClr val="7A3B2E"/>
                 </a:solidFill>
@@ -3883,72 +4047,11 @@
                 <a:ea typeface="Calibri" pitchFamily="34" charset="-122"/>
                 <a:cs typeface="Calibri" pitchFamily="34" charset="-120"/>
               </a:rPr>
-              <a:t>HOW THIS WEEK CONNECTS</a:t>
-            </a:r>
-            <a:endParaRPr lang="en-US" sz="1300" dirty="0"/>
-          </a:p>
-        </p:txBody>
-      </p:sp>
-      <p:sp>
-        <p:nvSpPr>
-          <p:cNvPr id="3" name="Text 1"/>
-          <p:cNvSpPr/>
-          <p:nvPr/>
-        </p:nvSpPr>
-        <p:spPr>
-          <a:xfrm>
-            <a:off x="640080" y="987552"/>
-            <a:ext cx="10058400" cy="640080"/>
-          </a:xfrm>
-          <a:prstGeom prst="rect">
-            <a:avLst/>
-          </a:prstGeom>
-          <a:noFill/>
-          <a:ln/>
-        </p:spPr>
-        <p:txBody>
-          <a:bodyPr wrap="square" rtlCol="0" anchor="ctr"/>
-          <a:lstStyle/>
-          <a:p>
-            <a:pPr indent="0" marL="0">
-              <a:buNone/>
-            </a:pPr>
-            <a:r>
-              <a:rPr lang="en-US" sz="2800" b="1" dirty="0">
-                <a:solidFill>
-                  <a:srgbClr val="1A1A1A"/>
-                </a:solidFill>
-                <a:latin typeface="Cambria" pitchFamily="34" charset="0"/>
-                <a:ea typeface="Cambria" pitchFamily="34" charset="-122"/>
-                <a:cs typeface="Cambria" pitchFamily="34" charset="-120"/>
-              </a:rPr>
-              <a:t>The course's through-lines</a:t>
-            </a:r>
-            <a:endParaRPr lang="en-US" sz="2800" dirty="0"/>
-          </a:p>
-        </p:txBody>
-      </p:sp>
-      <p:sp>
-        <p:nvSpPr>
-          <p:cNvPr id="4" name="Shape 2"/>
-          <p:cNvSpPr/>
-          <p:nvPr/>
-        </p:nvSpPr>
-        <p:spPr>
-          <a:xfrm>
-            <a:off x="640080" y="2057400"/>
-            <a:ext cx="457200" cy="457200"/>
-          </a:xfrm>
-          <a:prstGeom prst="roundRect">
-            <a:avLst>
-              <a:gd name="adj" fmla="val 16000"/>
-            </a:avLst>
-          </a:prstGeom>
-          <a:solidFill>
-            <a:srgbClr val="7A3B2E"/>
-          </a:solidFill>
-          <a:ln/>
-        </p:spPr>
+              <a:t>Reading</a:t>
+            </a:r>
+            <a:endParaRPr lang="en-US" sz="1500" dirty="0"/>
+          </a:p>
+        </p:txBody>
       </p:sp>
       <p:sp>
         <p:nvSpPr>
@@ -3958,86 +4061,8 @@
         </p:nvSpPr>
         <p:spPr>
           <a:xfrm>
-            <a:off x="640080" y="2057400"/>
-            <a:ext cx="457200" cy="457200"/>
-          </a:xfrm>
-          <a:prstGeom prst="rect">
-            <a:avLst/>
-          </a:prstGeom>
-          <a:noFill/>
-          <a:ln/>
-        </p:spPr>
-        <p:txBody>
-          <a:bodyPr wrap="square" rtlCol="0" anchor="ctr"/>
-          <a:lstStyle/>
-          <a:p>
-            <a:pPr algn="ctr" indent="0" marL="0">
-              <a:buNone/>
-            </a:pPr>
-            <a:r>
-              <a:rPr lang="en-US" sz="2000" b="1" dirty="0">
-                <a:solidFill>
-                  <a:srgbClr val="FFFFFF"/>
-                </a:solidFill>
-                <a:latin typeface="Cambria" pitchFamily="34" charset="0"/>
-                <a:ea typeface="Cambria" pitchFamily="34" charset="-122"/>
-                <a:cs typeface="Cambria" pitchFamily="34" charset="-120"/>
-              </a:rPr>
-              <a:t>1</a:t>
-            </a:r>
-            <a:endParaRPr lang="en-US" sz="2000" dirty="0"/>
-          </a:p>
-        </p:txBody>
-      </p:sp>
-      <p:sp>
-        <p:nvSpPr>
-          <p:cNvPr id="6" name="Text 4"/>
-          <p:cNvSpPr/>
-          <p:nvPr/>
-        </p:nvSpPr>
-        <p:spPr>
-          <a:xfrm>
-            <a:off x="1371600" y="2020824"/>
-            <a:ext cx="10332720" cy="411480"/>
-          </a:xfrm>
-          <a:prstGeom prst="rect">
-            <a:avLst/>
-          </a:prstGeom>
-          <a:noFill/>
-          <a:ln/>
-        </p:spPr>
-        <p:txBody>
-          <a:bodyPr wrap="square" rtlCol="0" anchor="ctr"/>
-          <a:lstStyle/>
-          <a:p>
-            <a:pPr indent="0" marL="0">
-              <a:buNone/>
-            </a:pPr>
-            <a:r>
-              <a:rPr lang="en-US" sz="1900" b="1" dirty="0">
-                <a:solidFill>
-                  <a:srgbClr val="7A3B2E"/>
-                </a:solidFill>
-                <a:latin typeface="Cambria" pitchFamily="34" charset="0"/>
-                <a:ea typeface="Cambria" pitchFamily="34" charset="-122"/>
-                <a:cs typeface="Cambria" pitchFamily="34" charset="-120"/>
-              </a:rPr>
-              <a:t>Read work critically</a:t>
-            </a:r>
-            <a:endParaRPr lang="en-US" sz="1900" dirty="0"/>
-          </a:p>
-        </p:txBody>
-      </p:sp>
-      <p:sp>
-        <p:nvSpPr>
-          <p:cNvPr id="7" name="Text 5"/>
-          <p:cNvSpPr/>
-          <p:nvPr/>
-        </p:nvSpPr>
-        <p:spPr>
-          <a:xfrm>
-            <a:off x="1371600" y="2441448"/>
-            <a:ext cx="10332720" cy="914400"/>
+            <a:off x="1051560" y="1984248"/>
+            <a:ext cx="10424160" cy="731520"/>
           </a:xfrm>
           <a:prstGeom prst="rect">
             <a:avLst/>
@@ -4052,13 +4077,10 @@
           <a:lstStyle/>
           <a:p>
             <a:pPr indent="0" marL="0">
-              <a:lnSpc>
-                <a:spcPct val="112000"/>
-              </a:lnSpc>
-              <a:buNone/>
-            </a:pPr>
-            <a:r>
-              <a:rPr lang="en-US" sz="1450" dirty="0">
+              <a:buNone/>
+            </a:pPr>
+            <a:r>
+              <a:rPr lang="en-US" sz="1400" dirty="0">
                 <a:solidFill>
                   <a:srgbClr val="1A1A1A"/>
                 </a:solidFill>
@@ -4066,27 +4088,25 @@
                 <a:ea typeface="Calibri" pitchFamily="34" charset="-122"/>
                 <a:cs typeface="Calibri" pitchFamily="34" charset="-120"/>
               </a:rPr>
-              <a:t>She Giggles, He Gallops is excellent and its choices are debatable. Admiring and questioning at once is the habit the course is built on.</a:t>
-            </a:r>
-            <a:endParaRPr lang="en-US" sz="1450" dirty="0"/>
-          </a:p>
-        </p:txBody>
-      </p:sp>
-      <p:sp>
-        <p:nvSpPr>
-          <p:cNvPr id="8" name="Shape 6"/>
-          <p:cNvSpPr/>
-          <p:nvPr/>
-        </p:nvSpPr>
-        <p:spPr>
-          <a:xfrm>
-            <a:off x="640080" y="3520440"/>
-            <a:ext cx="457200" cy="457200"/>
-          </a:xfrm>
-          <a:prstGeom prst="roundRect">
-            <a:avLst>
-              <a:gd name="adj" fmla="val 16000"/>
-            </a:avLst>
+              <a:t>Bollen et al., the cognitive-distortions hockey stick (PNAS 2021), with the Schmidt et al. critique</a:t>
+            </a:r>
+            <a:endParaRPr lang="en-US" sz="1400" dirty="0"/>
+          </a:p>
+        </p:txBody>
+      </p:sp>
+      <p:sp>
+        <p:nvSpPr>
+          <p:cNvPr id="6" name="Shape 4"/>
+          <p:cNvSpPr/>
+          <p:nvPr/>
+        </p:nvSpPr>
+        <p:spPr>
+          <a:xfrm>
+            <a:off x="640080" y="2633472"/>
+            <a:ext cx="219456" cy="219456"/>
+          </a:xfrm>
+          <a:prstGeom prst="ellipse">
+            <a:avLst/>
           </a:prstGeom>
           <a:solidFill>
             <a:srgbClr val="3F6F5F"/>
@@ -4096,14 +4116,14 @@
       </p:sp>
       <p:sp>
         <p:nvSpPr>
-          <p:cNvPr id="9" name="Text 7"/>
-          <p:cNvSpPr/>
-          <p:nvPr/>
-        </p:nvSpPr>
-        <p:spPr>
-          <a:xfrm>
-            <a:off x="640080" y="3520440"/>
-            <a:ext cx="457200" cy="457200"/>
+          <p:cNvPr id="7" name="Text 5"/>
+          <p:cNvSpPr/>
+          <p:nvPr/>
+        </p:nvSpPr>
+        <p:spPr>
+          <a:xfrm>
+            <a:off x="1051560" y="2560320"/>
+            <a:ext cx="10424160" cy="365760"/>
           </a:xfrm>
           <a:prstGeom prst="rect">
             <a:avLst/>
@@ -4115,73 +4135,34 @@
           <a:bodyPr wrap="square" rtlCol="0" anchor="ctr"/>
           <a:lstStyle/>
           <a:p>
-            <a:pPr algn="ctr" indent="0" marL="0">
-              <a:buNone/>
-            </a:pPr>
-            <a:r>
-              <a:rPr lang="en-US" sz="2000" b="1" dirty="0">
-                <a:solidFill>
-                  <a:srgbClr val="FFFFFF"/>
-                </a:solidFill>
-                <a:latin typeface="Cambria" pitchFamily="34" charset="0"/>
-                <a:ea typeface="Cambria" pitchFamily="34" charset="-122"/>
-                <a:cs typeface="Cambria" pitchFamily="34" charset="-120"/>
-              </a:rPr>
-              <a:t>2</a:t>
-            </a:r>
-            <a:endParaRPr lang="en-US" sz="2000" dirty="0"/>
-          </a:p>
-        </p:txBody>
-      </p:sp>
-      <p:sp>
-        <p:nvSpPr>
-          <p:cNvPr id="10" name="Text 8"/>
-          <p:cNvSpPr/>
-          <p:nvPr/>
-        </p:nvSpPr>
-        <p:spPr>
-          <a:xfrm>
-            <a:off x="1371600" y="3483864"/>
-            <a:ext cx="10332720" cy="411480"/>
-          </a:xfrm>
-          <a:prstGeom prst="rect">
-            <a:avLst/>
-          </a:prstGeom>
-          <a:noFill/>
-          <a:ln/>
-        </p:spPr>
-        <p:txBody>
-          <a:bodyPr wrap="square" rtlCol="0" anchor="ctr"/>
-          <a:lstStyle/>
-          <a:p>
-            <a:pPr indent="0" marL="0">
-              <a:buNone/>
-            </a:pPr>
-            <a:r>
-              <a:rPr lang="en-US" sz="1900" b="1" dirty="0">
+            <a:pPr indent="0" marL="0">
+              <a:buNone/>
+            </a:pPr>
+            <a:r>
+              <a:rPr lang="en-US" sz="1500" b="1" dirty="0">
                 <a:solidFill>
                   <a:srgbClr val="3F6F5F"/>
                 </a:solidFill>
-                <a:latin typeface="Cambria" pitchFamily="34" charset="0"/>
-                <a:ea typeface="Cambria" pitchFamily="34" charset="-122"/>
-                <a:cs typeface="Cambria" pitchFamily="34" charset="-120"/>
-              </a:rPr>
-              <a:t>Make something real</a:t>
-            </a:r>
-            <a:endParaRPr lang="en-US" sz="1900" dirty="0"/>
-          </a:p>
-        </p:txBody>
-      </p:sp>
-      <p:sp>
-        <p:nvSpPr>
-          <p:cNvPr id="11" name="Text 9"/>
-          <p:cNvSpPr/>
-          <p:nvPr/>
-        </p:nvSpPr>
-        <p:spPr>
-          <a:xfrm>
-            <a:off x="1371600" y="3904488"/>
-            <a:ext cx="10332720" cy="914400"/>
+                <a:latin typeface="Calibri" pitchFamily="34" charset="0"/>
+                <a:ea typeface="Calibri" pitchFamily="34" charset="-122"/>
+                <a:cs typeface="Calibri" pitchFamily="34" charset="-120"/>
+              </a:rPr>
+              <a:t>Supplement</a:t>
+            </a:r>
+            <a:endParaRPr lang="en-US" sz="1500" dirty="0"/>
+          </a:p>
+        </p:txBody>
+      </p:sp>
+      <p:sp>
+        <p:nvSpPr>
+          <p:cNvPr id="8" name="Text 6"/>
+          <p:cNvSpPr/>
+          <p:nvPr/>
+        </p:nvSpPr>
+        <p:spPr>
+          <a:xfrm>
+            <a:off x="1051560" y="2944368"/>
+            <a:ext cx="10424160" cy="731520"/>
           </a:xfrm>
           <a:prstGeom prst="rect">
             <a:avLst/>
@@ -4196,13 +4177,10 @@
           <a:lstStyle/>
           <a:p>
             <a:pPr indent="0" marL="0">
-              <a:lnSpc>
-                <a:spcPct val="112000"/>
-              </a:lnSpc>
-              <a:buNone/>
-            </a:pPr>
-            <a:r>
-              <a:rPr lang="en-US" sz="1450" dirty="0">
+              <a:buNone/>
+            </a:pPr>
+            <a:r>
+              <a:rPr lang="en-US" sz="1400" dirty="0">
                 <a:solidFill>
                   <a:srgbClr val="1A1A1A"/>
                 </a:solidFill>
@@ -4210,27 +4188,25 @@
                 <a:ea typeface="Calibri" pitchFamily="34" charset="-122"/>
                 <a:cs typeface="Calibri" pitchFamily="34" charset="-120"/>
               </a:rPr>
-              <a:t>A complete investigation by the first break, before any theory.</a:t>
-            </a:r>
-            <a:endParaRPr lang="en-US" sz="1450" dirty="0"/>
-          </a:p>
-        </p:txBody>
-      </p:sp>
-      <p:sp>
-        <p:nvSpPr>
-          <p:cNvPr id="12" name="Shape 10"/>
-          <p:cNvSpPr/>
-          <p:nvPr/>
-        </p:nvSpPr>
-        <p:spPr>
-          <a:xfrm>
-            <a:off x="640080" y="4983480"/>
-            <a:ext cx="457200" cy="457200"/>
-          </a:xfrm>
-          <a:prstGeom prst="roundRect">
-            <a:avLst>
-              <a:gd name="adj" fmla="val 16000"/>
-            </a:avLst>
+              <a:t>Robin Sloan, Writing with the machine</a:t>
+            </a:r>
+            <a:endParaRPr lang="en-US" sz="1400" dirty="0"/>
+          </a:p>
+        </p:txBody>
+      </p:sp>
+      <p:sp>
+        <p:nvSpPr>
+          <p:cNvPr id="9" name="Shape 7"/>
+          <p:cNvSpPr/>
+          <p:nvPr/>
+        </p:nvSpPr>
+        <p:spPr>
+          <a:xfrm>
+            <a:off x="640080" y="3593592"/>
+            <a:ext cx="219456" cy="219456"/>
+          </a:xfrm>
+          <a:prstGeom prst="ellipse">
+            <a:avLst/>
           </a:prstGeom>
           <a:solidFill>
             <a:srgbClr val="B9852F"/>
@@ -4240,14 +4216,14 @@
       </p:sp>
       <p:sp>
         <p:nvSpPr>
-          <p:cNvPr id="13" name="Text 11"/>
-          <p:cNvSpPr/>
-          <p:nvPr/>
-        </p:nvSpPr>
-        <p:spPr>
-          <a:xfrm>
-            <a:off x="640080" y="4983480"/>
-            <a:ext cx="457200" cy="457200"/>
+          <p:cNvPr id="10" name="Text 8"/>
+          <p:cNvSpPr/>
+          <p:nvPr/>
+        </p:nvSpPr>
+        <p:spPr>
+          <a:xfrm>
+            <a:off x="1051560" y="3520440"/>
+            <a:ext cx="10424160" cy="365760"/>
           </a:xfrm>
           <a:prstGeom prst="rect">
             <a:avLst/>
@@ -4259,73 +4235,34 @@
           <a:bodyPr wrap="square" rtlCol="0" anchor="ctr"/>
           <a:lstStyle/>
           <a:p>
-            <a:pPr algn="ctr" indent="0" marL="0">
-              <a:buNone/>
-            </a:pPr>
-            <a:r>
-              <a:rPr lang="en-US" sz="2000" b="1" dirty="0">
-                <a:solidFill>
-                  <a:srgbClr val="FFFFFF"/>
-                </a:solidFill>
-                <a:latin typeface="Cambria" pitchFamily="34" charset="0"/>
-                <a:ea typeface="Cambria" pitchFamily="34" charset="-122"/>
-                <a:cs typeface="Cambria" pitchFamily="34" charset="-120"/>
-              </a:rPr>
-              <a:t>3</a:t>
-            </a:r>
-            <a:endParaRPr lang="en-US" sz="2000" dirty="0"/>
-          </a:p>
-        </p:txBody>
-      </p:sp>
-      <p:sp>
-        <p:nvSpPr>
-          <p:cNvPr id="14" name="Text 12"/>
-          <p:cNvSpPr/>
-          <p:nvPr/>
-        </p:nvSpPr>
-        <p:spPr>
-          <a:xfrm>
-            <a:off x="1371600" y="4946904"/>
-            <a:ext cx="10332720" cy="411480"/>
-          </a:xfrm>
-          <a:prstGeom prst="rect">
-            <a:avLst/>
-          </a:prstGeom>
-          <a:noFill/>
-          <a:ln/>
-        </p:spPr>
-        <p:txBody>
-          <a:bodyPr wrap="square" rtlCol="0" anchor="ctr"/>
-          <a:lstStyle/>
-          <a:p>
-            <a:pPr indent="0" marL="0">
-              <a:buNone/>
-            </a:pPr>
-            <a:r>
-              <a:rPr lang="en-US" sz="1900" b="1" dirty="0">
+            <a:pPr indent="0" marL="0">
+              <a:buNone/>
+            </a:pPr>
+            <a:r>
+              <a:rPr lang="en-US" sz="1500" b="1" dirty="0">
                 <a:solidFill>
                   <a:srgbClr val="B9852F"/>
                 </a:solidFill>
-                <a:latin typeface="Cambria" pitchFamily="34" charset="0"/>
-                <a:ea typeface="Cambria" pitchFamily="34" charset="-122"/>
-                <a:cs typeface="Cambria" pitchFamily="34" charset="-120"/>
-              </a:rPr>
-              <a:t>Images are culture too</a:t>
-            </a:r>
-            <a:endParaRPr lang="en-US" sz="1900" dirty="0"/>
-          </a:p>
-        </p:txBody>
-      </p:sp>
-      <p:sp>
-        <p:nvSpPr>
-          <p:cNvPr id="15" name="Text 13"/>
-          <p:cNvSpPr/>
-          <p:nvPr/>
-        </p:nvSpPr>
-        <p:spPr>
-          <a:xfrm>
-            <a:off x="1371600" y="5367528"/>
-            <a:ext cx="10332720" cy="914400"/>
+                <a:latin typeface="Calibri" pitchFamily="34" charset="0"/>
+                <a:ea typeface="Calibri" pitchFamily="34" charset="-122"/>
+                <a:cs typeface="Calibri" pitchFamily="34" charset="-120"/>
+              </a:rPr>
+              <a:t>Deeper (optional)</a:t>
+            </a:r>
+            <a:endParaRPr lang="en-US" sz="1500" dirty="0"/>
+          </a:p>
+        </p:txBody>
+      </p:sp>
+      <p:sp>
+        <p:nvSpPr>
+          <p:cNvPr id="11" name="Text 9"/>
+          <p:cNvSpPr/>
+          <p:nvPr/>
+        </p:nvSpPr>
+        <p:spPr>
+          <a:xfrm>
+            <a:off x="1051560" y="3904488"/>
+            <a:ext cx="10424160" cy="731520"/>
           </a:xfrm>
           <a:prstGeom prst="rect">
             <a:avLst/>
@@ -4340,13 +4277,10 @@
           <a:lstStyle/>
           <a:p>
             <a:pPr indent="0" marL="0">
-              <a:lnSpc>
-                <a:spcPct val="112000"/>
-              </a:lnSpc>
-              <a:buNone/>
-            </a:pPr>
-            <a:r>
-              <a:rPr lang="en-US" sz="1450" dirty="0">
+              <a:buNone/>
+            </a:pPr>
+            <a:r>
+              <a:rPr lang="en-US" sz="1400" dirty="0">
                 <a:solidFill>
                   <a:srgbClr val="1A1A1A"/>
                 </a:solidFill>
@@ -4354,9 +4288,209 @@
                 <a:ea typeface="Calibri" pitchFamily="34" charset="-122"/>
                 <a:cs typeface="Calibri" pitchFamily="34" charset="-120"/>
               </a:rPr>
-              <a:t>A picture is numbers: you counted pixels on day one, and images continue as a co-equal corpus through all ten weeks.</a:t>
-            </a:r>
-            <a:endParaRPr lang="en-US" sz="1450" dirty="0"/>
+              <a:t>Moretti, Conjectures on World Literature (NLR 2000), the founding argument for reading culture at scale</a:t>
+            </a:r>
+            <a:endParaRPr lang="en-US" sz="1400" dirty="0"/>
+          </a:p>
+        </p:txBody>
+      </p:sp>
+      <p:sp>
+        <p:nvSpPr>
+          <p:cNvPr id="12" name="Shape 10"/>
+          <p:cNvSpPr/>
+          <p:nvPr/>
+        </p:nvSpPr>
+        <p:spPr>
+          <a:xfrm>
+            <a:off x="640080" y="4553712"/>
+            <a:ext cx="219456" cy="219456"/>
+          </a:xfrm>
+          <a:prstGeom prst="ellipse">
+            <a:avLst/>
+          </a:prstGeom>
+          <a:solidFill>
+            <a:srgbClr val="3F6F5F"/>
+          </a:solidFill>
+          <a:ln/>
+        </p:spPr>
+      </p:sp>
+      <p:sp>
+        <p:nvSpPr>
+          <p:cNvPr id="13" name="Text 11"/>
+          <p:cNvSpPr/>
+          <p:nvPr/>
+        </p:nvSpPr>
+        <p:spPr>
+          <a:xfrm>
+            <a:off x="1051560" y="4480560"/>
+            <a:ext cx="10424160" cy="365760"/>
+          </a:xfrm>
+          <a:prstGeom prst="rect">
+            <a:avLst/>
+          </a:prstGeom>
+          <a:noFill/>
+          <a:ln/>
+        </p:spPr>
+        <p:txBody>
+          <a:bodyPr wrap="square" rtlCol="0" anchor="ctr"/>
+          <a:lstStyle/>
+          <a:p>
+            <a:pPr indent="0" marL="0">
+              <a:buNone/>
+            </a:pPr>
+            <a:r>
+              <a:rPr lang="en-US" sz="1500" b="1" dirty="0">
+                <a:solidFill>
+                  <a:srgbClr val="3F6F5F"/>
+                </a:solidFill>
+                <a:latin typeface="Calibri" pitchFamily="34" charset="0"/>
+                <a:ea typeface="Calibri" pitchFamily="34" charset="-122"/>
+                <a:cs typeface="Calibri" pitchFamily="34" charset="-120"/>
+              </a:rPr>
+              <a:t>Sketch</a:t>
+            </a:r>
+            <a:endParaRPr lang="en-US" sz="1500" dirty="0"/>
+          </a:p>
+        </p:txBody>
+      </p:sp>
+      <p:sp>
+        <p:nvSpPr>
+          <p:cNvPr id="14" name="Text 12"/>
+          <p:cNvSpPr/>
+          <p:nvPr/>
+        </p:nvSpPr>
+        <p:spPr>
+          <a:xfrm>
+            <a:off x="1051560" y="4864608"/>
+            <a:ext cx="10424160" cy="731520"/>
+          </a:xfrm>
+          <a:prstGeom prst="rect">
+            <a:avLst/>
+          </a:prstGeom>
+          <a:noFill/>
+          <a:ln/>
+        </p:spPr>
+        <p:txBody>
+          <a:bodyPr wrap="square" rtlCol="0" anchor="t">
+            <a:spAutoFit/>
+          </a:bodyPr>
+          <a:lstStyle/>
+          <a:p>
+            <a:pPr indent="0" marL="0">
+              <a:buNone/>
+            </a:pPr>
+            <a:r>
+              <a:rPr lang="en-US" sz="1400" dirty="0">
+                <a:solidFill>
+                  <a:srgbClr val="1A1A1A"/>
+                </a:solidFill>
+                <a:latin typeface="Calibri" pitchFamily="34" charset="0"/>
+                <a:ea typeface="Calibri" pitchFamily="34" charset="-122"/>
+                <a:cs typeface="Calibri" pitchFamily="34" charset="-120"/>
+              </a:rPr>
+              <a:t>One question from your life answerable with text or image data; three sentences.</a:t>
+            </a:r>
+            <a:endParaRPr lang="en-US" sz="1400" dirty="0"/>
+          </a:p>
+        </p:txBody>
+      </p:sp>
+      <p:sp>
+        <p:nvSpPr>
+          <p:cNvPr id="15" name="Shape 13"/>
+          <p:cNvSpPr/>
+          <p:nvPr/>
+        </p:nvSpPr>
+        <p:spPr>
+          <a:xfrm>
+            <a:off x="640080" y="5513832"/>
+            <a:ext cx="219456" cy="219456"/>
+          </a:xfrm>
+          <a:prstGeom prst="ellipse">
+            <a:avLst/>
+          </a:prstGeom>
+          <a:solidFill>
+            <a:srgbClr val="7A3B2E"/>
+          </a:solidFill>
+          <a:ln/>
+        </p:spPr>
+      </p:sp>
+      <p:sp>
+        <p:nvSpPr>
+          <p:cNvPr id="16" name="Text 14"/>
+          <p:cNvSpPr/>
+          <p:nvPr/>
+        </p:nvSpPr>
+        <p:spPr>
+          <a:xfrm>
+            <a:off x="1051560" y="5440680"/>
+            <a:ext cx="10424160" cy="365760"/>
+          </a:xfrm>
+          <a:prstGeom prst="rect">
+            <a:avLst/>
+          </a:prstGeom>
+          <a:noFill/>
+          <a:ln/>
+        </p:spPr>
+        <p:txBody>
+          <a:bodyPr wrap="square" rtlCol="0" anchor="ctr"/>
+          <a:lstStyle/>
+          <a:p>
+            <a:pPr indent="0" marL="0">
+              <a:buNone/>
+            </a:pPr>
+            <a:r>
+              <a:rPr lang="en-US" sz="1500" b="1" dirty="0">
+                <a:solidFill>
+                  <a:srgbClr val="7A3B2E"/>
+                </a:solidFill>
+                <a:latin typeface="Calibri" pitchFamily="34" charset="0"/>
+                <a:ea typeface="Calibri" pitchFamily="34" charset="-122"/>
+                <a:cs typeface="Calibri" pitchFamily="34" charset="-120"/>
+              </a:rPr>
+              <a:t>Check (AI closed)</a:t>
+            </a:r>
+            <a:endParaRPr lang="en-US" sz="1500" dirty="0"/>
+          </a:p>
+        </p:txBody>
+      </p:sp>
+      <p:sp>
+        <p:nvSpPr>
+          <p:cNvPr id="17" name="Text 15"/>
+          <p:cNvSpPr/>
+          <p:nvPr/>
+        </p:nvSpPr>
+        <p:spPr>
+          <a:xfrm>
+            <a:off x="1051560" y="5824728"/>
+            <a:ext cx="10424160" cy="731520"/>
+          </a:xfrm>
+          <a:prstGeom prst="rect">
+            <a:avLst/>
+          </a:prstGeom>
+          <a:noFill/>
+          <a:ln/>
+        </p:spPr>
+        <p:txBody>
+          <a:bodyPr wrap="square" rtlCol="0" anchor="t">
+            <a:spAutoFit/>
+          </a:bodyPr>
+          <a:lstStyle/>
+          <a:p>
+            <a:pPr indent="0" marL="0">
+              <a:buNone/>
+            </a:pPr>
+            <a:r>
+              <a:rPr lang="en-US" sz="1400" dirty="0">
+                <a:solidFill>
+                  <a:srgbClr val="1A1A1A"/>
+                </a:solidFill>
+                <a:latin typeface="Calibri" pitchFamily="34" charset="0"/>
+                <a:ea typeface="Calibri" pitchFamily="34" charset="-122"/>
+                <a:cs typeface="Calibri" pitchFamily="34" charset="-120"/>
+              </a:rPr>
+              <a:t>Trace it: one written sentence predicting what your cell does before you run it. (Competency 1.)</a:t>
+            </a:r>
+            <a:endParaRPr lang="en-US" sz="1400" dirty="0"/>
           </a:p>
         </p:txBody>
       </p:sp>
@@ -4371,6 +4505,548 @@
 <file path=ppt/slides/slide13.xml><?xml version="1.0" encoding="utf-8"?>
 <p:sld xmlns:a="http://schemas.openxmlformats.org/drawingml/2006/main" xmlns:r="http://schemas.openxmlformats.org/officeDocument/2006/relationships" xmlns:p="http://schemas.openxmlformats.org/presentationml/2006/main">
   <p:cSld name="Slide 13">
+    <p:bg>
+      <p:bgPr>
+        <a:solidFill>
+          <a:srgbClr val="FFFFFF"/>
+        </a:solidFill>
+      </p:bgPr>
+    </p:bg>
+    <p:spTree>
+      <p:nvGrpSpPr>
+        <p:cNvPr id="1" name=""/>
+        <p:cNvGrpSpPr/>
+        <p:nvPr/>
+      </p:nvGrpSpPr>
+      <p:grpSpPr>
+        <a:xfrm>
+          <a:off x="0" y="0"/>
+          <a:ext cx="0" cy="0"/>
+          <a:chOff x="0" y="0"/>
+          <a:chExt cx="0" cy="0"/>
+        </a:xfrm>
+      </p:grpSpPr>
+      <p:sp>
+        <p:nvSpPr>
+          <p:cNvPr id="2" name="Text 0"/>
+          <p:cNvSpPr/>
+          <p:nvPr/>
+        </p:nvSpPr>
+        <p:spPr>
+          <a:xfrm>
+            <a:off x="640080" y="640080"/>
+            <a:ext cx="10058400" cy="320040"/>
+          </a:xfrm>
+          <a:prstGeom prst="rect">
+            <a:avLst/>
+          </a:prstGeom>
+          <a:noFill/>
+          <a:ln/>
+        </p:spPr>
+        <p:txBody>
+          <a:bodyPr wrap="square" rtlCol="0" anchor="ctr"/>
+          <a:lstStyle/>
+          <a:p>
+            <a:pPr indent="0" marL="0">
+              <a:buNone/>
+            </a:pPr>
+            <a:r>
+              <a:rPr lang="en-US" sz="1300" b="1" spc="300" kern="0" dirty="0">
+                <a:solidFill>
+                  <a:srgbClr val="7A3B2E"/>
+                </a:solidFill>
+                <a:latin typeface="Calibri" pitchFamily="34" charset="0"/>
+                <a:ea typeface="Calibri" pitchFamily="34" charset="-122"/>
+                <a:cs typeface="Calibri" pitchFamily="34" charset="-120"/>
+              </a:rPr>
+              <a:t>HOW THIS WEEK CONNECTS</a:t>
+            </a:r>
+            <a:endParaRPr lang="en-US" sz="1300" dirty="0"/>
+          </a:p>
+        </p:txBody>
+      </p:sp>
+      <p:sp>
+        <p:nvSpPr>
+          <p:cNvPr id="3" name="Text 1"/>
+          <p:cNvSpPr/>
+          <p:nvPr/>
+        </p:nvSpPr>
+        <p:spPr>
+          <a:xfrm>
+            <a:off x="640080" y="987552"/>
+            <a:ext cx="10058400" cy="640080"/>
+          </a:xfrm>
+          <a:prstGeom prst="rect">
+            <a:avLst/>
+          </a:prstGeom>
+          <a:noFill/>
+          <a:ln/>
+        </p:spPr>
+        <p:txBody>
+          <a:bodyPr wrap="square" rtlCol="0" anchor="ctr"/>
+          <a:lstStyle/>
+          <a:p>
+            <a:pPr indent="0" marL="0">
+              <a:buNone/>
+            </a:pPr>
+            <a:r>
+              <a:rPr lang="en-US" sz="2800" b="1" dirty="0">
+                <a:solidFill>
+                  <a:srgbClr val="1A1A1A"/>
+                </a:solidFill>
+                <a:latin typeface="Cambria" pitchFamily="34" charset="0"/>
+                <a:ea typeface="Cambria" pitchFamily="34" charset="-122"/>
+                <a:cs typeface="Cambria" pitchFamily="34" charset="-120"/>
+              </a:rPr>
+              <a:t>The course's through-lines</a:t>
+            </a:r>
+            <a:endParaRPr lang="en-US" sz="2800" dirty="0"/>
+          </a:p>
+        </p:txBody>
+      </p:sp>
+      <p:sp>
+        <p:nvSpPr>
+          <p:cNvPr id="4" name="Shape 2"/>
+          <p:cNvSpPr/>
+          <p:nvPr/>
+        </p:nvSpPr>
+        <p:spPr>
+          <a:xfrm>
+            <a:off x="640080" y="2057400"/>
+            <a:ext cx="457200" cy="457200"/>
+          </a:xfrm>
+          <a:prstGeom prst="roundRect">
+            <a:avLst>
+              <a:gd name="adj" fmla="val 16000"/>
+            </a:avLst>
+          </a:prstGeom>
+          <a:solidFill>
+            <a:srgbClr val="7A3B2E"/>
+          </a:solidFill>
+          <a:ln/>
+        </p:spPr>
+      </p:sp>
+      <p:sp>
+        <p:nvSpPr>
+          <p:cNvPr id="5" name="Text 3"/>
+          <p:cNvSpPr/>
+          <p:nvPr/>
+        </p:nvSpPr>
+        <p:spPr>
+          <a:xfrm>
+            <a:off x="640080" y="2057400"/>
+            <a:ext cx="457200" cy="457200"/>
+          </a:xfrm>
+          <a:prstGeom prst="rect">
+            <a:avLst/>
+          </a:prstGeom>
+          <a:noFill/>
+          <a:ln/>
+        </p:spPr>
+        <p:txBody>
+          <a:bodyPr wrap="square" rtlCol="0" anchor="ctr"/>
+          <a:lstStyle/>
+          <a:p>
+            <a:pPr algn="ctr" indent="0" marL="0">
+              <a:buNone/>
+            </a:pPr>
+            <a:r>
+              <a:rPr lang="en-US" sz="2000" b="1" dirty="0">
+                <a:solidFill>
+                  <a:srgbClr val="FFFFFF"/>
+                </a:solidFill>
+                <a:latin typeface="Cambria" pitchFamily="34" charset="0"/>
+                <a:ea typeface="Cambria" pitchFamily="34" charset="-122"/>
+                <a:cs typeface="Cambria" pitchFamily="34" charset="-120"/>
+              </a:rPr>
+              <a:t>1</a:t>
+            </a:r>
+            <a:endParaRPr lang="en-US" sz="2000" dirty="0"/>
+          </a:p>
+        </p:txBody>
+      </p:sp>
+      <p:sp>
+        <p:nvSpPr>
+          <p:cNvPr id="6" name="Text 4"/>
+          <p:cNvSpPr/>
+          <p:nvPr/>
+        </p:nvSpPr>
+        <p:spPr>
+          <a:xfrm>
+            <a:off x="1371600" y="2020824"/>
+            <a:ext cx="10332720" cy="411480"/>
+          </a:xfrm>
+          <a:prstGeom prst="rect">
+            <a:avLst/>
+          </a:prstGeom>
+          <a:noFill/>
+          <a:ln/>
+        </p:spPr>
+        <p:txBody>
+          <a:bodyPr wrap="square" rtlCol="0" anchor="ctr"/>
+          <a:lstStyle/>
+          <a:p>
+            <a:pPr indent="0" marL="0">
+              <a:buNone/>
+            </a:pPr>
+            <a:r>
+              <a:rPr lang="en-US" sz="1900" b="1" dirty="0">
+                <a:solidFill>
+                  <a:srgbClr val="7A3B2E"/>
+                </a:solidFill>
+                <a:latin typeface="Cambria" pitchFamily="34" charset="0"/>
+                <a:ea typeface="Cambria" pitchFamily="34" charset="-122"/>
+                <a:cs typeface="Cambria" pitchFamily="34" charset="-120"/>
+              </a:rPr>
+              <a:t>Read work critically</a:t>
+            </a:r>
+            <a:endParaRPr lang="en-US" sz="1900" dirty="0"/>
+          </a:p>
+        </p:txBody>
+      </p:sp>
+      <p:sp>
+        <p:nvSpPr>
+          <p:cNvPr id="7" name="Text 5"/>
+          <p:cNvSpPr/>
+          <p:nvPr/>
+        </p:nvSpPr>
+        <p:spPr>
+          <a:xfrm>
+            <a:off x="1371600" y="2441448"/>
+            <a:ext cx="10332720" cy="914400"/>
+          </a:xfrm>
+          <a:prstGeom prst="rect">
+            <a:avLst/>
+          </a:prstGeom>
+          <a:noFill/>
+          <a:ln/>
+        </p:spPr>
+        <p:txBody>
+          <a:bodyPr wrap="square" rtlCol="0" anchor="t">
+            <a:spAutoFit/>
+          </a:bodyPr>
+          <a:lstStyle/>
+          <a:p>
+            <a:pPr indent="0" marL="0">
+              <a:lnSpc>
+                <a:spcPct val="112000"/>
+              </a:lnSpc>
+              <a:buNone/>
+            </a:pPr>
+            <a:r>
+              <a:rPr lang="en-US" sz="1450" dirty="0">
+                <a:solidFill>
+                  <a:srgbClr val="1A1A1A"/>
+                </a:solidFill>
+                <a:latin typeface="Calibri" pitchFamily="34" charset="0"/>
+                <a:ea typeface="Calibri" pitchFamily="34" charset="-122"/>
+                <a:cs typeface="Calibri" pitchFamily="34" charset="-120"/>
+              </a:rPr>
+              <a:t>She Giggles, He Gallops is excellent and its choices are debatable. Admiring and questioning at once is the habit the course is built on.</a:t>
+            </a:r>
+            <a:endParaRPr lang="en-US" sz="1450" dirty="0"/>
+          </a:p>
+        </p:txBody>
+      </p:sp>
+      <p:sp>
+        <p:nvSpPr>
+          <p:cNvPr id="8" name="Shape 6"/>
+          <p:cNvSpPr/>
+          <p:nvPr/>
+        </p:nvSpPr>
+        <p:spPr>
+          <a:xfrm>
+            <a:off x="640080" y="3520440"/>
+            <a:ext cx="457200" cy="457200"/>
+          </a:xfrm>
+          <a:prstGeom prst="roundRect">
+            <a:avLst>
+              <a:gd name="adj" fmla="val 16000"/>
+            </a:avLst>
+          </a:prstGeom>
+          <a:solidFill>
+            <a:srgbClr val="3F6F5F"/>
+          </a:solidFill>
+          <a:ln/>
+        </p:spPr>
+      </p:sp>
+      <p:sp>
+        <p:nvSpPr>
+          <p:cNvPr id="9" name="Text 7"/>
+          <p:cNvSpPr/>
+          <p:nvPr/>
+        </p:nvSpPr>
+        <p:spPr>
+          <a:xfrm>
+            <a:off x="640080" y="3520440"/>
+            <a:ext cx="457200" cy="457200"/>
+          </a:xfrm>
+          <a:prstGeom prst="rect">
+            <a:avLst/>
+          </a:prstGeom>
+          <a:noFill/>
+          <a:ln/>
+        </p:spPr>
+        <p:txBody>
+          <a:bodyPr wrap="square" rtlCol="0" anchor="ctr"/>
+          <a:lstStyle/>
+          <a:p>
+            <a:pPr algn="ctr" indent="0" marL="0">
+              <a:buNone/>
+            </a:pPr>
+            <a:r>
+              <a:rPr lang="en-US" sz="2000" b="1" dirty="0">
+                <a:solidFill>
+                  <a:srgbClr val="FFFFFF"/>
+                </a:solidFill>
+                <a:latin typeface="Cambria" pitchFamily="34" charset="0"/>
+                <a:ea typeface="Cambria" pitchFamily="34" charset="-122"/>
+                <a:cs typeface="Cambria" pitchFamily="34" charset="-120"/>
+              </a:rPr>
+              <a:t>2</a:t>
+            </a:r>
+            <a:endParaRPr lang="en-US" sz="2000" dirty="0"/>
+          </a:p>
+        </p:txBody>
+      </p:sp>
+      <p:sp>
+        <p:nvSpPr>
+          <p:cNvPr id="10" name="Text 8"/>
+          <p:cNvSpPr/>
+          <p:nvPr/>
+        </p:nvSpPr>
+        <p:spPr>
+          <a:xfrm>
+            <a:off x="1371600" y="3483864"/>
+            <a:ext cx="10332720" cy="411480"/>
+          </a:xfrm>
+          <a:prstGeom prst="rect">
+            <a:avLst/>
+          </a:prstGeom>
+          <a:noFill/>
+          <a:ln/>
+        </p:spPr>
+        <p:txBody>
+          <a:bodyPr wrap="square" rtlCol="0" anchor="ctr"/>
+          <a:lstStyle/>
+          <a:p>
+            <a:pPr indent="0" marL="0">
+              <a:buNone/>
+            </a:pPr>
+            <a:r>
+              <a:rPr lang="en-US" sz="1900" b="1" dirty="0">
+                <a:solidFill>
+                  <a:srgbClr val="3F6F5F"/>
+                </a:solidFill>
+                <a:latin typeface="Cambria" pitchFamily="34" charset="0"/>
+                <a:ea typeface="Cambria" pitchFamily="34" charset="-122"/>
+                <a:cs typeface="Cambria" pitchFamily="34" charset="-120"/>
+              </a:rPr>
+              <a:t>Make something real</a:t>
+            </a:r>
+            <a:endParaRPr lang="en-US" sz="1900" dirty="0"/>
+          </a:p>
+        </p:txBody>
+      </p:sp>
+      <p:sp>
+        <p:nvSpPr>
+          <p:cNvPr id="11" name="Text 9"/>
+          <p:cNvSpPr/>
+          <p:nvPr/>
+        </p:nvSpPr>
+        <p:spPr>
+          <a:xfrm>
+            <a:off x="1371600" y="3904488"/>
+            <a:ext cx="10332720" cy="914400"/>
+          </a:xfrm>
+          <a:prstGeom prst="rect">
+            <a:avLst/>
+          </a:prstGeom>
+          <a:noFill/>
+          <a:ln/>
+        </p:spPr>
+        <p:txBody>
+          <a:bodyPr wrap="square" rtlCol="0" anchor="t">
+            <a:spAutoFit/>
+          </a:bodyPr>
+          <a:lstStyle/>
+          <a:p>
+            <a:pPr indent="0" marL="0">
+              <a:lnSpc>
+                <a:spcPct val="112000"/>
+              </a:lnSpc>
+              <a:buNone/>
+            </a:pPr>
+            <a:r>
+              <a:rPr lang="en-US" sz="1450" dirty="0">
+                <a:solidFill>
+                  <a:srgbClr val="1A1A1A"/>
+                </a:solidFill>
+                <a:latin typeface="Calibri" pitchFamily="34" charset="0"/>
+                <a:ea typeface="Calibri" pitchFamily="34" charset="-122"/>
+                <a:cs typeface="Calibri" pitchFamily="34" charset="-120"/>
+              </a:rPr>
+              <a:t>A complete investigation by the first break, before any theory.</a:t>
+            </a:r>
+            <a:endParaRPr lang="en-US" sz="1450" dirty="0"/>
+          </a:p>
+        </p:txBody>
+      </p:sp>
+      <p:sp>
+        <p:nvSpPr>
+          <p:cNvPr id="12" name="Shape 10"/>
+          <p:cNvSpPr/>
+          <p:nvPr/>
+        </p:nvSpPr>
+        <p:spPr>
+          <a:xfrm>
+            <a:off x="640080" y="4983480"/>
+            <a:ext cx="457200" cy="457200"/>
+          </a:xfrm>
+          <a:prstGeom prst="roundRect">
+            <a:avLst>
+              <a:gd name="adj" fmla="val 16000"/>
+            </a:avLst>
+          </a:prstGeom>
+          <a:solidFill>
+            <a:srgbClr val="B9852F"/>
+          </a:solidFill>
+          <a:ln/>
+        </p:spPr>
+      </p:sp>
+      <p:sp>
+        <p:nvSpPr>
+          <p:cNvPr id="13" name="Text 11"/>
+          <p:cNvSpPr/>
+          <p:nvPr/>
+        </p:nvSpPr>
+        <p:spPr>
+          <a:xfrm>
+            <a:off x="640080" y="4983480"/>
+            <a:ext cx="457200" cy="457200"/>
+          </a:xfrm>
+          <a:prstGeom prst="rect">
+            <a:avLst/>
+          </a:prstGeom>
+          <a:noFill/>
+          <a:ln/>
+        </p:spPr>
+        <p:txBody>
+          <a:bodyPr wrap="square" rtlCol="0" anchor="ctr"/>
+          <a:lstStyle/>
+          <a:p>
+            <a:pPr algn="ctr" indent="0" marL="0">
+              <a:buNone/>
+            </a:pPr>
+            <a:r>
+              <a:rPr lang="en-US" sz="2000" b="1" dirty="0">
+                <a:solidFill>
+                  <a:srgbClr val="FFFFFF"/>
+                </a:solidFill>
+                <a:latin typeface="Cambria" pitchFamily="34" charset="0"/>
+                <a:ea typeface="Cambria" pitchFamily="34" charset="-122"/>
+                <a:cs typeface="Cambria" pitchFamily="34" charset="-120"/>
+              </a:rPr>
+              <a:t>3</a:t>
+            </a:r>
+            <a:endParaRPr lang="en-US" sz="2000" dirty="0"/>
+          </a:p>
+        </p:txBody>
+      </p:sp>
+      <p:sp>
+        <p:nvSpPr>
+          <p:cNvPr id="14" name="Text 12"/>
+          <p:cNvSpPr/>
+          <p:nvPr/>
+        </p:nvSpPr>
+        <p:spPr>
+          <a:xfrm>
+            <a:off x="1371600" y="4946904"/>
+            <a:ext cx="10332720" cy="411480"/>
+          </a:xfrm>
+          <a:prstGeom prst="rect">
+            <a:avLst/>
+          </a:prstGeom>
+          <a:noFill/>
+          <a:ln/>
+        </p:spPr>
+        <p:txBody>
+          <a:bodyPr wrap="square" rtlCol="0" anchor="ctr"/>
+          <a:lstStyle/>
+          <a:p>
+            <a:pPr indent="0" marL="0">
+              <a:buNone/>
+            </a:pPr>
+            <a:r>
+              <a:rPr lang="en-US" sz="1900" b="1" dirty="0">
+                <a:solidFill>
+                  <a:srgbClr val="B9852F"/>
+                </a:solidFill>
+                <a:latin typeface="Cambria" pitchFamily="34" charset="0"/>
+                <a:ea typeface="Cambria" pitchFamily="34" charset="-122"/>
+                <a:cs typeface="Cambria" pitchFamily="34" charset="-120"/>
+              </a:rPr>
+              <a:t>Images are culture too</a:t>
+            </a:r>
+            <a:endParaRPr lang="en-US" sz="1900" dirty="0"/>
+          </a:p>
+        </p:txBody>
+      </p:sp>
+      <p:sp>
+        <p:nvSpPr>
+          <p:cNvPr id="15" name="Text 13"/>
+          <p:cNvSpPr/>
+          <p:nvPr/>
+        </p:nvSpPr>
+        <p:spPr>
+          <a:xfrm>
+            <a:off x="1371600" y="5367528"/>
+            <a:ext cx="10332720" cy="914400"/>
+          </a:xfrm>
+          <a:prstGeom prst="rect">
+            <a:avLst/>
+          </a:prstGeom>
+          <a:noFill/>
+          <a:ln/>
+        </p:spPr>
+        <p:txBody>
+          <a:bodyPr wrap="square" rtlCol="0" anchor="t">
+            <a:spAutoFit/>
+          </a:bodyPr>
+          <a:lstStyle/>
+          <a:p>
+            <a:pPr indent="0" marL="0">
+              <a:lnSpc>
+                <a:spcPct val="112000"/>
+              </a:lnSpc>
+              <a:buNone/>
+            </a:pPr>
+            <a:r>
+              <a:rPr lang="en-US" sz="1450" dirty="0">
+                <a:solidFill>
+                  <a:srgbClr val="1A1A1A"/>
+                </a:solidFill>
+                <a:latin typeface="Calibri" pitchFamily="34" charset="0"/>
+                <a:ea typeface="Calibri" pitchFamily="34" charset="-122"/>
+                <a:cs typeface="Calibri" pitchFamily="34" charset="-120"/>
+              </a:rPr>
+              <a:t>A picture is numbers: you counted pixels on day one, and images continue as a co-equal corpus through all ten weeks.</a:t>
+            </a:r>
+            <a:endParaRPr lang="en-US" sz="1450" dirty="0"/>
+          </a:p>
+        </p:txBody>
+      </p:sp>
+    </p:spTree>
+  </p:cSld>
+  <p:clrMapOvr>
+    <a:masterClrMapping/>
+  </p:clrMapOvr>
+</p:sld>
+</file>
+
+<file path=ppt/slides/slide14.xml><?xml version="1.0" encoding="utf-8"?>
+<p:sld xmlns:a="http://schemas.openxmlformats.org/drawingml/2006/main" xmlns:r="http://schemas.openxmlformats.org/officeDocument/2006/relationships" xmlns:p="http://schemas.openxmlformats.org/presentationml/2006/main">
+  <p:cSld name="Slide 14">
     <p:bg>
       <p:bgPr>
         <a:solidFill>
@@ -5330,7 +6006,7 @@
                 <a:ea typeface="Cambria" pitchFamily="34" charset="-122"/>
                 <a:cs typeface="Cambria" pitchFamily="34" charset="-120"/>
               </a:rPr>
-              <a:t>Culture is already data</a:t>
+              <a:t>Why this course: the stakes</a:t>
             </a:r>
             <a:endParaRPr lang="en-US" sz="3000" dirty="0"/>
           </a:p>
@@ -5394,7 +6070,7 @@
                 <a:ea typeface="Calibri" pitchFamily="34" charset="-122"/>
                 <a:cs typeface="Calibri" pitchFamily="34" charset="-120"/>
               </a:rPr>
-              <a:t>Spotify counts your listening; the For You feed is a model reading culture at scale; you are on the receiving end every day.</a:t>
+              <a:t>Machines already read culture at scale: the feed ranking what you see, the moderation filter, the model trained on scraped art and prose. That reading shapes which culture reaches you, and it happens without you.</a:t>
             </a:r>
             <a:endParaRPr lang="en-US" sz="1650" dirty="0"/>
           </a:p>
@@ -5458,7 +6134,7 @@
                 <a:ea typeface="Calibri" pitchFamily="34" charset="-122"/>
                 <a:cs typeface="Calibri" pitchFamily="34" charset="-120"/>
               </a:rPr>
-              <a:t>In ten weeks you run the same kind of reading yourself, on culture you choose.</a:t>
+              <a:t>Reading culture with machines produces real knowledge and real mistakes, and the two look identical until someone checks. Learning to check is the course.</a:t>
             </a:r>
             <a:endParaRPr lang="en-US" sz="1650" dirty="0"/>
           </a:p>
@@ -5522,7 +6198,7 @@
                 <a:ea typeface="Calibri" pitchFamily="34" charset="-122"/>
                 <a:cs typeface="Calibri" pitchFamily="34" charset="-120"/>
               </a:rPr>
-              <a:t>Today's corpus: 5,562 NYT wedding announcements, 1985-2014: whether the bride kept her name, and the couple's ages.</a:t>
+              <a:t>Ten weeks from now, you do the reading: a question you chose, a corpus you built, a published finding anyone can verify.</a:t>
             </a:r>
             <a:endParaRPr lang="en-US" sz="1650" dirty="0"/>
           </a:p>
@@ -5586,7 +6262,7 @@
                 <a:ea typeface="Calibri" pitchFamily="34" charset="-122"/>
                 <a:cs typeface="Calibri" pitchFamily="34" charset="-120"/>
               </a:rPr>
-              <a:t>The deliverable, shown now: a published web essay on top of a notebook anyone can run.</a:t>
+              <a:t>The whole method in one sentence: it is all counting and weighting, and you can learn to read both.</a:t>
             </a:r>
             <a:endParaRPr lang="en-US" sz="1650" dirty="0"/>
           </a:p>
@@ -5718,7 +6394,7 @@
                 <a:ea typeface="Cambria" pitchFamily="34" charset="-122"/>
                 <a:cs typeface="Cambria" pitchFamily="34" charset="-120"/>
               </a:rPr>
-              <a:t>Four words, used all term</a:t>
+              <a:t>What counting culture has found</a:t>
             </a:r>
             <a:endParaRPr lang="en-US" sz="3000" dirty="0"/>
           </a:p>
@@ -5753,7 +6429,7 @@
         <p:spPr>
           <a:xfrm>
             <a:off x="1097280" y="2240280"/>
-            <a:ext cx="10607040" cy="1017270"/>
+            <a:ext cx="10607040" cy="813816"/>
           </a:xfrm>
           <a:prstGeom prst="rect">
             <a:avLst/>
@@ -5774,7 +6450,7 @@
               <a:buNone/>
             </a:pPr>
             <a:r>
-              <a:rPr lang="en-US" sz="1650" dirty="0">
+              <a:rPr lang="en-US" sz="1500" dirty="0">
                 <a:solidFill>
                   <a:srgbClr val="1A1A1A"/>
                 </a:solidFill>
@@ -5782,9 +6458,9 @@
                 <a:ea typeface="Calibri" pitchFamily="34" charset="-122"/>
                 <a:cs typeface="Calibri" pitchFamily="34" charset="-120"/>
               </a:rPr>
-              <a:t>Corpus: the pile you study. 500 announcements, 2,000 screenplays, 10,000 album covers.</a:t>
-            </a:r>
-            <a:endParaRPr lang="en-US" sz="1650" dirty="0"/>
+              <a:t>In the stage directions of 2,000 film scripts: women snuggle, giggle, and sob; men strap, gallop, and kill. 85% of the screenwriters were men (The Pudding, 2017).</a:t>
+            </a:r>
+            <a:endParaRPr lang="en-US" sz="1500" dirty="0"/>
           </a:p>
         </p:txBody>
       </p:sp>
@@ -5796,7 +6472,7 @@
         </p:nvSpPr>
         <p:spPr>
           <a:xfrm>
-            <a:off x="640080" y="3348990"/>
+            <a:off x="640080" y="3145536"/>
             <a:ext cx="201168" cy="201168"/>
           </a:xfrm>
           <a:prstGeom prst="ellipse">
@@ -5816,8 +6492,8 @@
         </p:nvSpPr>
         <p:spPr>
           <a:xfrm>
-            <a:off x="1097280" y="3257550"/>
-            <a:ext cx="10607040" cy="1017270"/>
+            <a:off x="1097280" y="3054096"/>
+            <a:ext cx="10607040" cy="813816"/>
           </a:xfrm>
           <a:prstGeom prst="rect">
             <a:avLst/>
@@ -5838,7 +6514,7 @@
               <a:buNone/>
             </a:pPr>
             <a:r>
-              <a:rPr lang="en-US" sz="1650" dirty="0">
+              <a:rPr lang="en-US" sz="1500" dirty="0">
                 <a:solidFill>
                   <a:srgbClr val="1A1A1A"/>
                 </a:solidFill>
@@ -5846,9 +6522,9 @@
                 <a:ea typeface="Calibri" pitchFamily="34" charset="-122"/>
                 <a:cs typeface="Calibri" pitchFamily="34" charset="-120"/>
               </a:rPr>
-              <a:t>Method: the counting or weighting you run on the corpus.</a:t>
-            </a:r>
-            <a:endParaRPr lang="en-US" sz="1650" dirty="0"/>
+              <a:t>Across 17,000 Hot 100 songs, the biggest revolution in American pop was not the Beatles in 1964; it was hip-hop in 1991 (Mauch et al., 2015).</a:t>
+            </a:r>
+            <a:endParaRPr lang="en-US" sz="1500" dirty="0"/>
           </a:p>
         </p:txBody>
       </p:sp>
@@ -5860,7 +6536,7 @@
         </p:nvSpPr>
         <p:spPr>
           <a:xfrm>
-            <a:off x="640080" y="4366260"/>
+            <a:off x="640080" y="3959352"/>
             <a:ext cx="201168" cy="201168"/>
           </a:xfrm>
           <a:prstGeom prst="ellipse">
@@ -5880,8 +6556,8 @@
         </p:nvSpPr>
         <p:spPr>
           <a:xfrm>
-            <a:off x="1097280" y="4274820"/>
-            <a:ext cx="10607040" cy="1017270"/>
+            <a:off x="1097280" y="3867912"/>
+            <a:ext cx="10607040" cy="813816"/>
           </a:xfrm>
           <a:prstGeom prst="rect">
             <a:avLst/>
@@ -5902,7 +6578,7 @@
               <a:buNone/>
             </a:pPr>
             <a:r>
-              <a:rPr lang="en-US" sz="1650" dirty="0">
+              <a:rPr lang="en-US" sz="1500" dirty="0">
                 <a:solidFill>
                   <a:srgbClr val="1A1A1A"/>
                 </a:solidFill>
@@ -5910,9 +6586,9 @@
                 <a:ea typeface="Calibri" pitchFamily="34" charset="-122"/>
                 <a:cs typeface="Calibri" pitchFamily="34" charset="-120"/>
               </a:rPr>
-              <a:t>Model: any simplification that turns culture into numbers. A word count is already one.</a:t>
-            </a:r>
-            <a:endParaRPr lang="en-US" sz="1650" dirty="0"/>
+              <a:t>Counting small words like 'the' and 'of' unmasked Robert Galbraith as J.K. Rowling within days (Juola, 2013).</a:t>
+            </a:r>
+            <a:endParaRPr lang="en-US" sz="1500" dirty="0"/>
           </a:p>
         </p:txBody>
       </p:sp>
@@ -5924,7 +6600,7 @@
         </p:nvSpPr>
         <p:spPr>
           <a:xfrm>
-            <a:off x="640080" y="5383530"/>
+            <a:off x="640080" y="4773168"/>
             <a:ext cx="201168" cy="201168"/>
           </a:xfrm>
           <a:prstGeom prst="ellipse">
@@ -5944,8 +6620,8 @@
         </p:nvSpPr>
         <p:spPr>
           <a:xfrm>
-            <a:off x="1097280" y="5292090"/>
-            <a:ext cx="10607040" cy="1017270"/>
+            <a:off x="1097280" y="4681728"/>
+            <a:ext cx="10607040" cy="813816"/>
           </a:xfrm>
           <a:prstGeom prst="rect">
             <a:avLst/>
@@ -5966,7 +6642,7 @@
               <a:buNone/>
             </a:pPr>
             <a:r>
-              <a:rPr lang="en-US" sz="1650" dirty="0">
+              <a:rPr lang="en-US" sz="1500" dirty="0">
                 <a:solidFill>
                   <a:srgbClr val="1A1A1A"/>
                 </a:solidFill>
@@ -5974,9 +6650,73 @@
                 <a:ea typeface="Calibri" pitchFamily="34" charset="-122"/>
                 <a:cs typeface="Calibri" pitchFamily="34" charset="-120"/>
               </a:rPr>
-              <a:t>Embedding: a few hundred numbers that place an item on a map of meaning. Week 5.</a:t>
-            </a:r>
-            <a:endParaRPr lang="en-US" sz="1650" dirty="0"/>
+              <a:t>A model trained on Google News completes 'man is to computer programmer as woman is to...' with 'homemaker' (Bolukbasi et al., 2016).</a:t>
+            </a:r>
+            <a:endParaRPr lang="en-US" sz="1500" dirty="0"/>
+          </a:p>
+        </p:txBody>
+      </p:sp>
+      <p:sp>
+        <p:nvSpPr>
+          <p:cNvPr id="13" name="Shape 11"/>
+          <p:cNvSpPr/>
+          <p:nvPr/>
+        </p:nvSpPr>
+        <p:spPr>
+          <a:xfrm>
+            <a:off x="640080" y="5586984"/>
+            <a:ext cx="201168" cy="201168"/>
+          </a:xfrm>
+          <a:prstGeom prst="ellipse">
+            <a:avLst/>
+          </a:prstGeom>
+          <a:solidFill>
+            <a:srgbClr val="3F6F5F"/>
+          </a:solidFill>
+          <a:ln/>
+        </p:spPr>
+      </p:sp>
+      <p:sp>
+        <p:nvSpPr>
+          <p:cNvPr id="14" name="Text 12"/>
+          <p:cNvSpPr/>
+          <p:nvPr/>
+        </p:nvSpPr>
+        <p:spPr>
+          <a:xfrm>
+            <a:off x="1097280" y="5495544"/>
+            <a:ext cx="10607040" cy="813816"/>
+          </a:xfrm>
+          <a:prstGeom prst="rect">
+            <a:avLst/>
+          </a:prstGeom>
+          <a:noFill/>
+          <a:ln/>
+        </p:spPr>
+        <p:txBody>
+          <a:bodyPr wrap="square" rtlCol="0" anchor="t">
+            <a:spAutoFit/>
+          </a:bodyPr>
+          <a:lstStyle/>
+          <a:p>
+            <a:pPr indent="0" marL="0">
+              <a:lnSpc>
+                <a:spcPct val="112000"/>
+              </a:lnSpc>
+              <a:buNone/>
+            </a:pPr>
+            <a:r>
+              <a:rPr lang="en-US" sz="1500" dirty="0">
+                <a:solidFill>
+                  <a:srgbClr val="1A1A1A"/>
+                </a:solidFill>
+                <a:latin typeface="Calibri" pitchFamily="34" charset="0"/>
+                <a:ea typeface="Calibri" pitchFamily="34" charset="-122"/>
+                <a:cs typeface="Calibri" pitchFamily="34" charset="-120"/>
+              </a:rPr>
+              <a:t>An AI portrait sold at Christie's for $432,500; the training data was other people's paintings (2018). Every one of these is a count, and every one has arguable choices. Both halves are the course.</a:t>
+            </a:r>
+            <a:endParaRPr lang="en-US" sz="1500" dirty="0"/>
           </a:p>
         </p:txBody>
       </p:sp>
@@ -6106,7 +6846,7 @@
                 <a:ea typeface="Cambria" pitchFamily="34" charset="-122"/>
                 <a:cs typeface="Cambria" pitchFamily="34" charset="-120"/>
               </a:rPr>
-              <a:t>The Drive routine (every week, without exception)</a:t>
+              <a:t>Four words, used all term</a:t>
             </a:r>
             <a:endParaRPr lang="en-US" sz="3000" dirty="0"/>
           </a:p>
@@ -6170,7 +6910,7 @@
                 <a:ea typeface="Calibri" pitchFamily="34" charset="-122"/>
                 <a:cs typeface="Calibri" pitchFamily="34" charset="-120"/>
               </a:rPr>
-              <a:t>Colab wipes its machine when you idle. Your mounted Drive folder is what survives.</a:t>
+              <a:t>Corpus: the pile you study. 500 announcements, 2,000 screenplays, 10,000 album covers.</a:t>
             </a:r>
             <a:endParaRPr lang="en-US" sz="1650" dirty="0"/>
           </a:p>
@@ -6234,7 +6974,7 @@
                 <a:ea typeface="Calibri" pitchFamily="34" charset="-122"/>
                 <a:cs typeface="Calibri" pitchFamily="34" charset="-120"/>
               </a:rPr>
-              <a:t>Copy the notebook to Drive, mount Drive, save everything to the one project folder.</a:t>
+              <a:t>Method: the counting or weighting you run on the corpus.</a:t>
             </a:r>
             <a:endParaRPr lang="en-US" sz="1650" dirty="0"/>
           </a:p>
@@ -6298,7 +7038,7 @@
                 <a:ea typeface="Calibri" pitchFamily="34" charset="-122"/>
                 <a:cs typeface="Calibri" pitchFamily="34" charset="-120"/>
               </a:rPr>
-              <a:t>Your Week-4 corpus has to be alive in Week 5. This ritual is how.</a:t>
+              <a:t>Model: any simplification that turns culture into numbers. A word count is already one.</a:t>
             </a:r>
             <a:endParaRPr lang="en-US" sz="1650" dirty="0"/>
           </a:p>
@@ -6362,7 +7102,7 @@
                 <a:ea typeface="Calibri" pitchFamily="34" charset="-122"/>
                 <a:cs typeface="Calibri" pitchFamily="34" charset="-120"/>
               </a:rPr>
-              <a:t>Gemini key goes in Colab Secrets. Never pasted into code.</a:t>
+              <a:t>Embedding: a few hundred numbers that place an item on a map of meaning. Week 5.</a:t>
             </a:r>
             <a:endParaRPr lang="en-US" sz="1650" dirty="0"/>
           </a:p>
@@ -6494,7 +7234,7 @@
                 <a:ea typeface="Cambria" pitchFamily="34" charset="-122"/>
                 <a:cs typeface="Cambria" pitchFamily="34" charset="-120"/>
               </a:rPr>
-              <a:t>When code fails (it will, today, deliberately)</a:t>
+              <a:t>The Drive routine (every week, without exception)</a:t>
             </a:r>
             <a:endParaRPr lang="en-US" sz="3000" dirty="0"/>
           </a:p>
@@ -6558,7 +7298,7 @@
                 <a:ea typeface="Calibri" pitchFamily="34" charset="-122"/>
                 <a:cs typeface="Calibri" pitchFamily="34" charset="-120"/>
               </a:rPr>
-              <a:t>Read the last line of the traceback first. It names the problem.</a:t>
+              <a:t>Colab wipes its machine when you idle. Your mounted Drive folder is what survives.</a:t>
             </a:r>
             <a:endParaRPr lang="en-US" sz="1650" dirty="0"/>
           </a:p>
@@ -6622,7 +7362,7 @@
                 <a:ea typeface="Calibri" pitchFamily="34" charset="-122"/>
                 <a:cs typeface="Calibri" pitchFamily="34" charset="-120"/>
               </a:rPr>
-              <a:t>Paste it to the AI: "this errored, fix it and tell me what went wrong."</a:t>
+              <a:t>Copy the notebook to Drive, mount Drive, save everything to the one project folder.</a:t>
             </a:r>
             <a:endParaRPr lang="en-US" sz="1650" dirty="0"/>
           </a:p>
@@ -6686,7 +7426,7 @@
                 <a:ea typeface="Calibri" pitchFamily="34" charset="-122"/>
                 <a:cs typeface="Calibri" pitchFamily="34" charset="-120"/>
               </a:rPr>
-              <a:t>Try twice, then ask a human. In that order.</a:t>
+              <a:t>Your Week-4 corpus has to be alive in Week 5. This ritual is how.</a:t>
             </a:r>
             <a:endParaRPr lang="en-US" sz="1650" dirty="0"/>
           </a:p>
@@ -6750,7 +7490,7 @@
                 <a:ea typeface="Calibri" pitchFamily="34" charset="-122"/>
                 <a:cs typeface="Calibri" pitchFamily="34" charset="-120"/>
               </a:rPr>
-              <a:t>Keep the cheat sheet at hand. No one memorizes error messages; everyone reads them.</a:t>
+              <a:t>Gemini key goes in Colab Secrets. Never pasted into code.</a:t>
             </a:r>
             <a:endParaRPr lang="en-US" sz="1650" dirty="0"/>
           </a:p>
@@ -6882,7 +7622,7 @@
                 <a:ea typeface="Cambria" pitchFamily="34" charset="-122"/>
                 <a:cs typeface="Cambria" pitchFamily="34" charset="-120"/>
               </a:rPr>
-              <a:t>Counting, three shapes</a:t>
+              <a:t>When code fails (it will, today, deliberately)</a:t>
             </a:r>
             <a:endParaRPr lang="en-US" sz="3000" dirty="0"/>
           </a:p>
@@ -6946,7 +7686,7 @@
                 <a:ea typeface="Calibri" pitchFamily="34" charset="-122"/>
                 <a:cs typeface="Calibri" pitchFamily="34" charset="-120"/>
               </a:rPr>
-              <a:t>Rows: what share of brides kept their name, year by year. One groupby, one chart.</a:t>
+              <a:t>Read the last line of the traceback first. It names the problem.</a:t>
             </a:r>
             <a:endParaRPr lang="en-US" sz="1650" dirty="0"/>
           </a:p>
@@ -7010,7 +7750,7 @@
                 <a:ea typeface="Calibri" pitchFamily="34" charset="-122"/>
                 <a:cs typeface="Calibri" pitchFamily="34" charset="-120"/>
               </a:rPr>
-              <a:t>Words: the top words of a lyric are "the, and, you" until you remove stop-words. That removal is your first modeling choice.</a:t>
+              <a:t>Paste it to the AI: "this errored, fix it and tell me what went wrong."</a:t>
             </a:r>
             <a:endParaRPr lang="en-US" sz="1650" dirty="0"/>
           </a:p>
@@ -7074,7 +7814,7 @@
                 <a:ea typeface="Calibri" pitchFamily="34" charset="-122"/>
                 <a:cs typeface="Calibri" pitchFamily="34" charset="-120"/>
               </a:rPr>
-              <a:t>Pixels: rank 200 Met thumbnails darkest to brightest from average luminance.</a:t>
+              <a:t>Try twice, then ask a human. In that order.</a:t>
             </a:r>
             <a:endParaRPr lang="en-US" sz="1650" dirty="0"/>
           </a:p>
@@ -7138,7 +7878,7 @@
                 <a:ea typeface="Calibri" pitchFamily="34" charset="-122"/>
                 <a:cs typeface="Calibri" pitchFamily="34" charset="-120"/>
               </a:rPr>
-              <a:t>The same technique three times, each containing a decision.</a:t>
+              <a:t>Keep the cheat sheet at hand. No one memorizes error messages; everyone reads them.</a:t>
             </a:r>
             <a:endParaRPr lang="en-US" sz="1650" dirty="0"/>
           </a:p>
@@ -7178,14 +7918,34 @@
       </p:grpSpPr>
       <p:sp>
         <p:nvSpPr>
-          <p:cNvPr id="2" name="Text 0"/>
-          <p:cNvSpPr/>
-          <p:nvPr/>
-        </p:nvSpPr>
-        <p:spPr>
-          <a:xfrm>
-            <a:off x="640080" y="731520"/>
-            <a:ext cx="10058400" cy="731520"/>
+          <p:cNvPr id="2" name="Shape 0"/>
+          <p:cNvSpPr/>
+          <p:nvPr/>
+        </p:nvSpPr>
+        <p:spPr>
+          <a:xfrm>
+            <a:off x="0" y="0"/>
+            <a:ext cx="164592" cy="6858000"/>
+          </a:xfrm>
+          <a:prstGeom prst="rect">
+            <a:avLst/>
+          </a:prstGeom>
+          <a:solidFill>
+            <a:srgbClr val="B9852F"/>
+          </a:solidFill>
+          <a:ln/>
+        </p:spPr>
+      </p:sp>
+      <p:sp>
+        <p:nvSpPr>
+          <p:cNvPr id="3" name="Text 1"/>
+          <p:cNvSpPr/>
+          <p:nvPr/>
+        </p:nvSpPr>
+        <p:spPr>
+          <a:xfrm>
+            <a:off x="640080" y="640080"/>
+            <a:ext cx="10058400" cy="320040"/>
           </a:xfrm>
           <a:prstGeom prst="rect">
             <a:avLst/>
@@ -7195,6 +7955,47 @@
         </p:spPr>
         <p:txBody>
           <a:bodyPr wrap="square" rtlCol="0" anchor="ctr"/>
+          <a:lstStyle/>
+          <a:p>
+            <a:pPr indent="0" marL="0">
+              <a:buNone/>
+            </a:pPr>
+            <a:r>
+              <a:rPr lang="en-US" sz="1200" b="1" spc="300" kern="0" dirty="0">
+                <a:solidFill>
+                  <a:srgbClr val="B9852F"/>
+                </a:solidFill>
+                <a:latin typeface="Calibri" pitchFamily="34" charset="0"/>
+                <a:ea typeface="Calibri" pitchFamily="34" charset="-122"/>
+                <a:cs typeface="Calibri" pitchFamily="34" charset="-120"/>
+              </a:rPr>
+              <a:t>WEEK 1 · KEY POINTS</a:t>
+            </a:r>
+            <a:endParaRPr lang="en-US" sz="1200" dirty="0"/>
+          </a:p>
+        </p:txBody>
+      </p:sp>
+      <p:sp>
+        <p:nvSpPr>
+          <p:cNvPr id="4" name="Text 2"/>
+          <p:cNvSpPr/>
+          <p:nvPr/>
+        </p:nvSpPr>
+        <p:spPr>
+          <a:xfrm>
+            <a:off x="640080" y="1005840"/>
+            <a:ext cx="10881360" cy="914400"/>
+          </a:xfrm>
+          <a:prstGeom prst="rect">
+            <a:avLst/>
+          </a:prstGeom>
+          <a:noFill/>
+          <a:ln/>
+        </p:spPr>
+        <p:txBody>
+          <a:bodyPr wrap="square" rtlCol="0" anchor="t">
+            <a:spAutoFit/>
+          </a:bodyPr>
           <a:lstStyle/>
           <a:p>
             <a:pPr indent="0" marL="0">
@@ -7209,7 +8010,7 @@
                 <a:ea typeface="Cambria" pitchFamily="34" charset="-122"/>
                 <a:cs typeface="Cambria" pitchFamily="34" charset="-120"/>
               </a:rPr>
-              <a:t>Three modes today</a:t>
+              <a:t>Counting, three shapes</a:t>
             </a:r>
             <a:endParaRPr lang="en-US" sz="3000" dirty="0"/>
           </a:p>
@@ -7217,134 +8018,98 @@
       </p:sp>
       <p:sp>
         <p:nvSpPr>
-          <p:cNvPr id="3" name="Text 1"/>
-          <p:cNvSpPr/>
-          <p:nvPr/>
-        </p:nvSpPr>
-        <p:spPr>
-          <a:xfrm>
-            <a:off x="640080" y="1417320"/>
-            <a:ext cx="10058400" cy="365760"/>
-          </a:xfrm>
-          <a:prstGeom prst="rect">
-            <a:avLst/>
-          </a:prstGeom>
-          <a:noFill/>
-          <a:ln/>
-        </p:spPr>
-        <p:txBody>
-          <a:bodyPr wrap="square" rtlCol="0" anchor="ctr"/>
-          <a:lstStyle/>
-          <a:p>
-            <a:pPr indent="0" marL="0">
-              <a:buNone/>
-            </a:pPr>
-            <a:r>
-              <a:rPr lang="en-US" sz="1400" i="1" dirty="0">
-                <a:solidFill>
-                  <a:srgbClr val="6B6B63"/>
+          <p:cNvPr id="5" name="Shape 3"/>
+          <p:cNvSpPr/>
+          <p:nvPr/>
+        </p:nvSpPr>
+        <p:spPr>
+          <a:xfrm>
+            <a:off x="640080" y="2331720"/>
+            <a:ext cx="201168" cy="201168"/>
+          </a:xfrm>
+          <a:prstGeom prst="ellipse">
+            <a:avLst/>
+          </a:prstGeom>
+          <a:solidFill>
+            <a:srgbClr val="7A3B2E"/>
+          </a:solidFill>
+          <a:ln/>
+        </p:spPr>
+      </p:sp>
+      <p:sp>
+        <p:nvSpPr>
+          <p:cNvPr id="6" name="Text 4"/>
+          <p:cNvSpPr/>
+          <p:nvPr/>
+        </p:nvSpPr>
+        <p:spPr>
+          <a:xfrm>
+            <a:off x="1097280" y="2240280"/>
+            <a:ext cx="10607040" cy="1017270"/>
+          </a:xfrm>
+          <a:prstGeom prst="rect">
+            <a:avLst/>
+          </a:prstGeom>
+          <a:noFill/>
+          <a:ln/>
+        </p:spPr>
+        <p:txBody>
+          <a:bodyPr wrap="square" rtlCol="0" anchor="t">
+            <a:spAutoFit/>
+          </a:bodyPr>
+          <a:lstStyle/>
+          <a:p>
+            <a:pPr indent="0" marL="0">
+              <a:lnSpc>
+                <a:spcPct val="112000"/>
+              </a:lnSpc>
+              <a:buNone/>
+            </a:pPr>
+            <a:r>
+              <a:rPr lang="en-US" sz="1650" dirty="0">
+                <a:solidFill>
+                  <a:srgbClr val="1A1A1A"/>
                 </a:solidFill>
                 <a:latin typeface="Calibri" pitchFamily="34" charset="0"/>
                 <a:ea typeface="Calibri" pitchFamily="34" charset="-122"/>
                 <a:cs typeface="Calibri" pitchFamily="34" charset="-120"/>
               </a:rPr>
-              <a:t>about a third of the session each</a:t>
-            </a:r>
-            <a:endParaRPr lang="en-US" sz="1400" dirty="0"/>
-          </a:p>
-        </p:txBody>
-      </p:sp>
-      <p:sp>
-        <p:nvSpPr>
-          <p:cNvPr id="4" name="Shape 2"/>
-          <p:cNvSpPr/>
-          <p:nvPr/>
-        </p:nvSpPr>
-        <p:spPr>
-          <a:xfrm>
-            <a:off x="640080" y="2194560"/>
-            <a:ext cx="3383280" cy="3291840"/>
-          </a:xfrm>
-          <a:prstGeom prst="roundRect">
-            <a:avLst>
-              <a:gd name="adj" fmla="val 3333"/>
-            </a:avLst>
-          </a:prstGeom>
-          <a:solidFill>
-            <a:srgbClr val="F4EEE8"/>
-          </a:solidFill>
-          <a:ln/>
-        </p:spPr>
-      </p:sp>
-      <p:sp>
-        <p:nvSpPr>
-          <p:cNvPr id="5" name="Shape 3"/>
-          <p:cNvSpPr/>
-          <p:nvPr/>
-        </p:nvSpPr>
-        <p:spPr>
-          <a:xfrm>
-            <a:off x="1051560" y="2606040"/>
-            <a:ext cx="548640" cy="548640"/>
+              <a:t>Rows: what share of brides kept their name, year by year. One groupby, one chart.</a:t>
+            </a:r>
+            <a:endParaRPr lang="en-US" sz="1650" dirty="0"/>
+          </a:p>
+        </p:txBody>
+      </p:sp>
+      <p:sp>
+        <p:nvSpPr>
+          <p:cNvPr id="7" name="Shape 5"/>
+          <p:cNvSpPr/>
+          <p:nvPr/>
+        </p:nvSpPr>
+        <p:spPr>
+          <a:xfrm>
+            <a:off x="640080" y="3348990"/>
+            <a:ext cx="201168" cy="201168"/>
           </a:xfrm>
           <a:prstGeom prst="ellipse">
             <a:avLst/>
           </a:prstGeom>
           <a:solidFill>
-            <a:srgbClr val="7A3B2E"/>
-          </a:solidFill>
-          <a:ln/>
-        </p:spPr>
-      </p:sp>
-      <p:sp>
-        <p:nvSpPr>
-          <p:cNvPr id="6" name="Text 4"/>
-          <p:cNvSpPr/>
-          <p:nvPr/>
-        </p:nvSpPr>
-        <p:spPr>
-          <a:xfrm>
-            <a:off x="1005840" y="3383280"/>
-            <a:ext cx="2651760" cy="548640"/>
-          </a:xfrm>
-          <a:prstGeom prst="rect">
-            <a:avLst/>
-          </a:prstGeom>
-          <a:noFill/>
-          <a:ln/>
-        </p:spPr>
-        <p:txBody>
-          <a:bodyPr wrap="square" rtlCol="0" anchor="ctr"/>
-          <a:lstStyle/>
-          <a:p>
-            <a:pPr indent="0" marL="0">
-              <a:buNone/>
-            </a:pPr>
-            <a:r>
-              <a:rPr lang="en-US" sz="2100" b="1" dirty="0">
-                <a:solidFill>
-                  <a:srgbClr val="1A1A1A"/>
-                </a:solidFill>
-                <a:latin typeface="Cambria" pitchFamily="34" charset="0"/>
-                <a:ea typeface="Cambria" pitchFamily="34" charset="-122"/>
-                <a:cs typeface="Cambria" pitchFamily="34" charset="-120"/>
-              </a:rPr>
-              <a:t>Lecture / demo</a:t>
-            </a:r>
-            <a:endParaRPr lang="en-US" sz="2100" dirty="0"/>
-          </a:p>
-        </p:txBody>
-      </p:sp>
-      <p:sp>
-        <p:nvSpPr>
-          <p:cNvPr id="7" name="Text 5"/>
-          <p:cNvSpPr/>
-          <p:nvPr/>
-        </p:nvSpPr>
-        <p:spPr>
-          <a:xfrm>
-            <a:off x="1005840" y="3977640"/>
-            <a:ext cx="2651760" cy="1371600"/>
+            <a:srgbClr val="3F6F5F"/>
+          </a:solidFill>
+          <a:ln/>
+        </p:spPr>
+      </p:sp>
+      <p:sp>
+        <p:nvSpPr>
+          <p:cNvPr id="8" name="Text 6"/>
+          <p:cNvSpPr/>
+          <p:nvPr/>
+        </p:nvSpPr>
+        <p:spPr>
+          <a:xfrm>
+            <a:off x="1097280" y="3257550"/>
+            <a:ext cx="10607040" cy="1017270"/>
           </a:xfrm>
           <a:prstGeom prst="rect">
             <a:avLst/>
@@ -7360,12 +8125,12 @@
           <a:p>
             <a:pPr indent="0" marL="0">
               <a:lnSpc>
-                <a:spcPct val="115000"/>
+                <a:spcPct val="112000"/>
               </a:lnSpc>
               <a:buNone/>
             </a:pPr>
             <a:r>
-              <a:rPr lang="en-US" sz="1500" dirty="0">
+              <a:rPr lang="en-US" sz="1650" dirty="0">
                 <a:solidFill>
                   <a:srgbClr val="1A1A1A"/>
                 </a:solidFill>
@@ -7373,33 +8138,11 @@
                 <a:ea typeface="Calibri" pitchFamily="34" charset="-122"/>
                 <a:cs typeface="Calibri" pitchFamily="34" charset="-120"/>
               </a:rPr>
-              <a:t>Counting: rows, words, pixels</a:t>
-            </a:r>
-            <a:endParaRPr lang="en-US" sz="1500" dirty="0"/>
-          </a:p>
-        </p:txBody>
-      </p:sp>
-      <p:sp>
-        <p:nvSpPr>
-          <p:cNvPr id="8" name="Shape 6"/>
-          <p:cNvSpPr/>
-          <p:nvPr/>
-        </p:nvSpPr>
-        <p:spPr>
-          <a:xfrm>
-            <a:off x="4526280" y="2194560"/>
-            <a:ext cx="3383280" cy="3291840"/>
-          </a:xfrm>
-          <a:prstGeom prst="roundRect">
-            <a:avLst>
-              <a:gd name="adj" fmla="val 3333"/>
-            </a:avLst>
-          </a:prstGeom>
-          <a:solidFill>
-            <a:srgbClr val="F4EEE8"/>
-          </a:solidFill>
-          <a:ln/>
-        </p:spPr>
+              <a:t>Words: the top words of a lyric are "the, and, you" until you remove stop-words. That removal is your first modeling choice.</a:t>
+            </a:r>
+            <a:endParaRPr lang="en-US" sz="1650" dirty="0"/>
+          </a:p>
+        </p:txBody>
       </p:sp>
       <p:sp>
         <p:nvSpPr>
@@ -7409,14 +8152,14 @@
         </p:nvSpPr>
         <p:spPr>
           <a:xfrm>
-            <a:off x="4937760" y="2606040"/>
-            <a:ext cx="548640" cy="548640"/>
+            <a:off x="640080" y="4366260"/>
+            <a:ext cx="201168" cy="201168"/>
           </a:xfrm>
           <a:prstGeom prst="ellipse">
             <a:avLst/>
           </a:prstGeom>
           <a:solidFill>
-            <a:srgbClr val="3F6F5F"/>
+            <a:srgbClr val="B9852F"/>
           </a:solidFill>
           <a:ln/>
         </p:spPr>
@@ -7429,47 +8172,8 @@
         </p:nvSpPr>
         <p:spPr>
           <a:xfrm>
-            <a:off x="4892040" y="3383280"/>
-            <a:ext cx="2651760" cy="548640"/>
-          </a:xfrm>
-          <a:prstGeom prst="rect">
-            <a:avLst/>
-          </a:prstGeom>
-          <a:noFill/>
-          <a:ln/>
-        </p:spPr>
-        <p:txBody>
-          <a:bodyPr wrap="square" rtlCol="0" anchor="ctr"/>
-          <a:lstStyle/>
-          <a:p>
-            <a:pPr indent="0" marL="0">
-              <a:buNone/>
-            </a:pPr>
-            <a:r>
-              <a:rPr lang="en-US" sz="2100" b="1" dirty="0">
-                <a:solidFill>
-                  <a:srgbClr val="1A1A1A"/>
-                </a:solidFill>
-                <a:latin typeface="Cambria" pitchFamily="34" charset="0"/>
-                <a:ea typeface="Cambria" pitchFamily="34" charset="-122"/>
-                <a:cs typeface="Cambria" pitchFamily="34" charset="-120"/>
-              </a:rPr>
-              <a:t>Workshop</a:t>
-            </a:r>
-            <a:endParaRPr lang="en-US" sz="2100" dirty="0"/>
-          </a:p>
-        </p:txBody>
-      </p:sp>
-      <p:sp>
-        <p:nvSpPr>
-          <p:cNvPr id="11" name="Text 9"/>
-          <p:cNvSpPr/>
-          <p:nvPr/>
-        </p:nvSpPr>
-        <p:spPr>
-          <a:xfrm>
-            <a:off x="4892040" y="3977640"/>
-            <a:ext cx="2651760" cy="1371600"/>
+            <a:off x="1097280" y="4274820"/>
+            <a:ext cx="10607040" cy="1017270"/>
           </a:xfrm>
           <a:prstGeom prst="rect">
             <a:avLst/>
@@ -7485,12 +8189,12 @@
           <a:p>
             <a:pPr indent="0" marL="0">
               <a:lnSpc>
-                <a:spcPct val="115000"/>
+                <a:spcPct val="112000"/>
               </a:lnSpc>
               <a:buNone/>
             </a:pPr>
             <a:r>
-              <a:rPr lang="en-US" sz="1500" dirty="0">
+              <a:rPr lang="en-US" sz="1650" dirty="0">
                 <a:solidFill>
                   <a:srgbClr val="1A1A1A"/>
                 </a:solidFill>
@@ -7498,103 +8202,42 @@
                 <a:ea typeface="Calibri" pitchFamily="34" charset="-122"/>
                 <a:cs typeface="Calibri" pitchFamily="34" charset="-120"/>
               </a:rPr>
-              <a:t>Build hands-on on your own data.</a:t>
-            </a:r>
-            <a:endParaRPr lang="en-US" sz="1500" dirty="0"/>
-          </a:p>
-        </p:txBody>
-      </p:sp>
-      <p:sp>
-        <p:nvSpPr>
-          <p:cNvPr id="12" name="Shape 10"/>
-          <p:cNvSpPr/>
-          <p:nvPr/>
-        </p:nvSpPr>
-        <p:spPr>
-          <a:xfrm>
-            <a:off x="8412480" y="2194560"/>
-            <a:ext cx="3383280" cy="3291840"/>
-          </a:xfrm>
-          <a:prstGeom prst="roundRect">
-            <a:avLst>
-              <a:gd name="adj" fmla="val 3333"/>
-            </a:avLst>
-          </a:prstGeom>
-          <a:solidFill>
-            <a:srgbClr val="F4EEE8"/>
-          </a:solidFill>
-          <a:ln/>
-        </p:spPr>
-      </p:sp>
-      <p:sp>
-        <p:nvSpPr>
-          <p:cNvPr id="13" name="Shape 11"/>
-          <p:cNvSpPr/>
-          <p:nvPr/>
-        </p:nvSpPr>
-        <p:spPr>
-          <a:xfrm>
-            <a:off x="8823960" y="2606040"/>
-            <a:ext cx="548640" cy="548640"/>
+              <a:t>Pixels: rank 200 Met thumbnails darkest to brightest from average luminance.</a:t>
+            </a:r>
+            <a:endParaRPr lang="en-US" sz="1650" dirty="0"/>
+          </a:p>
+        </p:txBody>
+      </p:sp>
+      <p:sp>
+        <p:nvSpPr>
+          <p:cNvPr id="11" name="Shape 9"/>
+          <p:cNvSpPr/>
+          <p:nvPr/>
+        </p:nvSpPr>
+        <p:spPr>
+          <a:xfrm>
+            <a:off x="640080" y="5383530"/>
+            <a:ext cx="201168" cy="201168"/>
           </a:xfrm>
           <a:prstGeom prst="ellipse">
             <a:avLst/>
           </a:prstGeom>
           <a:solidFill>
-            <a:srgbClr val="B9852F"/>
-          </a:solidFill>
-          <a:ln/>
-        </p:spPr>
-      </p:sp>
-      <p:sp>
-        <p:nvSpPr>
-          <p:cNvPr id="14" name="Text 12"/>
-          <p:cNvSpPr/>
-          <p:nvPr/>
-        </p:nvSpPr>
-        <p:spPr>
-          <a:xfrm>
-            <a:off x="8778240" y="3383280"/>
-            <a:ext cx="2651760" cy="548640"/>
-          </a:xfrm>
-          <a:prstGeom prst="rect">
-            <a:avLst/>
-          </a:prstGeom>
-          <a:noFill/>
-          <a:ln/>
-        </p:spPr>
-        <p:txBody>
-          <a:bodyPr wrap="square" rtlCol="0" anchor="ctr"/>
-          <a:lstStyle/>
-          <a:p>
-            <a:pPr indent="0" marL="0">
-              <a:buNone/>
-            </a:pPr>
-            <a:r>
-              <a:rPr lang="en-US" sz="2100" b="1" dirty="0">
-                <a:solidFill>
-                  <a:srgbClr val="1A1A1A"/>
-                </a:solidFill>
-                <a:latin typeface="Cambria" pitchFamily="34" charset="0"/>
-                <a:ea typeface="Cambria" pitchFamily="34" charset="-122"/>
-                <a:cs typeface="Cambria" pitchFamily="34" charset="-120"/>
-              </a:rPr>
-              <a:t>Discussion</a:t>
-            </a:r>
-            <a:endParaRPr lang="en-US" sz="2100" dirty="0"/>
-          </a:p>
-        </p:txBody>
-      </p:sp>
-      <p:sp>
-        <p:nvSpPr>
-          <p:cNvPr id="15" name="Text 13"/>
-          <p:cNvSpPr/>
-          <p:nvPr/>
-        </p:nvSpPr>
-        <p:spPr>
-          <a:xfrm>
-            <a:off x="8778240" y="3977640"/>
-            <a:ext cx="2651760" cy="1371600"/>
+            <a:srgbClr val="7A3B2E"/>
+          </a:solidFill>
+          <a:ln/>
+        </p:spPr>
+      </p:sp>
+      <p:sp>
+        <p:nvSpPr>
+          <p:cNvPr id="12" name="Text 10"/>
+          <p:cNvSpPr/>
+          <p:nvPr/>
+        </p:nvSpPr>
+        <p:spPr>
+          <a:xfrm>
+            <a:off x="1097280" y="5292090"/>
+            <a:ext cx="10607040" cy="1017270"/>
           </a:xfrm>
           <a:prstGeom prst="rect">
             <a:avLst/>
@@ -7610,12 +8253,12 @@
           <a:p>
             <a:pPr indent="0" marL="0">
               <a:lnSpc>
-                <a:spcPct val="115000"/>
+                <a:spcPct val="112000"/>
               </a:lnSpc>
               <a:buNone/>
             </a:pPr>
             <a:r>
-              <a:rPr lang="en-US" sz="1500" dirty="0">
+              <a:rPr lang="en-US" sz="1650" dirty="0">
                 <a:solidFill>
                   <a:srgbClr val="1A1A1A"/>
                 </a:solidFill>
@@ -7623,9 +8266,9 @@
                 <a:ea typeface="Calibri" pitchFamily="34" charset="-122"/>
                 <a:cs typeface="Calibri" pitchFamily="34" charset="-120"/>
               </a:rPr>
-              <a:t>Interrogate the study, debate it, or critique each other's work.</a:t>
-            </a:r>
-            <a:endParaRPr lang="en-US" sz="1500" dirty="0"/>
+              <a:t>The same technique three times, each containing a decision.</a:t>
+            </a:r>
+            <a:endParaRPr lang="en-US" sz="1650" dirty="0"/>
           </a:p>
         </p:txBody>
       </p:sp>

</xml_diff>

<commit_message>
Move deep-research guidance from the Week 1 notebook to the deck
The notebook loses its prose-only deep-research section (it had no code to
run); the Week 1 deck gains 'Deep-research tools: one role, four rules' -
the scout role, citations as leads, verify access yourself, the report is
never a source, scout then close the tool. Lesson-plan and syllabus pointers
updated to name the deck as where the rules live.
</commit_message>
<xml_diff>
--- a/slides/pptx/week-01.pptx
+++ b/slides/pptx/week-01.pptx
@@ -21,9 +21,10 @@
     <p:sldId id="269" r:id="rId15"/>
     <p:sldId id="270" r:id="rId16"/>
     <p:sldId id="271" r:id="rId17"/>
+    <p:sldId id="272" r:id="rId18"/>
   </p:sldIdLst>
   <p:notesMasterIdLst>
-    <p:notesMasterId r:id="rId18"/>
+    <p:notesMasterId r:id="rId19"/>
   </p:notesMasterIdLst>
   <p:sldSz cx="12191695" cy="6858000"/>
   <p:notesSz cx="6858000" cy="12191695"/>
@@ -1175,6 +1176,94 @@
 </p:notes>
 </file>
 
+<file path=ppt/notesSlides/notesSlide17.xml><?xml version="1.0" encoding="utf-8"?>
+<p:notes xmlns:a="http://schemas.openxmlformats.org/drawingml/2006/main" xmlns:r="http://schemas.openxmlformats.org/officeDocument/2006/relationships" xmlns:p="http://schemas.openxmlformats.org/presentationml/2006/main">
+  <p:cSld>
+    <p:spTree>
+      <p:nvGrpSpPr>
+        <p:cNvPr id="1" name=""/>
+        <p:cNvGrpSpPr/>
+        <p:nvPr/>
+      </p:nvGrpSpPr>
+      <p:grpSpPr>
+        <a:xfrm>
+          <a:off x="0" y="0"/>
+          <a:ext cx="0" cy="0"/>
+          <a:chOff x="0" y="0"/>
+          <a:chExt cx="0" cy="0"/>
+        </a:xfrm>
+      </p:grpSpPr>
+      <p:sp>
+        <p:nvSpPr>
+          <p:cNvPr id="2" name="Slide Image Placeholder 1"/>
+          <p:cNvSpPr>
+            <a:spLocks noGrp="1" noRot="1" noChangeAspect="1"/>
+          </p:cNvSpPr>
+          <p:nvPr>
+            <p:ph type="sldImg"/>
+          </p:nvPr>
+        </p:nvSpPr>
+        <p:spPr/>
+      </p:sp>
+      <p:sp>
+        <p:nvSpPr>
+          <p:cNvPr id="3" name="Notes Placeholder 2"/>
+          <p:cNvSpPr>
+            <a:spLocks noGrp="1"/>
+          </p:cNvSpPr>
+          <p:nvPr>
+            <p:ph type="body" idx="1"/>
+          </p:nvPr>
+        </p:nvSpPr>
+        <p:spPr/>
+        <p:txBody>
+          <a:bodyPr/>
+          <a:lstStyle/>
+          <a:p>
+            <a:r>
+              <a:rPr lang="en-US" dirty="0"/>
+              <a:t/>
+            </a:r>
+            <a:endParaRPr lang="en-US" dirty="0"/>
+          </a:p>
+        </p:txBody>
+      </p:sp>
+      <p:sp>
+        <p:nvSpPr>
+          <p:cNvPr id="4" name="Slide Number Placeholder 3"/>
+          <p:cNvSpPr>
+            <a:spLocks noGrp="1"/>
+          </p:cNvSpPr>
+          <p:nvPr>
+            <p:ph type="sldNum" sz="quarter" idx="10"/>
+          </p:nvPr>
+        </p:nvSpPr>
+        <p:spPr/>
+        <p:txBody>
+          <a:bodyPr/>
+          <a:lstStyle/>
+          <a:p>
+            <a:fld id="{F7021451-1387-4CA6-816F-3879F97B5CBC}" type="slidenum">
+              <a:rPr lang="en-US"/>
+              <a:t>17</a:t>
+            </a:fld>
+            <a:endParaRPr lang="en-US"/>
+          </a:p>
+        </p:txBody>
+      </p:sp>
+    </p:spTree>
+    <p:extLst>
+      <p:ext uri="{BB962C8B-B14F-4D97-AF65-F5344CB8AC3E}">
+        <p14:creationId xmlns:p14="http://schemas.microsoft.com/office/powerpoint/2010/main" val="1024086991"/>
+      </p:ext>
+    </p:extLst>
+  </p:cSld>
+  <p:clrMapOvr>
+    <a:masterClrMapping/>
+  </p:clrMapOvr>
+</p:notes>
+</file>
+
 <file path=ppt/notesSlides/notesSlide2.xml><?xml version="1.0" encoding="utf-8"?>
 <p:notes xmlns:a="http://schemas.openxmlformats.org/drawingml/2006/main" xmlns:r="http://schemas.openxmlformats.org/officeDocument/2006/relationships" xmlns:p="http://schemas.openxmlformats.org/presentationml/2006/main">
   <p:cSld>
@@ -3243,7 +3332,7 @@
                 <a:ea typeface="Cambria" pitchFamily="34" charset="-122"/>
                 <a:cs typeface="Cambria" pitchFamily="34" charset="-120"/>
               </a:rPr>
-              <a:t>Counting, three shapes</a:t>
+              <a:t>Deep-research tools: one role, four rules</a:t>
             </a:r>
             <a:endParaRPr lang="en-US" sz="3000" dirty="0"/>
           </a:p>
@@ -3278,7 +3367,7 @@
         <p:spPr>
           <a:xfrm>
             <a:off x="1097280" y="2240280"/>
-            <a:ext cx="10607040" cy="1017270"/>
+            <a:ext cx="10607040" cy="813816"/>
           </a:xfrm>
           <a:prstGeom prst="rect">
             <a:avLst/>
@@ -3299,7 +3388,7 @@
               <a:buNone/>
             </a:pPr>
             <a:r>
-              <a:rPr lang="en-US" sz="1650" dirty="0">
+              <a:rPr lang="en-US" sz="1500" dirty="0">
                 <a:solidFill>
                   <a:srgbClr val="1A1A1A"/>
                 </a:solidFill>
@@ -3307,9 +3396,9 @@
                 <a:ea typeface="Calibri" pitchFamily="34" charset="-122"/>
                 <a:cs typeface="Calibri" pitchFamily="34" charset="-120"/>
               </a:rPr>
-              <a:t>Rows: what share of brides kept their name, year by year. One groupby, one chart.</a:t>
-            </a:r>
-            <a:endParaRPr lang="en-US" sz="1650" dirty="0"/>
+              <a:t>AI deep-research tools browse for an hour and return a long, cited report. In this course they have exactly one role: the scout, finding datasets and prior work before Week 4's commitment.</a:t>
+            </a:r>
+            <a:endParaRPr lang="en-US" sz="1500" dirty="0"/>
           </a:p>
         </p:txBody>
       </p:sp>
@@ -3321,7 +3410,7 @@
         </p:nvSpPr>
         <p:spPr>
           <a:xfrm>
-            <a:off x="640080" y="3348990"/>
+            <a:off x="640080" y="3145536"/>
             <a:ext cx="201168" cy="201168"/>
           </a:xfrm>
           <a:prstGeom prst="ellipse">
@@ -3341,8 +3430,8 @@
         </p:nvSpPr>
         <p:spPr>
           <a:xfrm>
-            <a:off x="1097280" y="3257550"/>
-            <a:ext cx="10607040" cy="1017270"/>
+            <a:off x="1097280" y="3054096"/>
+            <a:ext cx="10607040" cy="813816"/>
           </a:xfrm>
           <a:prstGeom prst="rect">
             <a:avLst/>
@@ -3363,7 +3452,7 @@
               <a:buNone/>
             </a:pPr>
             <a:r>
-              <a:rPr lang="en-US" sz="1650" dirty="0">
+              <a:rPr lang="en-US" sz="1500" dirty="0">
                 <a:solidFill>
                   <a:srgbClr val="1A1A1A"/>
                 </a:solidFill>
@@ -3371,9 +3460,9 @@
                 <a:ea typeface="Calibri" pitchFamily="34" charset="-122"/>
                 <a:cs typeface="Calibri" pitchFamily="34" charset="-120"/>
               </a:rPr>
-              <a:t>Words: the top words of a lyric are "the, and, you" until you remove stop-words. That removal is your first modeling choice.</a:t>
-            </a:r>
-            <a:endParaRPr lang="en-US" sz="1650" dirty="0"/>
+              <a:t>Rule one: every citation is a lead, not a source. Reports cite real, wrong, and nonexistent works with identical confidence; nothing enters your work unread.</a:t>
+            </a:r>
+            <a:endParaRPr lang="en-US" sz="1500" dirty="0"/>
           </a:p>
         </p:txBody>
       </p:sp>
@@ -3385,7 +3474,7 @@
         </p:nvSpPr>
         <p:spPr>
           <a:xfrm>
-            <a:off x="640080" y="4366260"/>
+            <a:off x="640080" y="3959352"/>
             <a:ext cx="201168" cy="201168"/>
           </a:xfrm>
           <a:prstGeom prst="ellipse">
@@ -3405,8 +3494,8 @@
         </p:nvSpPr>
         <p:spPr>
           <a:xfrm>
-            <a:off x="1097280" y="4274820"/>
-            <a:ext cx="10607040" cy="1017270"/>
+            <a:off x="1097280" y="3867912"/>
+            <a:ext cx="10607040" cy="813816"/>
           </a:xfrm>
           <a:prstGeom prst="rect">
             <a:avLst/>
@@ -3427,7 +3516,7 @@
               <a:buNone/>
             </a:pPr>
             <a:r>
-              <a:rPr lang="en-US" sz="1650" dirty="0">
+              <a:rPr lang="en-US" sz="1500" dirty="0">
                 <a:solidFill>
                   <a:srgbClr val="1A1A1A"/>
                 </a:solidFill>
@@ -3435,9 +3524,9 @@
                 <a:ea typeface="Calibri" pitchFamily="34" charset="-122"/>
                 <a:cs typeface="Calibri" pitchFamily="34" charset="-120"/>
               </a:rPr>
-              <a:t>Pixels: rank 200 Met thumbnails darkest to brightest from average luminance.</a:t>
-            </a:r>
-            <a:endParaRPr lang="en-US" sz="1650" dirty="0"/>
+              <a:t>Rule two: verify dataset access yourself. "Publicly available" in a report means someone once said so; the corpus-existence proof (50 loadable rows, Week 3's sketch) is the standard.</a:t>
+            </a:r>
+            <a:endParaRPr lang="en-US" sz="1500" dirty="0"/>
           </a:p>
         </p:txBody>
       </p:sp>
@@ -3449,7 +3538,7 @@
         </p:nvSpPr>
         <p:spPr>
           <a:xfrm>
-            <a:off x="640080" y="5383530"/>
+            <a:off x="640080" y="4773168"/>
             <a:ext cx="201168" cy="201168"/>
           </a:xfrm>
           <a:prstGeom prst="ellipse">
@@ -3469,8 +3558,8 @@
         </p:nvSpPr>
         <p:spPr>
           <a:xfrm>
-            <a:off x="1097280" y="5292090"/>
-            <a:ext cx="10607040" cy="1017270"/>
+            <a:off x="1097280" y="4681728"/>
+            <a:ext cx="10607040" cy="813816"/>
           </a:xfrm>
           <a:prstGeom prst="rect">
             <a:avLst/>
@@ -3491,7 +3580,7 @@
               <a:buNone/>
             </a:pPr>
             <a:r>
-              <a:rPr lang="en-US" sz="1650" dirty="0">
+              <a:rPr lang="en-US" sz="1500" dirty="0">
                 <a:solidFill>
                   <a:srgbClr val="1A1A1A"/>
                 </a:solidFill>
@@ -3499,9 +3588,73 @@
                 <a:ea typeface="Calibri" pitchFamily="34" charset="-122"/>
                 <a:cs typeface="Calibri" pitchFamily="34" charset="-120"/>
               </a:rPr>
-              <a:t>The same technique three times, each containing a decision.</a:t>
-            </a:r>
-            <a:endParaRPr lang="en-US" sz="1650" dirty="0"/>
+              <a:t>Rule three: the report is never a source. Cite what you read, not the tool that found it.</a:t>
+            </a:r>
+            <a:endParaRPr lang="en-US" sz="1500" dirty="0"/>
+          </a:p>
+        </p:txBody>
+      </p:sp>
+      <p:sp>
+        <p:nvSpPr>
+          <p:cNvPr id="13" name="Shape 11"/>
+          <p:cNvSpPr/>
+          <p:nvPr/>
+        </p:nvSpPr>
+        <p:spPr>
+          <a:xfrm>
+            <a:off x="640080" y="5586984"/>
+            <a:ext cx="201168" cy="201168"/>
+          </a:xfrm>
+          <a:prstGeom prst="ellipse">
+            <a:avLst/>
+          </a:prstGeom>
+          <a:solidFill>
+            <a:srgbClr val="3F6F5F"/>
+          </a:solidFill>
+          <a:ln/>
+        </p:spPr>
+      </p:sp>
+      <p:sp>
+        <p:nvSpPr>
+          <p:cNvPr id="14" name="Text 12"/>
+          <p:cNvSpPr/>
+          <p:nvPr/>
+        </p:nvSpPr>
+        <p:spPr>
+          <a:xfrm>
+            <a:off x="1097280" y="5495544"/>
+            <a:ext cx="10607040" cy="813816"/>
+          </a:xfrm>
+          <a:prstGeom prst="rect">
+            <a:avLst/>
+          </a:prstGeom>
+          <a:noFill/>
+          <a:ln/>
+        </p:spPr>
+        <p:txBody>
+          <a:bodyPr wrap="square" rtlCol="0" anchor="t">
+            <a:spAutoFit/>
+          </a:bodyPr>
+          <a:lstStyle/>
+          <a:p>
+            <a:pPr indent="0" marL="0">
+              <a:lnSpc>
+                <a:spcPct val="112000"/>
+              </a:lnSpc>
+              <a:buNone/>
+            </a:pPr>
+            <a:r>
+              <a:rPr lang="en-US" sz="1500" dirty="0">
+                <a:solidFill>
+                  <a:srgbClr val="1A1A1A"/>
+                </a:solidFill>
+                <a:latin typeface="Calibri" pitchFamily="34" charset="0"/>
+                <a:ea typeface="Calibri" pitchFamily="34" charset="-122"/>
+                <a:cs typeface="Calibri" pitchFamily="34" charset="-120"/>
+              </a:rPr>
+              <a:t>Rule four: scout, then close the tool. Your question, your reading, and your interpretation cannot be delegated - the same boundary as with code.</a:t>
+            </a:r>
+            <a:endParaRPr lang="en-US" sz="1500" dirty="0"/>
           </a:p>
         </p:txBody>
       </p:sp>
@@ -3539,14 +3692,34 @@
       </p:grpSpPr>
       <p:sp>
         <p:nvSpPr>
-          <p:cNvPr id="2" name="Text 0"/>
-          <p:cNvSpPr/>
-          <p:nvPr/>
-        </p:nvSpPr>
-        <p:spPr>
-          <a:xfrm>
-            <a:off x="640080" y="731520"/>
-            <a:ext cx="10058400" cy="731520"/>
+          <p:cNvPr id="2" name="Shape 0"/>
+          <p:cNvSpPr/>
+          <p:nvPr/>
+        </p:nvSpPr>
+        <p:spPr>
+          <a:xfrm>
+            <a:off x="0" y="0"/>
+            <a:ext cx="164592" cy="6858000"/>
+          </a:xfrm>
+          <a:prstGeom prst="rect">
+            <a:avLst/>
+          </a:prstGeom>
+          <a:solidFill>
+            <a:srgbClr val="B9852F"/>
+          </a:solidFill>
+          <a:ln/>
+        </p:spPr>
+      </p:sp>
+      <p:sp>
+        <p:nvSpPr>
+          <p:cNvPr id="3" name="Text 1"/>
+          <p:cNvSpPr/>
+          <p:nvPr/>
+        </p:nvSpPr>
+        <p:spPr>
+          <a:xfrm>
+            <a:off x="640080" y="640080"/>
+            <a:ext cx="10058400" cy="320040"/>
           </a:xfrm>
           <a:prstGeom prst="rect">
             <a:avLst/>
@@ -3556,6 +3729,47 @@
         </p:spPr>
         <p:txBody>
           <a:bodyPr wrap="square" rtlCol="0" anchor="ctr"/>
+          <a:lstStyle/>
+          <a:p>
+            <a:pPr indent="0" marL="0">
+              <a:buNone/>
+            </a:pPr>
+            <a:r>
+              <a:rPr lang="en-US" sz="1200" b="1" spc="300" kern="0" dirty="0">
+                <a:solidFill>
+                  <a:srgbClr val="B9852F"/>
+                </a:solidFill>
+                <a:latin typeface="Calibri" pitchFamily="34" charset="0"/>
+                <a:ea typeface="Calibri" pitchFamily="34" charset="-122"/>
+                <a:cs typeface="Calibri" pitchFamily="34" charset="-120"/>
+              </a:rPr>
+              <a:t>WEEK 1 · KEY POINTS</a:t>
+            </a:r>
+            <a:endParaRPr lang="en-US" sz="1200" dirty="0"/>
+          </a:p>
+        </p:txBody>
+      </p:sp>
+      <p:sp>
+        <p:nvSpPr>
+          <p:cNvPr id="4" name="Text 2"/>
+          <p:cNvSpPr/>
+          <p:nvPr/>
+        </p:nvSpPr>
+        <p:spPr>
+          <a:xfrm>
+            <a:off x="640080" y="1005840"/>
+            <a:ext cx="10881360" cy="914400"/>
+          </a:xfrm>
+          <a:prstGeom prst="rect">
+            <a:avLst/>
+          </a:prstGeom>
+          <a:noFill/>
+          <a:ln/>
+        </p:spPr>
+        <p:txBody>
+          <a:bodyPr wrap="square" rtlCol="0" anchor="t">
+            <a:spAutoFit/>
+          </a:bodyPr>
           <a:lstStyle/>
           <a:p>
             <a:pPr indent="0" marL="0">
@@ -3570,7 +3784,7 @@
                 <a:ea typeface="Cambria" pitchFamily="34" charset="-122"/>
                 <a:cs typeface="Cambria" pitchFamily="34" charset="-120"/>
               </a:rPr>
-              <a:t>Three modes today</a:t>
+              <a:t>Counting, three shapes</a:t>
             </a:r>
             <a:endParaRPr lang="en-US" sz="3000" dirty="0"/>
           </a:p>
@@ -3578,134 +3792,98 @@
       </p:sp>
       <p:sp>
         <p:nvSpPr>
-          <p:cNvPr id="3" name="Text 1"/>
-          <p:cNvSpPr/>
-          <p:nvPr/>
-        </p:nvSpPr>
-        <p:spPr>
-          <a:xfrm>
-            <a:off x="640080" y="1417320"/>
-            <a:ext cx="10058400" cy="365760"/>
-          </a:xfrm>
-          <a:prstGeom prst="rect">
-            <a:avLst/>
-          </a:prstGeom>
-          <a:noFill/>
-          <a:ln/>
-        </p:spPr>
-        <p:txBody>
-          <a:bodyPr wrap="square" rtlCol="0" anchor="ctr"/>
-          <a:lstStyle/>
-          <a:p>
-            <a:pPr indent="0" marL="0">
-              <a:buNone/>
-            </a:pPr>
-            <a:r>
-              <a:rPr lang="en-US" sz="1400" i="1" dirty="0">
-                <a:solidFill>
-                  <a:srgbClr val="6B6B63"/>
+          <p:cNvPr id="5" name="Shape 3"/>
+          <p:cNvSpPr/>
+          <p:nvPr/>
+        </p:nvSpPr>
+        <p:spPr>
+          <a:xfrm>
+            <a:off x="640080" y="2331720"/>
+            <a:ext cx="201168" cy="201168"/>
+          </a:xfrm>
+          <a:prstGeom prst="ellipse">
+            <a:avLst/>
+          </a:prstGeom>
+          <a:solidFill>
+            <a:srgbClr val="7A3B2E"/>
+          </a:solidFill>
+          <a:ln/>
+        </p:spPr>
+      </p:sp>
+      <p:sp>
+        <p:nvSpPr>
+          <p:cNvPr id="6" name="Text 4"/>
+          <p:cNvSpPr/>
+          <p:nvPr/>
+        </p:nvSpPr>
+        <p:spPr>
+          <a:xfrm>
+            <a:off x="1097280" y="2240280"/>
+            <a:ext cx="10607040" cy="1017270"/>
+          </a:xfrm>
+          <a:prstGeom prst="rect">
+            <a:avLst/>
+          </a:prstGeom>
+          <a:noFill/>
+          <a:ln/>
+        </p:spPr>
+        <p:txBody>
+          <a:bodyPr wrap="square" rtlCol="0" anchor="t">
+            <a:spAutoFit/>
+          </a:bodyPr>
+          <a:lstStyle/>
+          <a:p>
+            <a:pPr indent="0" marL="0">
+              <a:lnSpc>
+                <a:spcPct val="112000"/>
+              </a:lnSpc>
+              <a:buNone/>
+            </a:pPr>
+            <a:r>
+              <a:rPr lang="en-US" sz="1650" dirty="0">
+                <a:solidFill>
+                  <a:srgbClr val="1A1A1A"/>
                 </a:solidFill>
                 <a:latin typeface="Calibri" pitchFamily="34" charset="0"/>
                 <a:ea typeface="Calibri" pitchFamily="34" charset="-122"/>
                 <a:cs typeface="Calibri" pitchFamily="34" charset="-120"/>
               </a:rPr>
-              <a:t>about a third of the session each</a:t>
-            </a:r>
-            <a:endParaRPr lang="en-US" sz="1400" dirty="0"/>
-          </a:p>
-        </p:txBody>
-      </p:sp>
-      <p:sp>
-        <p:nvSpPr>
-          <p:cNvPr id="4" name="Shape 2"/>
-          <p:cNvSpPr/>
-          <p:nvPr/>
-        </p:nvSpPr>
-        <p:spPr>
-          <a:xfrm>
-            <a:off x="640080" y="2194560"/>
-            <a:ext cx="3383280" cy="3291840"/>
-          </a:xfrm>
-          <a:prstGeom prst="roundRect">
-            <a:avLst>
-              <a:gd name="adj" fmla="val 3333"/>
-            </a:avLst>
-          </a:prstGeom>
-          <a:solidFill>
-            <a:srgbClr val="F4EEE8"/>
-          </a:solidFill>
-          <a:ln/>
-        </p:spPr>
-      </p:sp>
-      <p:sp>
-        <p:nvSpPr>
-          <p:cNvPr id="5" name="Shape 3"/>
-          <p:cNvSpPr/>
-          <p:nvPr/>
-        </p:nvSpPr>
-        <p:spPr>
-          <a:xfrm>
-            <a:off x="1051560" y="2606040"/>
-            <a:ext cx="548640" cy="548640"/>
+              <a:t>Rows: what share of brides kept their name, year by year. One groupby, one chart.</a:t>
+            </a:r>
+            <a:endParaRPr lang="en-US" sz="1650" dirty="0"/>
+          </a:p>
+        </p:txBody>
+      </p:sp>
+      <p:sp>
+        <p:nvSpPr>
+          <p:cNvPr id="7" name="Shape 5"/>
+          <p:cNvSpPr/>
+          <p:nvPr/>
+        </p:nvSpPr>
+        <p:spPr>
+          <a:xfrm>
+            <a:off x="640080" y="3348990"/>
+            <a:ext cx="201168" cy="201168"/>
           </a:xfrm>
           <a:prstGeom prst="ellipse">
             <a:avLst/>
           </a:prstGeom>
           <a:solidFill>
-            <a:srgbClr val="7A3B2E"/>
-          </a:solidFill>
-          <a:ln/>
-        </p:spPr>
-      </p:sp>
-      <p:sp>
-        <p:nvSpPr>
-          <p:cNvPr id="6" name="Text 4"/>
-          <p:cNvSpPr/>
-          <p:nvPr/>
-        </p:nvSpPr>
-        <p:spPr>
-          <a:xfrm>
-            <a:off x="1005840" y="3383280"/>
-            <a:ext cx="2651760" cy="548640"/>
-          </a:xfrm>
-          <a:prstGeom prst="rect">
-            <a:avLst/>
-          </a:prstGeom>
-          <a:noFill/>
-          <a:ln/>
-        </p:spPr>
-        <p:txBody>
-          <a:bodyPr wrap="square" rtlCol="0" anchor="ctr"/>
-          <a:lstStyle/>
-          <a:p>
-            <a:pPr indent="0" marL="0">
-              <a:buNone/>
-            </a:pPr>
-            <a:r>
-              <a:rPr lang="en-US" sz="2100" b="1" dirty="0">
-                <a:solidFill>
-                  <a:srgbClr val="1A1A1A"/>
-                </a:solidFill>
-                <a:latin typeface="Cambria" pitchFamily="34" charset="0"/>
-                <a:ea typeface="Cambria" pitchFamily="34" charset="-122"/>
-                <a:cs typeface="Cambria" pitchFamily="34" charset="-120"/>
-              </a:rPr>
-              <a:t>Lecture / demo</a:t>
-            </a:r>
-            <a:endParaRPr lang="en-US" sz="2100" dirty="0"/>
-          </a:p>
-        </p:txBody>
-      </p:sp>
-      <p:sp>
-        <p:nvSpPr>
-          <p:cNvPr id="7" name="Text 5"/>
-          <p:cNvSpPr/>
-          <p:nvPr/>
-        </p:nvSpPr>
-        <p:spPr>
-          <a:xfrm>
-            <a:off x="1005840" y="3977640"/>
-            <a:ext cx="2651760" cy="1371600"/>
+            <a:srgbClr val="3F6F5F"/>
+          </a:solidFill>
+          <a:ln/>
+        </p:spPr>
+      </p:sp>
+      <p:sp>
+        <p:nvSpPr>
+          <p:cNvPr id="8" name="Text 6"/>
+          <p:cNvSpPr/>
+          <p:nvPr/>
+        </p:nvSpPr>
+        <p:spPr>
+          <a:xfrm>
+            <a:off x="1097280" y="3257550"/>
+            <a:ext cx="10607040" cy="1017270"/>
           </a:xfrm>
           <a:prstGeom prst="rect">
             <a:avLst/>
@@ -3721,12 +3899,12 @@
           <a:p>
             <a:pPr indent="0" marL="0">
               <a:lnSpc>
-                <a:spcPct val="115000"/>
+                <a:spcPct val="112000"/>
               </a:lnSpc>
               <a:buNone/>
             </a:pPr>
             <a:r>
-              <a:rPr lang="en-US" sz="1500" dirty="0">
+              <a:rPr lang="en-US" sz="1650" dirty="0">
                 <a:solidFill>
                   <a:srgbClr val="1A1A1A"/>
                 </a:solidFill>
@@ -3734,33 +3912,11 @@
                 <a:ea typeface="Calibri" pitchFamily="34" charset="-122"/>
                 <a:cs typeface="Calibri" pitchFamily="34" charset="-120"/>
               </a:rPr>
-              <a:t>Counting: rows, words, pixels</a:t>
-            </a:r>
-            <a:endParaRPr lang="en-US" sz="1500" dirty="0"/>
-          </a:p>
-        </p:txBody>
-      </p:sp>
-      <p:sp>
-        <p:nvSpPr>
-          <p:cNvPr id="8" name="Shape 6"/>
-          <p:cNvSpPr/>
-          <p:nvPr/>
-        </p:nvSpPr>
-        <p:spPr>
-          <a:xfrm>
-            <a:off x="4526280" y="2194560"/>
-            <a:ext cx="3383280" cy="3291840"/>
-          </a:xfrm>
-          <a:prstGeom prst="roundRect">
-            <a:avLst>
-              <a:gd name="adj" fmla="val 3333"/>
-            </a:avLst>
-          </a:prstGeom>
-          <a:solidFill>
-            <a:srgbClr val="F4EEE8"/>
-          </a:solidFill>
-          <a:ln/>
-        </p:spPr>
+              <a:t>Words: the top words of a lyric are "the, and, you" until you remove stop-words. That removal is your first modeling choice.</a:t>
+            </a:r>
+            <a:endParaRPr lang="en-US" sz="1650" dirty="0"/>
+          </a:p>
+        </p:txBody>
       </p:sp>
       <p:sp>
         <p:nvSpPr>
@@ -3770,14 +3926,14 @@
         </p:nvSpPr>
         <p:spPr>
           <a:xfrm>
-            <a:off x="4937760" y="2606040"/>
-            <a:ext cx="548640" cy="548640"/>
+            <a:off x="640080" y="4366260"/>
+            <a:ext cx="201168" cy="201168"/>
           </a:xfrm>
           <a:prstGeom prst="ellipse">
             <a:avLst/>
           </a:prstGeom>
           <a:solidFill>
-            <a:srgbClr val="3F6F5F"/>
+            <a:srgbClr val="B9852F"/>
           </a:solidFill>
           <a:ln/>
         </p:spPr>
@@ -3790,47 +3946,8 @@
         </p:nvSpPr>
         <p:spPr>
           <a:xfrm>
-            <a:off x="4892040" y="3383280"/>
-            <a:ext cx="2651760" cy="548640"/>
-          </a:xfrm>
-          <a:prstGeom prst="rect">
-            <a:avLst/>
-          </a:prstGeom>
-          <a:noFill/>
-          <a:ln/>
-        </p:spPr>
-        <p:txBody>
-          <a:bodyPr wrap="square" rtlCol="0" anchor="ctr"/>
-          <a:lstStyle/>
-          <a:p>
-            <a:pPr indent="0" marL="0">
-              <a:buNone/>
-            </a:pPr>
-            <a:r>
-              <a:rPr lang="en-US" sz="2100" b="1" dirty="0">
-                <a:solidFill>
-                  <a:srgbClr val="1A1A1A"/>
-                </a:solidFill>
-                <a:latin typeface="Cambria" pitchFamily="34" charset="0"/>
-                <a:ea typeface="Cambria" pitchFamily="34" charset="-122"/>
-                <a:cs typeface="Cambria" pitchFamily="34" charset="-120"/>
-              </a:rPr>
-              <a:t>Workshop</a:t>
-            </a:r>
-            <a:endParaRPr lang="en-US" sz="2100" dirty="0"/>
-          </a:p>
-        </p:txBody>
-      </p:sp>
-      <p:sp>
-        <p:nvSpPr>
-          <p:cNvPr id="11" name="Text 9"/>
-          <p:cNvSpPr/>
-          <p:nvPr/>
-        </p:nvSpPr>
-        <p:spPr>
-          <a:xfrm>
-            <a:off x="4892040" y="3977640"/>
-            <a:ext cx="2651760" cy="1371600"/>
+            <a:off x="1097280" y="4274820"/>
+            <a:ext cx="10607040" cy="1017270"/>
           </a:xfrm>
           <a:prstGeom prst="rect">
             <a:avLst/>
@@ -3846,12 +3963,12 @@
           <a:p>
             <a:pPr indent="0" marL="0">
               <a:lnSpc>
-                <a:spcPct val="115000"/>
+                <a:spcPct val="112000"/>
               </a:lnSpc>
               <a:buNone/>
             </a:pPr>
             <a:r>
-              <a:rPr lang="en-US" sz="1500" dirty="0">
+              <a:rPr lang="en-US" sz="1650" dirty="0">
                 <a:solidFill>
                   <a:srgbClr val="1A1A1A"/>
                 </a:solidFill>
@@ -3859,103 +3976,42 @@
                 <a:ea typeface="Calibri" pitchFamily="34" charset="-122"/>
                 <a:cs typeface="Calibri" pitchFamily="34" charset="-120"/>
               </a:rPr>
-              <a:t>Build hands-on on your own data.</a:t>
-            </a:r>
-            <a:endParaRPr lang="en-US" sz="1500" dirty="0"/>
-          </a:p>
-        </p:txBody>
-      </p:sp>
-      <p:sp>
-        <p:nvSpPr>
-          <p:cNvPr id="12" name="Shape 10"/>
-          <p:cNvSpPr/>
-          <p:nvPr/>
-        </p:nvSpPr>
-        <p:spPr>
-          <a:xfrm>
-            <a:off x="8412480" y="2194560"/>
-            <a:ext cx="3383280" cy="3291840"/>
-          </a:xfrm>
-          <a:prstGeom prst="roundRect">
-            <a:avLst>
-              <a:gd name="adj" fmla="val 3333"/>
-            </a:avLst>
-          </a:prstGeom>
-          <a:solidFill>
-            <a:srgbClr val="F4EEE8"/>
-          </a:solidFill>
-          <a:ln/>
-        </p:spPr>
-      </p:sp>
-      <p:sp>
-        <p:nvSpPr>
-          <p:cNvPr id="13" name="Shape 11"/>
-          <p:cNvSpPr/>
-          <p:nvPr/>
-        </p:nvSpPr>
-        <p:spPr>
-          <a:xfrm>
-            <a:off x="8823960" y="2606040"/>
-            <a:ext cx="548640" cy="548640"/>
+              <a:t>Pixels: rank 200 Met thumbnails darkest to brightest from average luminance.</a:t>
+            </a:r>
+            <a:endParaRPr lang="en-US" sz="1650" dirty="0"/>
+          </a:p>
+        </p:txBody>
+      </p:sp>
+      <p:sp>
+        <p:nvSpPr>
+          <p:cNvPr id="11" name="Shape 9"/>
+          <p:cNvSpPr/>
+          <p:nvPr/>
+        </p:nvSpPr>
+        <p:spPr>
+          <a:xfrm>
+            <a:off x="640080" y="5383530"/>
+            <a:ext cx="201168" cy="201168"/>
           </a:xfrm>
           <a:prstGeom prst="ellipse">
             <a:avLst/>
           </a:prstGeom>
           <a:solidFill>
-            <a:srgbClr val="B9852F"/>
-          </a:solidFill>
-          <a:ln/>
-        </p:spPr>
-      </p:sp>
-      <p:sp>
-        <p:nvSpPr>
-          <p:cNvPr id="14" name="Text 12"/>
-          <p:cNvSpPr/>
-          <p:nvPr/>
-        </p:nvSpPr>
-        <p:spPr>
-          <a:xfrm>
-            <a:off x="8778240" y="3383280"/>
-            <a:ext cx="2651760" cy="548640"/>
-          </a:xfrm>
-          <a:prstGeom prst="rect">
-            <a:avLst/>
-          </a:prstGeom>
-          <a:noFill/>
-          <a:ln/>
-        </p:spPr>
-        <p:txBody>
-          <a:bodyPr wrap="square" rtlCol="0" anchor="ctr"/>
-          <a:lstStyle/>
-          <a:p>
-            <a:pPr indent="0" marL="0">
-              <a:buNone/>
-            </a:pPr>
-            <a:r>
-              <a:rPr lang="en-US" sz="2100" b="1" dirty="0">
-                <a:solidFill>
-                  <a:srgbClr val="1A1A1A"/>
-                </a:solidFill>
-                <a:latin typeface="Cambria" pitchFamily="34" charset="0"/>
-                <a:ea typeface="Cambria" pitchFamily="34" charset="-122"/>
-                <a:cs typeface="Cambria" pitchFamily="34" charset="-120"/>
-              </a:rPr>
-              <a:t>Discussion</a:t>
-            </a:r>
-            <a:endParaRPr lang="en-US" sz="2100" dirty="0"/>
-          </a:p>
-        </p:txBody>
-      </p:sp>
-      <p:sp>
-        <p:nvSpPr>
-          <p:cNvPr id="15" name="Text 13"/>
-          <p:cNvSpPr/>
-          <p:nvPr/>
-        </p:nvSpPr>
-        <p:spPr>
-          <a:xfrm>
-            <a:off x="8778240" y="3977640"/>
-            <a:ext cx="2651760" cy="1371600"/>
+            <a:srgbClr val="7A3B2E"/>
+          </a:solidFill>
+          <a:ln/>
+        </p:spPr>
+      </p:sp>
+      <p:sp>
+        <p:nvSpPr>
+          <p:cNvPr id="12" name="Text 10"/>
+          <p:cNvSpPr/>
+          <p:nvPr/>
+        </p:nvSpPr>
+        <p:spPr>
+          <a:xfrm>
+            <a:off x="1097280" y="5292090"/>
+            <a:ext cx="10607040" cy="1017270"/>
           </a:xfrm>
           <a:prstGeom prst="rect">
             <a:avLst/>
@@ -3971,12 +4027,12 @@
           <a:p>
             <a:pPr indent="0" marL="0">
               <a:lnSpc>
-                <a:spcPct val="115000"/>
+                <a:spcPct val="112000"/>
               </a:lnSpc>
               <a:buNone/>
             </a:pPr>
             <a:r>
-              <a:rPr lang="en-US" sz="1500" dirty="0">
+              <a:rPr lang="en-US" sz="1650" dirty="0">
                 <a:solidFill>
                   <a:srgbClr val="1A1A1A"/>
                 </a:solidFill>
@@ -3984,9 +4040,9 @@
                 <a:ea typeface="Calibri" pitchFamily="34" charset="-122"/>
                 <a:cs typeface="Calibri" pitchFamily="34" charset="-120"/>
               </a:rPr>
-              <a:t>Interrogate the study, debate it, or critique each other's work.</a:t>
-            </a:r>
-            <a:endParaRPr lang="en-US" sz="1500" dirty="0"/>
+              <a:t>The same technique three times, each containing a decision.</a:t>
+            </a:r>
+            <a:endParaRPr lang="en-US" sz="1650" dirty="0"/>
           </a:p>
         </p:txBody>
       </p:sp>
@@ -4030,7 +4086,7 @@
         </p:nvSpPr>
         <p:spPr>
           <a:xfrm>
-            <a:off x="640080" y="640080"/>
+            <a:off x="640080" y="731520"/>
             <a:ext cx="10058400" cy="731520"/>
           </a:xfrm>
           <a:prstGeom prst="rect">
@@ -4055,7 +4111,7 @@
                 <a:ea typeface="Cambria" pitchFamily="34" charset="-122"/>
                 <a:cs typeface="Cambria" pitchFamily="34" charset="-120"/>
               </a:rPr>
-              <a:t>The session</a:t>
+              <a:t>Three modes today</a:t>
             </a:r>
             <a:endParaRPr lang="en-US" sz="3000" dirty="0"/>
           </a:p>
@@ -4063,36 +4119,14 @@
       </p:sp>
       <p:sp>
         <p:nvSpPr>
-          <p:cNvPr id="3" name="Shape 1"/>
-          <p:cNvSpPr/>
-          <p:nvPr/>
-        </p:nvSpPr>
-        <p:spPr>
-          <a:xfrm>
-            <a:off x="640080" y="1572768"/>
-            <a:ext cx="868680" cy="450342"/>
-          </a:xfrm>
-          <a:prstGeom prst="roundRect">
-            <a:avLst>
-              <a:gd name="adj" fmla="val 12183"/>
-            </a:avLst>
-          </a:prstGeom>
-          <a:solidFill>
-            <a:srgbClr val="7A3B2E"/>
-          </a:solidFill>
-          <a:ln/>
-        </p:spPr>
-      </p:sp>
-      <p:sp>
-        <p:nvSpPr>
-          <p:cNvPr id="4" name="Text 2"/>
-          <p:cNvSpPr/>
-          <p:nvPr/>
-        </p:nvSpPr>
-        <p:spPr>
-          <a:xfrm>
-            <a:off x="640080" y="1572768"/>
-            <a:ext cx="868680" cy="450342"/>
+          <p:cNvPr id="3" name="Text 1"/>
+          <p:cNvSpPr/>
+          <p:nvPr/>
+        </p:nvSpPr>
+        <p:spPr>
+          <a:xfrm>
+            <a:off x="640080" y="1417320"/>
+            <a:ext cx="10058400" cy="365760"/>
           </a:xfrm>
           <a:prstGeom prst="rect">
             <a:avLst/>
@@ -4104,52 +4138,136 @@
           <a:bodyPr wrap="square" rtlCol="0" anchor="ctr"/>
           <a:lstStyle/>
           <a:p>
-            <a:pPr algn="ctr" indent="0" marL="0">
-              <a:buNone/>
-            </a:pPr>
-            <a:r>
-              <a:rPr lang="en-US" sz="1100" b="1" dirty="0">
-                <a:solidFill>
-                  <a:srgbClr val="FFFFFF"/>
+            <a:pPr indent="0" marL="0">
+              <a:buNone/>
+            </a:pPr>
+            <a:r>
+              <a:rPr lang="en-US" sz="1400" i="1" dirty="0">
+                <a:solidFill>
+                  <a:srgbClr val="6B6B63"/>
                 </a:solidFill>
                 <a:latin typeface="Calibri" pitchFamily="34" charset="0"/>
                 <a:ea typeface="Calibri" pitchFamily="34" charset="-122"/>
                 <a:cs typeface="Calibri" pitchFamily="34" charset="-120"/>
               </a:rPr>
-              <a:t>0:00</a:t>
-            </a:r>
-            <a:endParaRPr lang="en-US" sz="1100" dirty="0"/>
-          </a:p>
-        </p:txBody>
-      </p:sp>
-      <p:sp>
-        <p:nvSpPr>
-          <p:cNvPr id="5" name="Text 3"/>
-          <p:cNvSpPr/>
-          <p:nvPr/>
-        </p:nvSpPr>
-        <p:spPr>
-          <a:xfrm>
-            <a:off x="1691640" y="1554480"/>
-            <a:ext cx="9646920" cy="560070"/>
-          </a:xfrm>
-          <a:prstGeom prst="rect">
-            <a:avLst/>
-          </a:prstGeom>
-          <a:noFill/>
-          <a:ln/>
-        </p:spPr>
-        <p:txBody>
-          <a:bodyPr wrap="square" rtlCol="0" anchor="ctr">
+              <a:t>about a third of the session each</a:t>
+            </a:r>
+            <a:endParaRPr lang="en-US" sz="1400" dirty="0"/>
+          </a:p>
+        </p:txBody>
+      </p:sp>
+      <p:sp>
+        <p:nvSpPr>
+          <p:cNvPr id="4" name="Shape 2"/>
+          <p:cNvSpPr/>
+          <p:nvPr/>
+        </p:nvSpPr>
+        <p:spPr>
+          <a:xfrm>
+            <a:off x="640080" y="2194560"/>
+            <a:ext cx="3383280" cy="3291840"/>
+          </a:xfrm>
+          <a:prstGeom prst="roundRect">
+            <a:avLst>
+              <a:gd name="adj" fmla="val 3333"/>
+            </a:avLst>
+          </a:prstGeom>
+          <a:solidFill>
+            <a:srgbClr val="F4EEE8"/>
+          </a:solidFill>
+          <a:ln/>
+        </p:spPr>
+      </p:sp>
+      <p:sp>
+        <p:nvSpPr>
+          <p:cNvPr id="5" name="Shape 3"/>
+          <p:cNvSpPr/>
+          <p:nvPr/>
+        </p:nvSpPr>
+        <p:spPr>
+          <a:xfrm>
+            <a:off x="1051560" y="2606040"/>
+            <a:ext cx="548640" cy="548640"/>
+          </a:xfrm>
+          <a:prstGeom prst="ellipse">
+            <a:avLst/>
+          </a:prstGeom>
+          <a:solidFill>
+            <a:srgbClr val="7A3B2E"/>
+          </a:solidFill>
+          <a:ln/>
+        </p:spPr>
+      </p:sp>
+      <p:sp>
+        <p:nvSpPr>
+          <p:cNvPr id="6" name="Text 4"/>
+          <p:cNvSpPr/>
+          <p:nvPr/>
+        </p:nvSpPr>
+        <p:spPr>
+          <a:xfrm>
+            <a:off x="1005840" y="3383280"/>
+            <a:ext cx="2651760" cy="548640"/>
+          </a:xfrm>
+          <a:prstGeom prst="rect">
+            <a:avLst/>
+          </a:prstGeom>
+          <a:noFill/>
+          <a:ln/>
+        </p:spPr>
+        <p:txBody>
+          <a:bodyPr wrap="square" rtlCol="0" anchor="ctr"/>
+          <a:lstStyle/>
+          <a:p>
+            <a:pPr indent="0" marL="0">
+              <a:buNone/>
+            </a:pPr>
+            <a:r>
+              <a:rPr lang="en-US" sz="2100" b="1" dirty="0">
+                <a:solidFill>
+                  <a:srgbClr val="1A1A1A"/>
+                </a:solidFill>
+                <a:latin typeface="Cambria" pitchFamily="34" charset="0"/>
+                <a:ea typeface="Cambria" pitchFamily="34" charset="-122"/>
+                <a:cs typeface="Cambria" pitchFamily="34" charset="-120"/>
+              </a:rPr>
+              <a:t>Lecture / demo</a:t>
+            </a:r>
+            <a:endParaRPr lang="en-US" sz="2100" dirty="0"/>
+          </a:p>
+        </p:txBody>
+      </p:sp>
+      <p:sp>
+        <p:nvSpPr>
+          <p:cNvPr id="7" name="Text 5"/>
+          <p:cNvSpPr/>
+          <p:nvPr/>
+        </p:nvSpPr>
+        <p:spPr>
+          <a:xfrm>
+            <a:off x="1005840" y="3977640"/>
+            <a:ext cx="2651760" cy="1371600"/>
+          </a:xfrm>
+          <a:prstGeom prst="rect">
+            <a:avLst/>
+          </a:prstGeom>
+          <a:noFill/>
+          <a:ln/>
+        </p:spPr>
+        <p:txBody>
+          <a:bodyPr wrap="square" rtlCol="0" anchor="t">
             <a:spAutoFit/>
           </a:bodyPr>
           <a:lstStyle/>
           <a:p>
             <a:pPr indent="0" marL="0">
-              <a:buNone/>
-            </a:pPr>
-            <a:r>
-              <a:rPr lang="en-US" sz="1100" dirty="0">
+              <a:lnSpc>
+                <a:spcPct val="115000"/>
+              </a:lnSpc>
+              <a:buNone/>
+            </a:pPr>
+            <a:r>
+              <a:rPr lang="en-US" sz="1500" dirty="0">
                 <a:solidFill>
                   <a:srgbClr val="1A1A1A"/>
                 </a:solidFill>
@@ -4157,44 +4275,64 @@
                 <a:ea typeface="Calibri" pitchFamily="34" charset="-122"/>
                 <a:cs typeface="Calibri" pitchFamily="34" charset="-120"/>
               </a:rPr>
-              <a:t>Introductions and working agreements, demonstrated in practice. Today's live coding deliberately includes real mistakes.</a:t>
-            </a:r>
-            <a:endParaRPr lang="en-US" sz="1100" dirty="0"/>
-          </a:p>
-        </p:txBody>
-      </p:sp>
-      <p:sp>
-        <p:nvSpPr>
-          <p:cNvPr id="6" name="Shape 4"/>
-          <p:cNvSpPr/>
-          <p:nvPr/>
-        </p:nvSpPr>
-        <p:spPr>
-          <a:xfrm>
-            <a:off x="640080" y="2132838"/>
-            <a:ext cx="868680" cy="450342"/>
+              <a:t>Counting: rows, words, pixels</a:t>
+            </a:r>
+            <a:endParaRPr lang="en-US" sz="1500" dirty="0"/>
+          </a:p>
+        </p:txBody>
+      </p:sp>
+      <p:sp>
+        <p:nvSpPr>
+          <p:cNvPr id="8" name="Shape 6"/>
+          <p:cNvSpPr/>
+          <p:nvPr/>
+        </p:nvSpPr>
+        <p:spPr>
+          <a:xfrm>
+            <a:off x="4526280" y="2194560"/>
+            <a:ext cx="3383280" cy="3291840"/>
           </a:xfrm>
           <a:prstGeom prst="roundRect">
             <a:avLst>
-              <a:gd name="adj" fmla="val 12183"/>
+              <a:gd name="adj" fmla="val 3333"/>
             </a:avLst>
           </a:prstGeom>
           <a:solidFill>
-            <a:srgbClr val="7A3B2E"/>
-          </a:solidFill>
-          <a:ln/>
-        </p:spPr>
-      </p:sp>
-      <p:sp>
-        <p:nvSpPr>
-          <p:cNvPr id="7" name="Text 5"/>
-          <p:cNvSpPr/>
-          <p:nvPr/>
-        </p:nvSpPr>
-        <p:spPr>
-          <a:xfrm>
-            <a:off x="640080" y="2132838"/>
-            <a:ext cx="868680" cy="450342"/>
+            <a:srgbClr val="F4EEE8"/>
+          </a:solidFill>
+          <a:ln/>
+        </p:spPr>
+      </p:sp>
+      <p:sp>
+        <p:nvSpPr>
+          <p:cNvPr id="9" name="Shape 7"/>
+          <p:cNvSpPr/>
+          <p:nvPr/>
+        </p:nvSpPr>
+        <p:spPr>
+          <a:xfrm>
+            <a:off x="4937760" y="2606040"/>
+            <a:ext cx="548640" cy="548640"/>
+          </a:xfrm>
+          <a:prstGeom prst="ellipse">
+            <a:avLst/>
+          </a:prstGeom>
+          <a:solidFill>
+            <a:srgbClr val="3F6F5F"/>
+          </a:solidFill>
+          <a:ln/>
+        </p:spPr>
+      </p:sp>
+      <p:sp>
+        <p:nvSpPr>
+          <p:cNvPr id="10" name="Text 8"/>
+          <p:cNvSpPr/>
+          <p:nvPr/>
+        </p:nvSpPr>
+        <p:spPr>
+          <a:xfrm>
+            <a:off x="4892040" y="3383280"/>
+            <a:ext cx="2651760" cy="548640"/>
           </a:xfrm>
           <a:prstGeom prst="rect">
             <a:avLst/>
@@ -4206,52 +4344,180 @@
           <a:bodyPr wrap="square" rtlCol="0" anchor="ctr"/>
           <a:lstStyle/>
           <a:p>
-            <a:pPr algn="ctr" indent="0" marL="0">
-              <a:buNone/>
-            </a:pPr>
-            <a:r>
-              <a:rPr lang="en-US" sz="1100" b="1" dirty="0">
-                <a:solidFill>
-                  <a:srgbClr val="FFFFFF"/>
+            <a:pPr indent="0" marL="0">
+              <a:buNone/>
+            </a:pPr>
+            <a:r>
+              <a:rPr lang="en-US" sz="2100" b="1" dirty="0">
+                <a:solidFill>
+                  <a:srgbClr val="1A1A1A"/>
+                </a:solidFill>
+                <a:latin typeface="Cambria" pitchFamily="34" charset="0"/>
+                <a:ea typeface="Cambria" pitchFamily="34" charset="-122"/>
+                <a:cs typeface="Cambria" pitchFamily="34" charset="-120"/>
+              </a:rPr>
+              <a:t>Workshop</a:t>
+            </a:r>
+            <a:endParaRPr lang="en-US" sz="2100" dirty="0"/>
+          </a:p>
+        </p:txBody>
+      </p:sp>
+      <p:sp>
+        <p:nvSpPr>
+          <p:cNvPr id="11" name="Text 9"/>
+          <p:cNvSpPr/>
+          <p:nvPr/>
+        </p:nvSpPr>
+        <p:spPr>
+          <a:xfrm>
+            <a:off x="4892040" y="3977640"/>
+            <a:ext cx="2651760" cy="1371600"/>
+          </a:xfrm>
+          <a:prstGeom prst="rect">
+            <a:avLst/>
+          </a:prstGeom>
+          <a:noFill/>
+          <a:ln/>
+        </p:spPr>
+        <p:txBody>
+          <a:bodyPr wrap="square" rtlCol="0" anchor="t">
+            <a:spAutoFit/>
+          </a:bodyPr>
+          <a:lstStyle/>
+          <a:p>
+            <a:pPr indent="0" marL="0">
+              <a:lnSpc>
+                <a:spcPct val="115000"/>
+              </a:lnSpc>
+              <a:buNone/>
+            </a:pPr>
+            <a:r>
+              <a:rPr lang="en-US" sz="1500" dirty="0">
+                <a:solidFill>
+                  <a:srgbClr val="1A1A1A"/>
                 </a:solidFill>
                 <a:latin typeface="Calibri" pitchFamily="34" charset="0"/>
                 <a:ea typeface="Calibri" pitchFamily="34" charset="-122"/>
                 <a:cs typeface="Calibri" pitchFamily="34" charset="-120"/>
               </a:rPr>
-              <a:t>0:10</a:t>
-            </a:r>
-            <a:endParaRPr lang="en-US" sz="1100" dirty="0"/>
-          </a:p>
-        </p:txBody>
-      </p:sp>
-      <p:sp>
-        <p:nvSpPr>
-          <p:cNvPr id="8" name="Text 6"/>
-          <p:cNvSpPr/>
-          <p:nvPr/>
-        </p:nvSpPr>
-        <p:spPr>
-          <a:xfrm>
-            <a:off x="1691640" y="2114550"/>
-            <a:ext cx="9646920" cy="560070"/>
-          </a:xfrm>
-          <a:prstGeom prst="rect">
-            <a:avLst/>
-          </a:prstGeom>
-          <a:noFill/>
-          <a:ln/>
-        </p:spPr>
-        <p:txBody>
-          <a:bodyPr wrap="square" rtlCol="0" anchor="ctr">
+              <a:t>Build hands-on on your own data.</a:t>
+            </a:r>
+            <a:endParaRPr lang="en-US" sz="1500" dirty="0"/>
+          </a:p>
+        </p:txBody>
+      </p:sp>
+      <p:sp>
+        <p:nvSpPr>
+          <p:cNvPr id="12" name="Shape 10"/>
+          <p:cNvSpPr/>
+          <p:nvPr/>
+        </p:nvSpPr>
+        <p:spPr>
+          <a:xfrm>
+            <a:off x="8412480" y="2194560"/>
+            <a:ext cx="3383280" cy="3291840"/>
+          </a:xfrm>
+          <a:prstGeom prst="roundRect">
+            <a:avLst>
+              <a:gd name="adj" fmla="val 3333"/>
+            </a:avLst>
+          </a:prstGeom>
+          <a:solidFill>
+            <a:srgbClr val="F4EEE8"/>
+          </a:solidFill>
+          <a:ln/>
+        </p:spPr>
+      </p:sp>
+      <p:sp>
+        <p:nvSpPr>
+          <p:cNvPr id="13" name="Shape 11"/>
+          <p:cNvSpPr/>
+          <p:nvPr/>
+        </p:nvSpPr>
+        <p:spPr>
+          <a:xfrm>
+            <a:off x="8823960" y="2606040"/>
+            <a:ext cx="548640" cy="548640"/>
+          </a:xfrm>
+          <a:prstGeom prst="ellipse">
+            <a:avLst/>
+          </a:prstGeom>
+          <a:solidFill>
+            <a:srgbClr val="B9852F"/>
+          </a:solidFill>
+          <a:ln/>
+        </p:spPr>
+      </p:sp>
+      <p:sp>
+        <p:nvSpPr>
+          <p:cNvPr id="14" name="Text 12"/>
+          <p:cNvSpPr/>
+          <p:nvPr/>
+        </p:nvSpPr>
+        <p:spPr>
+          <a:xfrm>
+            <a:off x="8778240" y="3383280"/>
+            <a:ext cx="2651760" cy="548640"/>
+          </a:xfrm>
+          <a:prstGeom prst="rect">
+            <a:avLst/>
+          </a:prstGeom>
+          <a:noFill/>
+          <a:ln/>
+        </p:spPr>
+        <p:txBody>
+          <a:bodyPr wrap="square" rtlCol="0" anchor="ctr"/>
+          <a:lstStyle/>
+          <a:p>
+            <a:pPr indent="0" marL="0">
+              <a:buNone/>
+            </a:pPr>
+            <a:r>
+              <a:rPr lang="en-US" sz="2100" b="1" dirty="0">
+                <a:solidFill>
+                  <a:srgbClr val="1A1A1A"/>
+                </a:solidFill>
+                <a:latin typeface="Cambria" pitchFamily="34" charset="0"/>
+                <a:ea typeface="Cambria" pitchFamily="34" charset="-122"/>
+                <a:cs typeface="Cambria" pitchFamily="34" charset="-120"/>
+              </a:rPr>
+              <a:t>Discussion</a:t>
+            </a:r>
+            <a:endParaRPr lang="en-US" sz="2100" dirty="0"/>
+          </a:p>
+        </p:txBody>
+      </p:sp>
+      <p:sp>
+        <p:nvSpPr>
+          <p:cNvPr id="15" name="Text 13"/>
+          <p:cNvSpPr/>
+          <p:nvPr/>
+        </p:nvSpPr>
+        <p:spPr>
+          <a:xfrm>
+            <a:off x="8778240" y="3977640"/>
+            <a:ext cx="2651760" cy="1371600"/>
+          </a:xfrm>
+          <a:prstGeom prst="rect">
+            <a:avLst/>
+          </a:prstGeom>
+          <a:noFill/>
+          <a:ln/>
+        </p:spPr>
+        <p:txBody>
+          <a:bodyPr wrap="square" rtlCol="0" anchor="t">
             <a:spAutoFit/>
           </a:bodyPr>
           <a:lstStyle/>
           <a:p>
             <a:pPr indent="0" marL="0">
-              <a:buNone/>
-            </a:pPr>
-            <a:r>
-              <a:rPr lang="en-US" sz="1100" dirty="0">
+              <a:lnSpc>
+                <a:spcPct val="115000"/>
+              </a:lnSpc>
+              <a:buNone/>
+            </a:pPr>
+            <a:r>
+              <a:rPr lang="en-US" sz="1500" dirty="0">
                 <a:solidFill>
                   <a:srgbClr val="1A1A1A"/>
                 </a:solidFill>
@@ -4259,621 +4525,9 @@
                 <a:ea typeface="Calibri" pitchFamily="34" charset="-122"/>
                 <a:cs typeface="Calibri" pitchFamily="34" charset="-120"/>
               </a:rPr>
-              <a:t>Lecture, the stakes: machines already read culture at scale, the feed ranking what you see, the moderation filter, the model trained on scraped art and prose, and that reading happens without you. Counting culture has produced real knowledge (the screenplay verb split, the Rowling unmasking, pop music's 1991 revolution) and real mistakes, and both look identical until someone checks. In ten weeks you do the reading yourself and publish something checkable.</a:t>
-            </a:r>
-            <a:endParaRPr lang="en-US" sz="1100" dirty="0"/>
-          </a:p>
-        </p:txBody>
-      </p:sp>
-      <p:sp>
-        <p:nvSpPr>
-          <p:cNvPr id="9" name="Shape 7"/>
-          <p:cNvSpPr/>
-          <p:nvPr/>
-        </p:nvSpPr>
-        <p:spPr>
-          <a:xfrm>
-            <a:off x="640080" y="2692908"/>
-            <a:ext cx="868680" cy="450342"/>
-          </a:xfrm>
-          <a:prstGeom prst="roundRect">
-            <a:avLst>
-              <a:gd name="adj" fmla="val 12183"/>
-            </a:avLst>
-          </a:prstGeom>
-          <a:solidFill>
-            <a:srgbClr val="7A3B2E"/>
-          </a:solidFill>
-          <a:ln/>
-        </p:spPr>
-      </p:sp>
-      <p:sp>
-        <p:nvSpPr>
-          <p:cNvPr id="10" name="Text 8"/>
-          <p:cNvSpPr/>
-          <p:nvPr/>
-        </p:nvSpPr>
-        <p:spPr>
-          <a:xfrm>
-            <a:off x="640080" y="2692908"/>
-            <a:ext cx="868680" cy="450342"/>
-          </a:xfrm>
-          <a:prstGeom prst="rect">
-            <a:avLst/>
-          </a:prstGeom>
-          <a:noFill/>
-          <a:ln/>
-        </p:spPr>
-        <p:txBody>
-          <a:bodyPr wrap="square" rtlCol="0" anchor="ctr"/>
-          <a:lstStyle/>
-          <a:p>
-            <a:pPr algn="ctr" indent="0" marL="0">
-              <a:buNone/>
-            </a:pPr>
-            <a:r>
-              <a:rPr lang="en-US" sz="1100" b="1" dirty="0">
-                <a:solidFill>
-                  <a:srgbClr val="FFFFFF"/>
-                </a:solidFill>
-                <a:latin typeface="Calibri" pitchFamily="34" charset="0"/>
-                <a:ea typeface="Calibri" pitchFamily="34" charset="-122"/>
-                <a:cs typeface="Calibri" pitchFamily="34" charset="-120"/>
-              </a:rPr>
-              <a:t>0:28</a:t>
-            </a:r>
-            <a:endParaRPr lang="en-US" sz="1100" dirty="0"/>
-          </a:p>
-        </p:txBody>
-      </p:sp>
-      <p:sp>
-        <p:nvSpPr>
-          <p:cNvPr id="11" name="Text 9"/>
-          <p:cNvSpPr/>
-          <p:nvPr/>
-        </p:nvSpPr>
-        <p:spPr>
-          <a:xfrm>
-            <a:off x="1691640" y="2674620"/>
-            <a:ext cx="9646920" cy="560070"/>
-          </a:xfrm>
-          <a:prstGeom prst="rect">
-            <a:avLst/>
-          </a:prstGeom>
-          <a:noFill/>
-          <a:ln/>
-        </p:spPr>
-        <p:txBody>
-          <a:bodyPr wrap="square" rtlCol="0" anchor="ctr">
-            <a:spAutoFit/>
-          </a:bodyPr>
-          <a:lstStyle/>
-          <a:p>
-            <a:pPr indent="0" marL="0">
-              <a:buNone/>
-            </a:pPr>
-            <a:r>
-              <a:rPr lang="en-US" sz="1100" dirty="0">
-                <a:solidFill>
-                  <a:srgbClr val="1A1A1A"/>
-                </a:solidFill>
-                <a:latin typeface="Calibri" pitchFamily="34" charset="0"/>
-                <a:ea typeface="Calibri" pitchFamily="34" charset="-122"/>
-                <a:cs typeface="Calibri" pitchFamily="34" charset="-120"/>
-              </a:rPr>
-              <a:t>Look at This, then Question It: She Giggles, He Gallops.</a:t>
-            </a:r>
-            <a:endParaRPr lang="en-US" sz="1100" dirty="0"/>
-          </a:p>
-        </p:txBody>
-      </p:sp>
-      <p:sp>
-        <p:nvSpPr>
-          <p:cNvPr id="12" name="Shape 10"/>
-          <p:cNvSpPr/>
-          <p:nvPr/>
-        </p:nvSpPr>
-        <p:spPr>
-          <a:xfrm>
-            <a:off x="640080" y="3252978"/>
-            <a:ext cx="868680" cy="450342"/>
-          </a:xfrm>
-          <a:prstGeom prst="roundRect">
-            <a:avLst>
-              <a:gd name="adj" fmla="val 12183"/>
-            </a:avLst>
-          </a:prstGeom>
-          <a:solidFill>
-            <a:srgbClr val="7A3B2E"/>
-          </a:solidFill>
-          <a:ln/>
-        </p:spPr>
-      </p:sp>
-      <p:sp>
-        <p:nvSpPr>
-          <p:cNvPr id="13" name="Text 11"/>
-          <p:cNvSpPr/>
-          <p:nvPr/>
-        </p:nvSpPr>
-        <p:spPr>
-          <a:xfrm>
-            <a:off x="640080" y="3252978"/>
-            <a:ext cx="868680" cy="450342"/>
-          </a:xfrm>
-          <a:prstGeom prst="rect">
-            <a:avLst/>
-          </a:prstGeom>
-          <a:noFill/>
-          <a:ln/>
-        </p:spPr>
-        <p:txBody>
-          <a:bodyPr wrap="square" rtlCol="0" anchor="ctr"/>
-          <a:lstStyle/>
-          <a:p>
-            <a:pPr algn="ctr" indent="0" marL="0">
-              <a:buNone/>
-            </a:pPr>
-            <a:r>
-              <a:rPr lang="en-US" sz="1100" b="1" dirty="0">
-                <a:solidFill>
-                  <a:srgbClr val="FFFFFF"/>
-                </a:solidFill>
-                <a:latin typeface="Calibri" pitchFamily="34" charset="0"/>
-                <a:ea typeface="Calibri" pitchFamily="34" charset="-122"/>
-                <a:cs typeface="Calibri" pitchFamily="34" charset="-120"/>
-              </a:rPr>
-              <a:t>0:35</a:t>
-            </a:r>
-            <a:endParaRPr lang="en-US" sz="1100" dirty="0"/>
-          </a:p>
-        </p:txBody>
-      </p:sp>
-      <p:sp>
-        <p:nvSpPr>
-          <p:cNvPr id="14" name="Text 12"/>
-          <p:cNvSpPr/>
-          <p:nvPr/>
-        </p:nvSpPr>
-        <p:spPr>
-          <a:xfrm>
-            <a:off x="1691640" y="3234690"/>
-            <a:ext cx="9646920" cy="560070"/>
-          </a:xfrm>
-          <a:prstGeom prst="rect">
-            <a:avLst/>
-          </a:prstGeom>
-          <a:noFill/>
-          <a:ln/>
-        </p:spPr>
-        <p:txBody>
-          <a:bodyPr wrap="square" rtlCol="0" anchor="ctr">
-            <a:spAutoFit/>
-          </a:bodyPr>
-          <a:lstStyle/>
-          <a:p>
-            <a:pPr indent="0" marL="0">
-              <a:buNone/>
-            </a:pPr>
-            <a:r>
-              <a:rPr lang="en-US" sz="1100" dirty="0">
-                <a:solidFill>
-                  <a:srgbClr val="1A1A1A"/>
-                </a:solidFill>
-                <a:latin typeface="Calibri" pitchFamily="34" charset="0"/>
-                <a:ea typeface="Calibri" pitchFamily="34" charset="-122"/>
-                <a:cs typeface="Calibri" pitchFamily="34" charset="-120"/>
-              </a:rPr>
-              <a:t>The vocabulary and the map (no code): corpus, method, model, embedding, plus what data itself is. A CSV, anatomized on screen (rows are observations, columns are recorded facts), and Drucker's correction: data is capta, taken not given. Two minutes in pairs: what did the makers of the wedding table take, and what did they leave out? The deliverable, shown: a web essay on a runnable notebook.</a:t>
-            </a:r>
-            <a:endParaRPr lang="en-US" sz="1100" dirty="0"/>
-          </a:p>
-        </p:txBody>
-      </p:sp>
-      <p:sp>
-        <p:nvSpPr>
-          <p:cNvPr id="15" name="Shape 13"/>
-          <p:cNvSpPr/>
-          <p:nvPr/>
-        </p:nvSpPr>
-        <p:spPr>
-          <a:xfrm>
-            <a:off x="640080" y="3813048"/>
-            <a:ext cx="868680" cy="450342"/>
-          </a:xfrm>
-          <a:prstGeom prst="roundRect">
-            <a:avLst>
-              <a:gd name="adj" fmla="val 12183"/>
-            </a:avLst>
-          </a:prstGeom>
-          <a:solidFill>
-            <a:srgbClr val="7A3B2E"/>
-          </a:solidFill>
-          <a:ln/>
-        </p:spPr>
-      </p:sp>
-      <p:sp>
-        <p:nvSpPr>
-          <p:cNvPr id="16" name="Text 14"/>
-          <p:cNvSpPr/>
-          <p:nvPr/>
-        </p:nvSpPr>
-        <p:spPr>
-          <a:xfrm>
-            <a:off x="640080" y="3813048"/>
-            <a:ext cx="868680" cy="450342"/>
-          </a:xfrm>
-          <a:prstGeom prst="rect">
-            <a:avLst/>
-          </a:prstGeom>
-          <a:noFill/>
-          <a:ln/>
-        </p:spPr>
-        <p:txBody>
-          <a:bodyPr wrap="square" rtlCol="0" anchor="ctr"/>
-          <a:lstStyle/>
-          <a:p>
-            <a:pPr algn="ctr" indent="0" marL="0">
-              <a:buNone/>
-            </a:pPr>
-            <a:r>
-              <a:rPr lang="en-US" sz="1100" b="1" dirty="0">
-                <a:solidFill>
-                  <a:srgbClr val="FFFFFF"/>
-                </a:solidFill>
-                <a:latin typeface="Calibri" pitchFamily="34" charset="0"/>
-                <a:ea typeface="Calibri" pitchFamily="34" charset="-122"/>
-                <a:cs typeface="Calibri" pitchFamily="34" charset="-120"/>
-              </a:rPr>
-              <a:t>0:47</a:t>
-            </a:r>
-            <a:endParaRPr lang="en-US" sz="1100" dirty="0"/>
-          </a:p>
-        </p:txBody>
-      </p:sp>
-      <p:sp>
-        <p:nvSpPr>
-          <p:cNvPr id="17" name="Text 15"/>
-          <p:cNvSpPr/>
-          <p:nvPr/>
-        </p:nvSpPr>
-        <p:spPr>
-          <a:xfrm>
-            <a:off x="1691640" y="3794760"/>
-            <a:ext cx="9646920" cy="560070"/>
-          </a:xfrm>
-          <a:prstGeom prst="rect">
-            <a:avLst/>
-          </a:prstGeom>
-          <a:noFill/>
-          <a:ln/>
-        </p:spPr>
-        <p:txBody>
-          <a:bodyPr wrap="square" rtlCol="0" anchor="ctr">
-            <a:spAutoFit/>
-          </a:bodyPr>
-          <a:lstStyle/>
-          <a:p>
-            <a:pPr indent="0" marL="0">
-              <a:buNone/>
-            </a:pPr>
-            <a:r>
-              <a:rPr lang="en-US" sz="1100" dirty="0">
-                <a:solidFill>
-                  <a:srgbClr val="1A1A1A"/>
-                </a:solidFill>
-                <a:latin typeface="Calibri" pitchFamily="34" charset="0"/>
-                <a:ea typeface="Calibri" pitchFamily="34" charset="-122"/>
-                <a:cs typeface="Calibri" pitchFamily="34" charset="-120"/>
-              </a:rPr>
-              <a:t>Lab 1 (worked, participatory): copy the notebook to Drive and mount Drive into the runtime (this is how your corpus and results survive Colab wiping the session, everything saving to one project folder), put a Gemini key in Colab Secrets, load NYT wedding data, make a first chart. Hand out the common-errors cheat sheet. Then solo with a partner: draft three questions, pick one, have the AI write the code, run it, chart it. Write one sentence predicting your cell before you run it.</a:t>
-            </a:r>
-            <a:endParaRPr lang="en-US" sz="1100" dirty="0"/>
-          </a:p>
-        </p:txBody>
-      </p:sp>
-      <p:sp>
-        <p:nvSpPr>
-          <p:cNvPr id="18" name="Shape 16"/>
-          <p:cNvSpPr/>
-          <p:nvPr/>
-        </p:nvSpPr>
-        <p:spPr>
-          <a:xfrm>
-            <a:off x="640080" y="4373118"/>
-            <a:ext cx="868680" cy="450342"/>
-          </a:xfrm>
-          <a:prstGeom prst="roundRect">
-            <a:avLst>
-              <a:gd name="adj" fmla="val 12183"/>
-            </a:avLst>
-          </a:prstGeom>
-          <a:solidFill>
-            <a:srgbClr val="7A3B2E"/>
-          </a:solidFill>
-          <a:ln/>
-        </p:spPr>
-      </p:sp>
-      <p:sp>
-        <p:nvSpPr>
-          <p:cNvPr id="19" name="Text 17"/>
-          <p:cNvSpPr/>
-          <p:nvPr/>
-        </p:nvSpPr>
-        <p:spPr>
-          <a:xfrm>
-            <a:off x="640080" y="4373118"/>
-            <a:ext cx="868680" cy="450342"/>
-          </a:xfrm>
-          <a:prstGeom prst="rect">
-            <a:avLst/>
-          </a:prstGeom>
-          <a:noFill/>
-          <a:ln/>
-        </p:spPr>
-        <p:txBody>
-          <a:bodyPr wrap="square" rtlCol="0" anchor="ctr"/>
-          <a:lstStyle/>
-          <a:p>
-            <a:pPr algn="ctr" indent="0" marL="0">
-              <a:buNone/>
-            </a:pPr>
-            <a:r>
-              <a:rPr lang="en-US" sz="1100" b="1" dirty="0">
-                <a:solidFill>
-                  <a:srgbClr val="FFFFFF"/>
-                </a:solidFill>
-                <a:latin typeface="Calibri" pitchFamily="34" charset="0"/>
-                <a:ea typeface="Calibri" pitchFamily="34" charset="-122"/>
-                <a:cs typeface="Calibri" pitchFamily="34" charset="-120"/>
-              </a:rPr>
-              <a:t>1:20</a:t>
-            </a:r>
-            <a:endParaRPr lang="en-US" sz="1100" dirty="0"/>
-          </a:p>
-        </p:txBody>
-      </p:sp>
-      <p:sp>
-        <p:nvSpPr>
-          <p:cNvPr id="20" name="Text 18"/>
-          <p:cNvSpPr/>
-          <p:nvPr/>
-        </p:nvSpPr>
-        <p:spPr>
-          <a:xfrm>
-            <a:off x="1691640" y="4354830"/>
-            <a:ext cx="9646920" cy="560070"/>
-          </a:xfrm>
-          <a:prstGeom prst="rect">
-            <a:avLst/>
-          </a:prstGeom>
-          <a:noFill/>
-          <a:ln/>
-        </p:spPr>
-        <p:txBody>
-          <a:bodyPr wrap="square" rtlCol="0" anchor="ctr">
-            <a:spAutoFit/>
-          </a:bodyPr>
-          <a:lstStyle/>
-          <a:p>
-            <a:pPr indent="0" marL="0">
-              <a:buNone/>
-            </a:pPr>
-            <a:r>
-              <a:rPr lang="en-US" sz="1100" dirty="0">
-                <a:solidFill>
-                  <a:srgbClr val="1A1A1A"/>
-                </a:solidFill>
-                <a:latin typeface="Calibri" pitchFamily="34" charset="0"/>
-                <a:ea typeface="Calibri" pitchFamily="34" charset="-122"/>
-                <a:cs typeface="Calibri" pitchFamily="34" charset="-120"/>
-              </a:rPr>
-              <a:t>Break</a:t>
-            </a:r>
-            <a:endParaRPr lang="en-US" sz="1100" dirty="0"/>
-          </a:p>
-        </p:txBody>
-      </p:sp>
-      <p:sp>
-        <p:nvSpPr>
-          <p:cNvPr id="21" name="Shape 19"/>
-          <p:cNvSpPr/>
-          <p:nvPr/>
-        </p:nvSpPr>
-        <p:spPr>
-          <a:xfrm>
-            <a:off x="640080" y="4933188"/>
-            <a:ext cx="868680" cy="450342"/>
-          </a:xfrm>
-          <a:prstGeom prst="roundRect">
-            <a:avLst>
-              <a:gd name="adj" fmla="val 12183"/>
-            </a:avLst>
-          </a:prstGeom>
-          <a:solidFill>
-            <a:srgbClr val="7A3B2E"/>
-          </a:solidFill>
-          <a:ln/>
-        </p:spPr>
-      </p:sp>
-      <p:sp>
-        <p:nvSpPr>
-          <p:cNvPr id="22" name="Text 20"/>
-          <p:cNvSpPr/>
-          <p:nvPr/>
-        </p:nvSpPr>
-        <p:spPr>
-          <a:xfrm>
-            <a:off x="640080" y="4933188"/>
-            <a:ext cx="868680" cy="450342"/>
-          </a:xfrm>
-          <a:prstGeom prst="rect">
-            <a:avLst/>
-          </a:prstGeom>
-          <a:noFill/>
-          <a:ln/>
-        </p:spPr>
-        <p:txBody>
-          <a:bodyPr wrap="square" rtlCol="0" anchor="ctr"/>
-          <a:lstStyle/>
-          <a:p>
-            <a:pPr algn="ctr" indent="0" marL="0">
-              <a:buNone/>
-            </a:pPr>
-            <a:r>
-              <a:rPr lang="en-US" sz="1100" b="1" dirty="0">
-                <a:solidFill>
-                  <a:srgbClr val="FFFFFF"/>
-                </a:solidFill>
-                <a:latin typeface="Calibri" pitchFamily="34" charset="0"/>
-                <a:ea typeface="Calibri" pitchFamily="34" charset="-122"/>
-                <a:cs typeface="Calibri" pitchFamily="34" charset="-120"/>
-              </a:rPr>
-              <a:t>1:30</a:t>
-            </a:r>
-            <a:endParaRPr lang="en-US" sz="1100" dirty="0"/>
-          </a:p>
-        </p:txBody>
-      </p:sp>
-      <p:sp>
-        <p:nvSpPr>
-          <p:cNvPr id="23" name="Text 21"/>
-          <p:cNvSpPr/>
-          <p:nvPr/>
-        </p:nvSpPr>
-        <p:spPr>
-          <a:xfrm>
-            <a:off x="1691640" y="4914900"/>
-            <a:ext cx="9646920" cy="560070"/>
-          </a:xfrm>
-          <a:prstGeom prst="rect">
-            <a:avLst/>
-          </a:prstGeom>
-          <a:noFill/>
-          <a:ln/>
-        </p:spPr>
-        <p:txBody>
-          <a:bodyPr wrap="square" rtlCol="0" anchor="ctr">
-            <a:spAutoFit/>
-          </a:bodyPr>
-          <a:lstStyle/>
-          <a:p>
-            <a:pPr indent="0" marL="0">
-              <a:buNone/>
-            </a:pPr>
-            <a:r>
-              <a:rPr lang="en-US" sz="1100" dirty="0">
-                <a:solidFill>
-                  <a:srgbClr val="1A1A1A"/>
-                </a:solidFill>
-                <a:latin typeface="Calibri" pitchFamily="34" charset="0"/>
-                <a:ea typeface="Calibri" pitchFamily="34" charset="-122"/>
-                <a:cs typeface="Calibri" pitchFamily="34" charset="-120"/>
-              </a:rPr>
-              <a:t>Lab 2 (worked): count words, then pixels. The real headlines' top words (stop-words dominate until removed, the first counting decision), then the Met image corpus ranked darkest to brightest by average brightness. The notebook's after-class half, defined color ranges and what every bag throws away, is this week's guided homework. Image projects begin here.</a:t>
-            </a:r>
-            <a:endParaRPr lang="en-US" sz="1100" dirty="0"/>
-          </a:p>
-        </p:txBody>
-      </p:sp>
-      <p:sp>
-        <p:nvSpPr>
-          <p:cNvPr id="24" name="Shape 22"/>
-          <p:cNvSpPr/>
-          <p:nvPr/>
-        </p:nvSpPr>
-        <p:spPr>
-          <a:xfrm>
-            <a:off x="640080" y="5493258"/>
-            <a:ext cx="868680" cy="450342"/>
-          </a:xfrm>
-          <a:prstGeom prst="roundRect">
-            <a:avLst>
-              <a:gd name="adj" fmla="val 12183"/>
-            </a:avLst>
-          </a:prstGeom>
-          <a:solidFill>
-            <a:srgbClr val="7A3B2E"/>
-          </a:solidFill>
-          <a:ln/>
-        </p:spPr>
-      </p:sp>
-      <p:sp>
-        <p:nvSpPr>
-          <p:cNvPr id="25" name="Text 23"/>
-          <p:cNvSpPr/>
-          <p:nvPr/>
-        </p:nvSpPr>
-        <p:spPr>
-          <a:xfrm>
-            <a:off x="640080" y="5493258"/>
-            <a:ext cx="868680" cy="450342"/>
-          </a:xfrm>
-          <a:prstGeom prst="rect">
-            <a:avLst/>
-          </a:prstGeom>
-          <a:noFill/>
-          <a:ln/>
-        </p:spPr>
-        <p:txBody>
-          <a:bodyPr wrap="square" rtlCol="0" anchor="ctr"/>
-          <a:lstStyle/>
-          <a:p>
-            <a:pPr algn="ctr" indent="0" marL="0">
-              <a:buNone/>
-            </a:pPr>
-            <a:r>
-              <a:rPr lang="en-US" sz="1100" b="1" dirty="0">
-                <a:solidFill>
-                  <a:srgbClr val="FFFFFF"/>
-                </a:solidFill>
-                <a:latin typeface="Calibri" pitchFamily="34" charset="0"/>
-                <a:ea typeface="Calibri" pitchFamily="34" charset="-122"/>
-                <a:cs typeface="Calibri" pitchFamily="34" charset="-120"/>
-              </a:rPr>
-              <a:t>1:52</a:t>
-            </a:r>
-            <a:endParaRPr lang="en-US" sz="1100" dirty="0"/>
-          </a:p>
-        </p:txBody>
-      </p:sp>
-      <p:sp>
-        <p:nvSpPr>
-          <p:cNvPr id="26" name="Text 24"/>
-          <p:cNvSpPr/>
-          <p:nvPr/>
-        </p:nvSpPr>
-        <p:spPr>
-          <a:xfrm>
-            <a:off x="1691640" y="5474970"/>
-            <a:ext cx="9646920" cy="560070"/>
-          </a:xfrm>
-          <a:prstGeom prst="rect">
-            <a:avLst/>
-          </a:prstGeom>
-          <a:noFill/>
-          <a:ln/>
-        </p:spPr>
-        <p:txBody>
-          <a:bodyPr wrap="square" rtlCol="0" anchor="ctr">
-            <a:spAutoFit/>
-          </a:bodyPr>
-          <a:lstStyle/>
-          <a:p>
-            <a:pPr indent="0" marL="0">
-              <a:buNone/>
-            </a:pPr>
-            <a:r>
-              <a:rPr lang="en-US" sz="1100" dirty="0">
-                <a:solidFill>
-                  <a:srgbClr val="1A1A1A"/>
-                </a:solidFill>
-                <a:latin typeface="Calibri" pitchFamily="34" charset="0"/>
-                <a:ea typeface="Calibri" pitchFamily="34" charset="-122"/>
-                <a:cs typeface="Calibri" pitchFamily="34" charset="-120"/>
-              </a:rPr>
-              <a:t>Preview of the methods ahead; the weekly routines introduced. First check-out.</a:t>
-            </a:r>
-            <a:endParaRPr lang="en-US" sz="1100" dirty="0"/>
+              <a:t>Interrogate the study, debate it, or critique each other's work.</a:t>
+            </a:r>
+            <a:endParaRPr lang="en-US" sz="1500" dirty="0"/>
           </a:p>
         </p:txBody>
       </p:sp>
@@ -4942,7 +4596,7 @@
                 <a:ea typeface="Cambria" pitchFamily="34" charset="-122"/>
                 <a:cs typeface="Cambria" pitchFamily="34" charset="-120"/>
               </a:rPr>
-              <a:t>Reading &amp; homework</a:t>
+              <a:t>The session</a:t>
             </a:r>
             <a:endParaRPr lang="en-US" sz="3000" dirty="0"/>
           </a:p>
@@ -4956,11 +4610,13 @@
         </p:nvSpPr>
         <p:spPr>
           <a:xfrm>
-            <a:off x="640080" y="1673352"/>
-            <a:ext cx="219456" cy="219456"/>
-          </a:xfrm>
-          <a:prstGeom prst="ellipse">
-            <a:avLst/>
+            <a:off x="640080" y="1572768"/>
+            <a:ext cx="868680" cy="450342"/>
+          </a:xfrm>
+          <a:prstGeom prst="roundRect">
+            <a:avLst>
+              <a:gd name="adj" fmla="val 12183"/>
+            </a:avLst>
           </a:prstGeom>
           <a:solidFill>
             <a:srgbClr val="7A3B2E"/>
@@ -4976,8 +4632,8 @@
         </p:nvSpPr>
         <p:spPr>
           <a:xfrm>
-            <a:off x="1051560" y="1600200"/>
-            <a:ext cx="10424160" cy="365760"/>
+            <a:off x="640080" y="1572768"/>
+            <a:ext cx="868680" cy="450342"/>
           </a:xfrm>
           <a:prstGeom prst="rect">
             <a:avLst/>
@@ -4989,21 +4645,21 @@
           <a:bodyPr wrap="square" rtlCol="0" anchor="ctr"/>
           <a:lstStyle/>
           <a:p>
-            <a:pPr indent="0" marL="0">
-              <a:buNone/>
-            </a:pPr>
-            <a:r>
-              <a:rPr lang="en-US" sz="1500" b="1" dirty="0">
-                <a:solidFill>
-                  <a:srgbClr val="7A3B2E"/>
+            <a:pPr algn="ctr" indent="0" marL="0">
+              <a:buNone/>
+            </a:pPr>
+            <a:r>
+              <a:rPr lang="en-US" sz="1100" b="1" dirty="0">
+                <a:solidFill>
+                  <a:srgbClr val="FFFFFF"/>
                 </a:solidFill>
                 <a:latin typeface="Calibri" pitchFamily="34" charset="0"/>
                 <a:ea typeface="Calibri" pitchFamily="34" charset="-122"/>
                 <a:cs typeface="Calibri" pitchFamily="34" charset="-120"/>
               </a:rPr>
-              <a:t>Reading</a:t>
-            </a:r>
-            <a:endParaRPr lang="en-US" sz="1500" dirty="0"/>
+              <a:t>0:00</a:t>
+            </a:r>
+            <a:endParaRPr lang="en-US" sz="1100" dirty="0"/>
           </a:p>
         </p:txBody>
       </p:sp>
@@ -5015,17 +4671,17 @@
         </p:nvSpPr>
         <p:spPr>
           <a:xfrm>
-            <a:off x="1051560" y="1984248"/>
-            <a:ext cx="10424160" cy="731520"/>
-          </a:xfrm>
-          <a:prstGeom prst="rect">
-            <a:avLst/>
-          </a:prstGeom>
-          <a:noFill/>
-          <a:ln/>
-        </p:spPr>
-        <p:txBody>
-          <a:bodyPr wrap="square" rtlCol="0" anchor="t">
+            <a:off x="1691640" y="1554480"/>
+            <a:ext cx="9646920" cy="560070"/>
+          </a:xfrm>
+          <a:prstGeom prst="rect">
+            <a:avLst/>
+          </a:prstGeom>
+          <a:noFill/>
+          <a:ln/>
+        </p:spPr>
+        <p:txBody>
+          <a:bodyPr wrap="square" rtlCol="0" anchor="ctr">
             <a:spAutoFit/>
           </a:bodyPr>
           <a:lstStyle/>
@@ -5034,7 +4690,7 @@
               <a:buNone/>
             </a:pPr>
             <a:r>
-              <a:rPr lang="en-US" sz="1400" dirty="0">
+              <a:rPr lang="en-US" sz="1100" dirty="0">
                 <a:solidFill>
                   <a:srgbClr val="1A1A1A"/>
                 </a:solidFill>
@@ -5042,9 +4698,9 @@
                 <a:ea typeface="Calibri" pitchFamily="34" charset="-122"/>
                 <a:cs typeface="Calibri" pitchFamily="34" charset="-120"/>
               </a:rPr>
-              <a:t>Bollen et al., the cognitive-distortions hockey stick (PNAS 2021), with the Schmidt et al. critique</a:t>
-            </a:r>
-            <a:endParaRPr lang="en-US" sz="1400" dirty="0"/>
+              <a:t>Introductions and working agreements, demonstrated in practice. Today's live coding deliberately includes real mistakes.</a:t>
+            </a:r>
+            <a:endParaRPr lang="en-US" sz="1100" dirty="0"/>
           </a:p>
         </p:txBody>
       </p:sp>
@@ -5056,14 +4712,16 @@
         </p:nvSpPr>
         <p:spPr>
           <a:xfrm>
-            <a:off x="640080" y="2633472"/>
-            <a:ext cx="219456" cy="219456"/>
-          </a:xfrm>
-          <a:prstGeom prst="ellipse">
-            <a:avLst/>
-          </a:prstGeom>
-          <a:solidFill>
-            <a:srgbClr val="3F6F5F"/>
+            <a:off x="640080" y="2132838"/>
+            <a:ext cx="868680" cy="450342"/>
+          </a:xfrm>
+          <a:prstGeom prst="roundRect">
+            <a:avLst>
+              <a:gd name="adj" fmla="val 12183"/>
+            </a:avLst>
+          </a:prstGeom>
+          <a:solidFill>
+            <a:srgbClr val="7A3B2E"/>
           </a:solidFill>
           <a:ln/>
         </p:spPr>
@@ -5076,8 +4734,8 @@
         </p:nvSpPr>
         <p:spPr>
           <a:xfrm>
-            <a:off x="1051560" y="2560320"/>
-            <a:ext cx="10424160" cy="365760"/>
+            <a:off x="640080" y="2132838"/>
+            <a:ext cx="868680" cy="450342"/>
           </a:xfrm>
           <a:prstGeom prst="rect">
             <a:avLst/>
@@ -5089,21 +4747,21 @@
           <a:bodyPr wrap="square" rtlCol="0" anchor="ctr"/>
           <a:lstStyle/>
           <a:p>
-            <a:pPr indent="0" marL="0">
-              <a:buNone/>
-            </a:pPr>
-            <a:r>
-              <a:rPr lang="en-US" sz="1500" b="1" dirty="0">
-                <a:solidFill>
-                  <a:srgbClr val="3F6F5F"/>
+            <a:pPr algn="ctr" indent="0" marL="0">
+              <a:buNone/>
+            </a:pPr>
+            <a:r>
+              <a:rPr lang="en-US" sz="1100" b="1" dirty="0">
+                <a:solidFill>
+                  <a:srgbClr val="FFFFFF"/>
                 </a:solidFill>
                 <a:latin typeface="Calibri" pitchFamily="34" charset="0"/>
                 <a:ea typeface="Calibri" pitchFamily="34" charset="-122"/>
                 <a:cs typeface="Calibri" pitchFamily="34" charset="-120"/>
               </a:rPr>
-              <a:t>Supplement</a:t>
-            </a:r>
-            <a:endParaRPr lang="en-US" sz="1500" dirty="0"/>
+              <a:t>0:10</a:t>
+            </a:r>
+            <a:endParaRPr lang="en-US" sz="1100" dirty="0"/>
           </a:p>
         </p:txBody>
       </p:sp>
@@ -5115,17 +4773,17 @@
         </p:nvSpPr>
         <p:spPr>
           <a:xfrm>
-            <a:off x="1051560" y="2944368"/>
-            <a:ext cx="10424160" cy="731520"/>
-          </a:xfrm>
-          <a:prstGeom prst="rect">
-            <a:avLst/>
-          </a:prstGeom>
-          <a:noFill/>
-          <a:ln/>
-        </p:spPr>
-        <p:txBody>
-          <a:bodyPr wrap="square" rtlCol="0" anchor="t">
+            <a:off x="1691640" y="2114550"/>
+            <a:ext cx="9646920" cy="560070"/>
+          </a:xfrm>
+          <a:prstGeom prst="rect">
+            <a:avLst/>
+          </a:prstGeom>
+          <a:noFill/>
+          <a:ln/>
+        </p:spPr>
+        <p:txBody>
+          <a:bodyPr wrap="square" rtlCol="0" anchor="ctr">
             <a:spAutoFit/>
           </a:bodyPr>
           <a:lstStyle/>
@@ -5134,7 +4792,7 @@
               <a:buNone/>
             </a:pPr>
             <a:r>
-              <a:rPr lang="en-US" sz="1400" dirty="0">
+              <a:rPr lang="en-US" sz="1100" dirty="0">
                 <a:solidFill>
                   <a:srgbClr val="1A1A1A"/>
                 </a:solidFill>
@@ -5142,9 +4800,9 @@
                 <a:ea typeface="Calibri" pitchFamily="34" charset="-122"/>
                 <a:cs typeface="Calibri" pitchFamily="34" charset="-120"/>
               </a:rPr>
-              <a:t>Robin Sloan, Writing with the machine; Drucker, Humanities Approaches to Graphical Display (DHQ 2011), the case that all data is capta</a:t>
-            </a:r>
-            <a:endParaRPr lang="en-US" sz="1400" dirty="0"/>
+              <a:t>Lecture, the stakes: machines already read culture at scale, the feed ranking what you see, the moderation filter, the model trained on scraped art and prose, and that reading happens without you. Counting culture has produced real knowledge (the screenplay verb split, the Rowling unmasking, pop music's 1991 revolution) and real mistakes, and both look identical until someone checks. In ten weeks you do the reading yourself and publish something checkable.</a:t>
+            </a:r>
+            <a:endParaRPr lang="en-US" sz="1100" dirty="0"/>
           </a:p>
         </p:txBody>
       </p:sp>
@@ -5156,14 +4814,16 @@
         </p:nvSpPr>
         <p:spPr>
           <a:xfrm>
-            <a:off x="640080" y="3593592"/>
-            <a:ext cx="219456" cy="219456"/>
-          </a:xfrm>
-          <a:prstGeom prst="ellipse">
-            <a:avLst/>
-          </a:prstGeom>
-          <a:solidFill>
-            <a:srgbClr val="B9852F"/>
+            <a:off x="640080" y="2692908"/>
+            <a:ext cx="868680" cy="450342"/>
+          </a:xfrm>
+          <a:prstGeom prst="roundRect">
+            <a:avLst>
+              <a:gd name="adj" fmla="val 12183"/>
+            </a:avLst>
+          </a:prstGeom>
+          <a:solidFill>
+            <a:srgbClr val="7A3B2E"/>
           </a:solidFill>
           <a:ln/>
         </p:spPr>
@@ -5176,8 +4836,8 @@
         </p:nvSpPr>
         <p:spPr>
           <a:xfrm>
-            <a:off x="1051560" y="3520440"/>
-            <a:ext cx="10424160" cy="365760"/>
+            <a:off x="640080" y="2692908"/>
+            <a:ext cx="868680" cy="450342"/>
           </a:xfrm>
           <a:prstGeom prst="rect">
             <a:avLst/>
@@ -5189,21 +4849,21 @@
           <a:bodyPr wrap="square" rtlCol="0" anchor="ctr"/>
           <a:lstStyle/>
           <a:p>
-            <a:pPr indent="0" marL="0">
-              <a:buNone/>
-            </a:pPr>
-            <a:r>
-              <a:rPr lang="en-US" sz="1500" b="1" dirty="0">
-                <a:solidFill>
-                  <a:srgbClr val="B9852F"/>
+            <a:pPr algn="ctr" indent="0" marL="0">
+              <a:buNone/>
+            </a:pPr>
+            <a:r>
+              <a:rPr lang="en-US" sz="1100" b="1" dirty="0">
+                <a:solidFill>
+                  <a:srgbClr val="FFFFFF"/>
                 </a:solidFill>
                 <a:latin typeface="Calibri" pitchFamily="34" charset="0"/>
                 <a:ea typeface="Calibri" pitchFamily="34" charset="-122"/>
                 <a:cs typeface="Calibri" pitchFamily="34" charset="-120"/>
               </a:rPr>
-              <a:t>Deeper (optional)</a:t>
-            </a:r>
-            <a:endParaRPr lang="en-US" sz="1500" dirty="0"/>
+              <a:t>0:28</a:t>
+            </a:r>
+            <a:endParaRPr lang="en-US" sz="1100" dirty="0"/>
           </a:p>
         </p:txBody>
       </p:sp>
@@ -5215,17 +4875,17 @@
         </p:nvSpPr>
         <p:spPr>
           <a:xfrm>
-            <a:off x="1051560" y="3904488"/>
-            <a:ext cx="10424160" cy="731520"/>
-          </a:xfrm>
-          <a:prstGeom prst="rect">
-            <a:avLst/>
-          </a:prstGeom>
-          <a:noFill/>
-          <a:ln/>
-        </p:spPr>
-        <p:txBody>
-          <a:bodyPr wrap="square" rtlCol="0" anchor="t">
+            <a:off x="1691640" y="2674620"/>
+            <a:ext cx="9646920" cy="560070"/>
+          </a:xfrm>
+          <a:prstGeom prst="rect">
+            <a:avLst/>
+          </a:prstGeom>
+          <a:noFill/>
+          <a:ln/>
+        </p:spPr>
+        <p:txBody>
+          <a:bodyPr wrap="square" rtlCol="0" anchor="ctr">
             <a:spAutoFit/>
           </a:bodyPr>
           <a:lstStyle/>
@@ -5234,7 +4894,7 @@
               <a:buNone/>
             </a:pPr>
             <a:r>
-              <a:rPr lang="en-US" sz="1400" dirty="0">
+              <a:rPr lang="en-US" sz="1100" dirty="0">
                 <a:solidFill>
                   <a:srgbClr val="1A1A1A"/>
                 </a:solidFill>
@@ -5242,9 +4902,9 @@
                 <a:ea typeface="Calibri" pitchFamily="34" charset="-122"/>
                 <a:cs typeface="Calibri" pitchFamily="34" charset="-120"/>
               </a:rPr>
-              <a:t>Moretti, Conjectures on World Literature (NLR 2000), the founding argument for reading culture at scale</a:t>
-            </a:r>
-            <a:endParaRPr lang="en-US" sz="1400" dirty="0"/>
+              <a:t>Look at This, then Question It: She Giggles, He Gallops.</a:t>
+            </a:r>
+            <a:endParaRPr lang="en-US" sz="1100" dirty="0"/>
           </a:p>
         </p:txBody>
       </p:sp>
@@ -5256,14 +4916,16 @@
         </p:nvSpPr>
         <p:spPr>
           <a:xfrm>
-            <a:off x="640080" y="4553712"/>
-            <a:ext cx="219456" cy="219456"/>
-          </a:xfrm>
-          <a:prstGeom prst="ellipse">
-            <a:avLst/>
-          </a:prstGeom>
-          <a:solidFill>
-            <a:srgbClr val="3F6F5F"/>
+            <a:off x="640080" y="3252978"/>
+            <a:ext cx="868680" cy="450342"/>
+          </a:xfrm>
+          <a:prstGeom prst="roundRect">
+            <a:avLst>
+              <a:gd name="adj" fmla="val 12183"/>
+            </a:avLst>
+          </a:prstGeom>
+          <a:solidFill>
+            <a:srgbClr val="7A3B2E"/>
           </a:solidFill>
           <a:ln/>
         </p:spPr>
@@ -5276,8 +4938,8 @@
         </p:nvSpPr>
         <p:spPr>
           <a:xfrm>
-            <a:off x="1051560" y="4480560"/>
-            <a:ext cx="10424160" cy="365760"/>
+            <a:off x="640080" y="3252978"/>
+            <a:ext cx="868680" cy="450342"/>
           </a:xfrm>
           <a:prstGeom prst="rect">
             <a:avLst/>
@@ -5289,21 +4951,21 @@
           <a:bodyPr wrap="square" rtlCol="0" anchor="ctr"/>
           <a:lstStyle/>
           <a:p>
-            <a:pPr indent="0" marL="0">
-              <a:buNone/>
-            </a:pPr>
-            <a:r>
-              <a:rPr lang="en-US" sz="1500" b="1" dirty="0">
-                <a:solidFill>
-                  <a:srgbClr val="3F6F5F"/>
+            <a:pPr algn="ctr" indent="0" marL="0">
+              <a:buNone/>
+            </a:pPr>
+            <a:r>
+              <a:rPr lang="en-US" sz="1100" b="1" dirty="0">
+                <a:solidFill>
+                  <a:srgbClr val="FFFFFF"/>
                 </a:solidFill>
                 <a:latin typeface="Calibri" pitchFamily="34" charset="0"/>
                 <a:ea typeface="Calibri" pitchFamily="34" charset="-122"/>
                 <a:cs typeface="Calibri" pitchFamily="34" charset="-120"/>
               </a:rPr>
-              <a:t>Sketch</a:t>
-            </a:r>
-            <a:endParaRPr lang="en-US" sz="1500" dirty="0"/>
+              <a:t>0:35</a:t>
+            </a:r>
+            <a:endParaRPr lang="en-US" sz="1100" dirty="0"/>
           </a:p>
         </p:txBody>
       </p:sp>
@@ -5315,17 +4977,17 @@
         </p:nvSpPr>
         <p:spPr>
           <a:xfrm>
-            <a:off x="1051560" y="4864608"/>
-            <a:ext cx="10424160" cy="731520"/>
-          </a:xfrm>
-          <a:prstGeom prst="rect">
-            <a:avLst/>
-          </a:prstGeom>
-          <a:noFill/>
-          <a:ln/>
-        </p:spPr>
-        <p:txBody>
-          <a:bodyPr wrap="square" rtlCol="0" anchor="t">
+            <a:off x="1691640" y="3234690"/>
+            <a:ext cx="9646920" cy="560070"/>
+          </a:xfrm>
+          <a:prstGeom prst="rect">
+            <a:avLst/>
+          </a:prstGeom>
+          <a:noFill/>
+          <a:ln/>
+        </p:spPr>
+        <p:txBody>
+          <a:bodyPr wrap="square" rtlCol="0" anchor="ctr">
             <a:spAutoFit/>
           </a:bodyPr>
           <a:lstStyle/>
@@ -5334,7 +4996,7 @@
               <a:buNone/>
             </a:pPr>
             <a:r>
-              <a:rPr lang="en-US" sz="1400" dirty="0">
+              <a:rPr lang="en-US" sz="1100" dirty="0">
                 <a:solidFill>
                   <a:srgbClr val="1A1A1A"/>
                 </a:solidFill>
@@ -5342,9 +5004,9 @@
                 <a:ea typeface="Calibri" pitchFamily="34" charset="-122"/>
                 <a:cs typeface="Calibri" pitchFamily="34" charset="-120"/>
               </a:rPr>
-              <a:t>One question from your life, answerable with data (three sentences), plus the notebook's after-class half (~20 minutes).</a:t>
-            </a:r>
-            <a:endParaRPr lang="en-US" sz="1400" dirty="0"/>
+              <a:t>The vocabulary and the map (no code): corpus, method, model, embedding, plus what data itself is. A CSV, anatomized on screen (rows are observations, columns are recorded facts), and Drucker's correction: data is capta, taken not given. Two minutes in pairs: what did the makers of the wedding table take, and what did they leave out? The deliverable, shown: a web essay on a runnable notebook.</a:t>
+            </a:r>
+            <a:endParaRPr lang="en-US" sz="1100" dirty="0"/>
           </a:p>
         </p:txBody>
       </p:sp>
@@ -5356,11 +5018,13 @@
         </p:nvSpPr>
         <p:spPr>
           <a:xfrm>
-            <a:off x="640080" y="5513832"/>
-            <a:ext cx="219456" cy="219456"/>
-          </a:xfrm>
-          <a:prstGeom prst="ellipse">
-            <a:avLst/>
+            <a:off x="640080" y="3813048"/>
+            <a:ext cx="868680" cy="450342"/>
+          </a:xfrm>
+          <a:prstGeom prst="roundRect">
+            <a:avLst>
+              <a:gd name="adj" fmla="val 12183"/>
+            </a:avLst>
           </a:prstGeom>
           <a:solidFill>
             <a:srgbClr val="7A3B2E"/>
@@ -5376,8 +5040,8 @@
         </p:nvSpPr>
         <p:spPr>
           <a:xfrm>
-            <a:off x="1051560" y="5440680"/>
-            <a:ext cx="10424160" cy="365760"/>
+            <a:off x="640080" y="3813048"/>
+            <a:ext cx="868680" cy="450342"/>
           </a:xfrm>
           <a:prstGeom prst="rect">
             <a:avLst/>
@@ -5389,21 +5053,21 @@
           <a:bodyPr wrap="square" rtlCol="0" anchor="ctr"/>
           <a:lstStyle/>
           <a:p>
-            <a:pPr indent="0" marL="0">
-              <a:buNone/>
-            </a:pPr>
-            <a:r>
-              <a:rPr lang="en-US" sz="1500" b="1" dirty="0">
-                <a:solidFill>
-                  <a:srgbClr val="7A3B2E"/>
+            <a:pPr algn="ctr" indent="0" marL="0">
+              <a:buNone/>
+            </a:pPr>
+            <a:r>
+              <a:rPr lang="en-US" sz="1100" b="1" dirty="0">
+                <a:solidFill>
+                  <a:srgbClr val="FFFFFF"/>
                 </a:solidFill>
                 <a:latin typeface="Calibri" pitchFamily="34" charset="0"/>
                 <a:ea typeface="Calibri" pitchFamily="34" charset="-122"/>
                 <a:cs typeface="Calibri" pitchFamily="34" charset="-120"/>
               </a:rPr>
-              <a:t>Check (AI closed)</a:t>
-            </a:r>
-            <a:endParaRPr lang="en-US" sz="1500" dirty="0"/>
+              <a:t>0:47</a:t>
+            </a:r>
+            <a:endParaRPr lang="en-US" sz="1100" dirty="0"/>
           </a:p>
         </p:txBody>
       </p:sp>
@@ -5415,17 +5079,17 @@
         </p:nvSpPr>
         <p:spPr>
           <a:xfrm>
-            <a:off x="1051560" y="5824728"/>
-            <a:ext cx="10424160" cy="731520"/>
-          </a:xfrm>
-          <a:prstGeom prst="rect">
-            <a:avLst/>
-          </a:prstGeom>
-          <a:noFill/>
-          <a:ln/>
-        </p:spPr>
-        <p:txBody>
-          <a:bodyPr wrap="square" rtlCol="0" anchor="t">
+            <a:off x="1691640" y="3794760"/>
+            <a:ext cx="9646920" cy="560070"/>
+          </a:xfrm>
+          <a:prstGeom prst="rect">
+            <a:avLst/>
+          </a:prstGeom>
+          <a:noFill/>
+          <a:ln/>
+        </p:spPr>
+        <p:txBody>
+          <a:bodyPr wrap="square" rtlCol="0" anchor="ctr">
             <a:spAutoFit/>
           </a:bodyPr>
           <a:lstStyle/>
@@ -5434,7 +5098,7 @@
               <a:buNone/>
             </a:pPr>
             <a:r>
-              <a:rPr lang="en-US" sz="1400" dirty="0">
+              <a:rPr lang="en-US" sz="1100" dirty="0">
                 <a:solidFill>
                   <a:srgbClr val="1A1A1A"/>
                 </a:solidFill>
@@ -5442,9 +5106,315 @@
                 <a:ea typeface="Calibri" pitchFamily="34" charset="-122"/>
                 <a:cs typeface="Calibri" pitchFamily="34" charset="-120"/>
               </a:rPr>
-              <a:t>Trace it: one written sentence predicting what your cell does before you run it. (Competency 1.)</a:t>
-            </a:r>
-            <a:endParaRPr lang="en-US" sz="1400" dirty="0"/>
+              <a:t>Lab 1 (worked, participatory): copy the notebook to Drive and mount Drive into the runtime (this is how your corpus and results survive Colab wiping the session, everything saving to one project folder), put a Gemini key in Colab Secrets, load NYT wedding data, make a first chart. Hand out the common-errors cheat sheet. Then solo with a partner: draft three questions, pick one, have the AI write the code, run it, chart it. Write one sentence predicting your cell before you run it.</a:t>
+            </a:r>
+            <a:endParaRPr lang="en-US" sz="1100" dirty="0"/>
+          </a:p>
+        </p:txBody>
+      </p:sp>
+      <p:sp>
+        <p:nvSpPr>
+          <p:cNvPr id="18" name="Shape 16"/>
+          <p:cNvSpPr/>
+          <p:nvPr/>
+        </p:nvSpPr>
+        <p:spPr>
+          <a:xfrm>
+            <a:off x="640080" y="4373118"/>
+            <a:ext cx="868680" cy="450342"/>
+          </a:xfrm>
+          <a:prstGeom prst="roundRect">
+            <a:avLst>
+              <a:gd name="adj" fmla="val 12183"/>
+            </a:avLst>
+          </a:prstGeom>
+          <a:solidFill>
+            <a:srgbClr val="7A3B2E"/>
+          </a:solidFill>
+          <a:ln/>
+        </p:spPr>
+      </p:sp>
+      <p:sp>
+        <p:nvSpPr>
+          <p:cNvPr id="19" name="Text 17"/>
+          <p:cNvSpPr/>
+          <p:nvPr/>
+        </p:nvSpPr>
+        <p:spPr>
+          <a:xfrm>
+            <a:off x="640080" y="4373118"/>
+            <a:ext cx="868680" cy="450342"/>
+          </a:xfrm>
+          <a:prstGeom prst="rect">
+            <a:avLst/>
+          </a:prstGeom>
+          <a:noFill/>
+          <a:ln/>
+        </p:spPr>
+        <p:txBody>
+          <a:bodyPr wrap="square" rtlCol="0" anchor="ctr"/>
+          <a:lstStyle/>
+          <a:p>
+            <a:pPr algn="ctr" indent="0" marL="0">
+              <a:buNone/>
+            </a:pPr>
+            <a:r>
+              <a:rPr lang="en-US" sz="1100" b="1" dirty="0">
+                <a:solidFill>
+                  <a:srgbClr val="FFFFFF"/>
+                </a:solidFill>
+                <a:latin typeface="Calibri" pitchFamily="34" charset="0"/>
+                <a:ea typeface="Calibri" pitchFamily="34" charset="-122"/>
+                <a:cs typeface="Calibri" pitchFamily="34" charset="-120"/>
+              </a:rPr>
+              <a:t>1:20</a:t>
+            </a:r>
+            <a:endParaRPr lang="en-US" sz="1100" dirty="0"/>
+          </a:p>
+        </p:txBody>
+      </p:sp>
+      <p:sp>
+        <p:nvSpPr>
+          <p:cNvPr id="20" name="Text 18"/>
+          <p:cNvSpPr/>
+          <p:nvPr/>
+        </p:nvSpPr>
+        <p:spPr>
+          <a:xfrm>
+            <a:off x="1691640" y="4354830"/>
+            <a:ext cx="9646920" cy="560070"/>
+          </a:xfrm>
+          <a:prstGeom prst="rect">
+            <a:avLst/>
+          </a:prstGeom>
+          <a:noFill/>
+          <a:ln/>
+        </p:spPr>
+        <p:txBody>
+          <a:bodyPr wrap="square" rtlCol="0" anchor="ctr">
+            <a:spAutoFit/>
+          </a:bodyPr>
+          <a:lstStyle/>
+          <a:p>
+            <a:pPr indent="0" marL="0">
+              <a:buNone/>
+            </a:pPr>
+            <a:r>
+              <a:rPr lang="en-US" sz="1100" dirty="0">
+                <a:solidFill>
+                  <a:srgbClr val="1A1A1A"/>
+                </a:solidFill>
+                <a:latin typeface="Calibri" pitchFamily="34" charset="0"/>
+                <a:ea typeface="Calibri" pitchFamily="34" charset="-122"/>
+                <a:cs typeface="Calibri" pitchFamily="34" charset="-120"/>
+              </a:rPr>
+              <a:t>Break</a:t>
+            </a:r>
+            <a:endParaRPr lang="en-US" sz="1100" dirty="0"/>
+          </a:p>
+        </p:txBody>
+      </p:sp>
+      <p:sp>
+        <p:nvSpPr>
+          <p:cNvPr id="21" name="Shape 19"/>
+          <p:cNvSpPr/>
+          <p:nvPr/>
+        </p:nvSpPr>
+        <p:spPr>
+          <a:xfrm>
+            <a:off x="640080" y="4933188"/>
+            <a:ext cx="868680" cy="450342"/>
+          </a:xfrm>
+          <a:prstGeom prst="roundRect">
+            <a:avLst>
+              <a:gd name="adj" fmla="val 12183"/>
+            </a:avLst>
+          </a:prstGeom>
+          <a:solidFill>
+            <a:srgbClr val="7A3B2E"/>
+          </a:solidFill>
+          <a:ln/>
+        </p:spPr>
+      </p:sp>
+      <p:sp>
+        <p:nvSpPr>
+          <p:cNvPr id="22" name="Text 20"/>
+          <p:cNvSpPr/>
+          <p:nvPr/>
+        </p:nvSpPr>
+        <p:spPr>
+          <a:xfrm>
+            <a:off x="640080" y="4933188"/>
+            <a:ext cx="868680" cy="450342"/>
+          </a:xfrm>
+          <a:prstGeom prst="rect">
+            <a:avLst/>
+          </a:prstGeom>
+          <a:noFill/>
+          <a:ln/>
+        </p:spPr>
+        <p:txBody>
+          <a:bodyPr wrap="square" rtlCol="0" anchor="ctr"/>
+          <a:lstStyle/>
+          <a:p>
+            <a:pPr algn="ctr" indent="0" marL="0">
+              <a:buNone/>
+            </a:pPr>
+            <a:r>
+              <a:rPr lang="en-US" sz="1100" b="1" dirty="0">
+                <a:solidFill>
+                  <a:srgbClr val="FFFFFF"/>
+                </a:solidFill>
+                <a:latin typeface="Calibri" pitchFamily="34" charset="0"/>
+                <a:ea typeface="Calibri" pitchFamily="34" charset="-122"/>
+                <a:cs typeface="Calibri" pitchFamily="34" charset="-120"/>
+              </a:rPr>
+              <a:t>1:30</a:t>
+            </a:r>
+            <a:endParaRPr lang="en-US" sz="1100" dirty="0"/>
+          </a:p>
+        </p:txBody>
+      </p:sp>
+      <p:sp>
+        <p:nvSpPr>
+          <p:cNvPr id="23" name="Text 21"/>
+          <p:cNvSpPr/>
+          <p:nvPr/>
+        </p:nvSpPr>
+        <p:spPr>
+          <a:xfrm>
+            <a:off x="1691640" y="4914900"/>
+            <a:ext cx="9646920" cy="560070"/>
+          </a:xfrm>
+          <a:prstGeom prst="rect">
+            <a:avLst/>
+          </a:prstGeom>
+          <a:noFill/>
+          <a:ln/>
+        </p:spPr>
+        <p:txBody>
+          <a:bodyPr wrap="square" rtlCol="0" anchor="ctr">
+            <a:spAutoFit/>
+          </a:bodyPr>
+          <a:lstStyle/>
+          <a:p>
+            <a:pPr indent="0" marL="0">
+              <a:buNone/>
+            </a:pPr>
+            <a:r>
+              <a:rPr lang="en-US" sz="1100" dirty="0">
+                <a:solidFill>
+                  <a:srgbClr val="1A1A1A"/>
+                </a:solidFill>
+                <a:latin typeface="Calibri" pitchFamily="34" charset="0"/>
+                <a:ea typeface="Calibri" pitchFamily="34" charset="-122"/>
+                <a:cs typeface="Calibri" pitchFamily="34" charset="-120"/>
+              </a:rPr>
+              <a:t>Lab 2 (worked): count words, then pixels. The real headlines' top words (stop-words dominate until removed, the first counting decision), then the Met image corpus ranked darkest to brightest by average brightness. The notebook's after-class half, defined color ranges and what every bag throws away, is this week's guided homework. Image projects begin here.</a:t>
+            </a:r>
+            <a:endParaRPr lang="en-US" sz="1100" dirty="0"/>
+          </a:p>
+        </p:txBody>
+      </p:sp>
+      <p:sp>
+        <p:nvSpPr>
+          <p:cNvPr id="24" name="Shape 22"/>
+          <p:cNvSpPr/>
+          <p:nvPr/>
+        </p:nvSpPr>
+        <p:spPr>
+          <a:xfrm>
+            <a:off x="640080" y="5493258"/>
+            <a:ext cx="868680" cy="450342"/>
+          </a:xfrm>
+          <a:prstGeom prst="roundRect">
+            <a:avLst>
+              <a:gd name="adj" fmla="val 12183"/>
+            </a:avLst>
+          </a:prstGeom>
+          <a:solidFill>
+            <a:srgbClr val="7A3B2E"/>
+          </a:solidFill>
+          <a:ln/>
+        </p:spPr>
+      </p:sp>
+      <p:sp>
+        <p:nvSpPr>
+          <p:cNvPr id="25" name="Text 23"/>
+          <p:cNvSpPr/>
+          <p:nvPr/>
+        </p:nvSpPr>
+        <p:spPr>
+          <a:xfrm>
+            <a:off x="640080" y="5493258"/>
+            <a:ext cx="868680" cy="450342"/>
+          </a:xfrm>
+          <a:prstGeom prst="rect">
+            <a:avLst/>
+          </a:prstGeom>
+          <a:noFill/>
+          <a:ln/>
+        </p:spPr>
+        <p:txBody>
+          <a:bodyPr wrap="square" rtlCol="0" anchor="ctr"/>
+          <a:lstStyle/>
+          <a:p>
+            <a:pPr algn="ctr" indent="0" marL="0">
+              <a:buNone/>
+            </a:pPr>
+            <a:r>
+              <a:rPr lang="en-US" sz="1100" b="1" dirty="0">
+                <a:solidFill>
+                  <a:srgbClr val="FFFFFF"/>
+                </a:solidFill>
+                <a:latin typeface="Calibri" pitchFamily="34" charset="0"/>
+                <a:ea typeface="Calibri" pitchFamily="34" charset="-122"/>
+                <a:cs typeface="Calibri" pitchFamily="34" charset="-120"/>
+              </a:rPr>
+              <a:t>1:52</a:t>
+            </a:r>
+            <a:endParaRPr lang="en-US" sz="1100" dirty="0"/>
+          </a:p>
+        </p:txBody>
+      </p:sp>
+      <p:sp>
+        <p:nvSpPr>
+          <p:cNvPr id="26" name="Text 24"/>
+          <p:cNvSpPr/>
+          <p:nvPr/>
+        </p:nvSpPr>
+        <p:spPr>
+          <a:xfrm>
+            <a:off x="1691640" y="5474970"/>
+            <a:ext cx="9646920" cy="560070"/>
+          </a:xfrm>
+          <a:prstGeom prst="rect">
+            <a:avLst/>
+          </a:prstGeom>
+          <a:noFill/>
+          <a:ln/>
+        </p:spPr>
+        <p:txBody>
+          <a:bodyPr wrap="square" rtlCol="0" anchor="ctr">
+            <a:spAutoFit/>
+          </a:bodyPr>
+          <a:lstStyle/>
+          <a:p>
+            <a:pPr indent="0" marL="0">
+              <a:buNone/>
+            </a:pPr>
+            <a:r>
+              <a:rPr lang="en-US" sz="1100" dirty="0">
+                <a:solidFill>
+                  <a:srgbClr val="1A1A1A"/>
+                </a:solidFill>
+                <a:latin typeface="Calibri" pitchFamily="34" charset="0"/>
+                <a:ea typeface="Calibri" pitchFamily="34" charset="-122"/>
+                <a:cs typeface="Calibri" pitchFamily="34" charset="-120"/>
+              </a:rPr>
+              <a:t>Preview of the methods ahead; the weekly routines introduced. First check-out.</a:t>
+            </a:r>
+            <a:endParaRPr lang="en-US" sz="1100" dirty="0"/>
           </a:p>
         </p:txBody>
       </p:sp>
@@ -5489,7 +5459,7 @@
         <p:spPr>
           <a:xfrm>
             <a:off x="640080" y="640080"/>
-            <a:ext cx="10058400" cy="320040"/>
+            <a:ext cx="10058400" cy="731520"/>
           </a:xfrm>
           <a:prstGeom prst="rect">
             <a:avLst/>
@@ -5505,7 +5475,66 @@
               <a:buNone/>
             </a:pPr>
             <a:r>
-              <a:rPr lang="en-US" sz="1300" b="1" spc="300" kern="0" dirty="0">
+              <a:rPr lang="en-US" sz="3000" b="1" dirty="0">
+                <a:solidFill>
+                  <a:srgbClr val="1A1A1A"/>
+                </a:solidFill>
+                <a:latin typeface="Cambria" pitchFamily="34" charset="0"/>
+                <a:ea typeface="Cambria" pitchFamily="34" charset="-122"/>
+                <a:cs typeface="Cambria" pitchFamily="34" charset="-120"/>
+              </a:rPr>
+              <a:t>Reading &amp; homework</a:t>
+            </a:r>
+            <a:endParaRPr lang="en-US" sz="3000" dirty="0"/>
+          </a:p>
+        </p:txBody>
+      </p:sp>
+      <p:sp>
+        <p:nvSpPr>
+          <p:cNvPr id="3" name="Shape 1"/>
+          <p:cNvSpPr/>
+          <p:nvPr/>
+        </p:nvSpPr>
+        <p:spPr>
+          <a:xfrm>
+            <a:off x="640080" y="1673352"/>
+            <a:ext cx="219456" cy="219456"/>
+          </a:xfrm>
+          <a:prstGeom prst="ellipse">
+            <a:avLst/>
+          </a:prstGeom>
+          <a:solidFill>
+            <a:srgbClr val="7A3B2E"/>
+          </a:solidFill>
+          <a:ln/>
+        </p:spPr>
+      </p:sp>
+      <p:sp>
+        <p:nvSpPr>
+          <p:cNvPr id="4" name="Text 2"/>
+          <p:cNvSpPr/>
+          <p:nvPr/>
+        </p:nvSpPr>
+        <p:spPr>
+          <a:xfrm>
+            <a:off x="1051560" y="1600200"/>
+            <a:ext cx="10424160" cy="365760"/>
+          </a:xfrm>
+          <a:prstGeom prst="rect">
+            <a:avLst/>
+          </a:prstGeom>
+          <a:noFill/>
+          <a:ln/>
+        </p:spPr>
+        <p:txBody>
+          <a:bodyPr wrap="square" rtlCol="0" anchor="ctr"/>
+          <a:lstStyle/>
+          <a:p>
+            <a:pPr indent="0" marL="0">
+              <a:buNone/>
+            </a:pPr>
+            <a:r>
+              <a:rPr lang="en-US" sz="1500" b="1" dirty="0">
                 <a:solidFill>
                   <a:srgbClr val="7A3B2E"/>
                 </a:solidFill>
@@ -5513,72 +5542,11 @@
                 <a:ea typeface="Calibri" pitchFamily="34" charset="-122"/>
                 <a:cs typeface="Calibri" pitchFamily="34" charset="-120"/>
               </a:rPr>
-              <a:t>HOW THIS WEEK CONNECTS</a:t>
-            </a:r>
-            <a:endParaRPr lang="en-US" sz="1300" dirty="0"/>
-          </a:p>
-        </p:txBody>
-      </p:sp>
-      <p:sp>
-        <p:nvSpPr>
-          <p:cNvPr id="3" name="Text 1"/>
-          <p:cNvSpPr/>
-          <p:nvPr/>
-        </p:nvSpPr>
-        <p:spPr>
-          <a:xfrm>
-            <a:off x="640080" y="987552"/>
-            <a:ext cx="10058400" cy="640080"/>
-          </a:xfrm>
-          <a:prstGeom prst="rect">
-            <a:avLst/>
-          </a:prstGeom>
-          <a:noFill/>
-          <a:ln/>
-        </p:spPr>
-        <p:txBody>
-          <a:bodyPr wrap="square" rtlCol="0" anchor="ctr"/>
-          <a:lstStyle/>
-          <a:p>
-            <a:pPr indent="0" marL="0">
-              <a:buNone/>
-            </a:pPr>
-            <a:r>
-              <a:rPr lang="en-US" sz="2800" b="1" dirty="0">
-                <a:solidFill>
-                  <a:srgbClr val="1A1A1A"/>
-                </a:solidFill>
-                <a:latin typeface="Cambria" pitchFamily="34" charset="0"/>
-                <a:ea typeface="Cambria" pitchFamily="34" charset="-122"/>
-                <a:cs typeface="Cambria" pitchFamily="34" charset="-120"/>
-              </a:rPr>
-              <a:t>The course's through-lines</a:t>
-            </a:r>
-            <a:endParaRPr lang="en-US" sz="2800" dirty="0"/>
-          </a:p>
-        </p:txBody>
-      </p:sp>
-      <p:sp>
-        <p:nvSpPr>
-          <p:cNvPr id="4" name="Shape 2"/>
-          <p:cNvSpPr/>
-          <p:nvPr/>
-        </p:nvSpPr>
-        <p:spPr>
-          <a:xfrm>
-            <a:off x="640080" y="2057400"/>
-            <a:ext cx="457200" cy="457200"/>
-          </a:xfrm>
-          <a:prstGeom prst="roundRect">
-            <a:avLst>
-              <a:gd name="adj" fmla="val 16000"/>
-            </a:avLst>
-          </a:prstGeom>
-          <a:solidFill>
-            <a:srgbClr val="7A3B2E"/>
-          </a:solidFill>
-          <a:ln/>
-        </p:spPr>
+              <a:t>Reading</a:t>
+            </a:r>
+            <a:endParaRPr lang="en-US" sz="1500" dirty="0"/>
+          </a:p>
+        </p:txBody>
       </p:sp>
       <p:sp>
         <p:nvSpPr>
@@ -5588,86 +5556,8 @@
         </p:nvSpPr>
         <p:spPr>
           <a:xfrm>
-            <a:off x="640080" y="2057400"/>
-            <a:ext cx="457200" cy="457200"/>
-          </a:xfrm>
-          <a:prstGeom prst="rect">
-            <a:avLst/>
-          </a:prstGeom>
-          <a:noFill/>
-          <a:ln/>
-        </p:spPr>
-        <p:txBody>
-          <a:bodyPr wrap="square" rtlCol="0" anchor="ctr"/>
-          <a:lstStyle/>
-          <a:p>
-            <a:pPr algn="ctr" indent="0" marL="0">
-              <a:buNone/>
-            </a:pPr>
-            <a:r>
-              <a:rPr lang="en-US" sz="2000" b="1" dirty="0">
-                <a:solidFill>
-                  <a:srgbClr val="FFFFFF"/>
-                </a:solidFill>
-                <a:latin typeface="Cambria" pitchFamily="34" charset="0"/>
-                <a:ea typeface="Cambria" pitchFamily="34" charset="-122"/>
-                <a:cs typeface="Cambria" pitchFamily="34" charset="-120"/>
-              </a:rPr>
-              <a:t>1</a:t>
-            </a:r>
-            <a:endParaRPr lang="en-US" sz="2000" dirty="0"/>
-          </a:p>
-        </p:txBody>
-      </p:sp>
-      <p:sp>
-        <p:nvSpPr>
-          <p:cNvPr id="6" name="Text 4"/>
-          <p:cNvSpPr/>
-          <p:nvPr/>
-        </p:nvSpPr>
-        <p:spPr>
-          <a:xfrm>
-            <a:off x="1371600" y="2020824"/>
-            <a:ext cx="10332720" cy="411480"/>
-          </a:xfrm>
-          <a:prstGeom prst="rect">
-            <a:avLst/>
-          </a:prstGeom>
-          <a:noFill/>
-          <a:ln/>
-        </p:spPr>
-        <p:txBody>
-          <a:bodyPr wrap="square" rtlCol="0" anchor="ctr"/>
-          <a:lstStyle/>
-          <a:p>
-            <a:pPr indent="0" marL="0">
-              <a:buNone/>
-            </a:pPr>
-            <a:r>
-              <a:rPr lang="en-US" sz="1900" b="1" dirty="0">
-                <a:solidFill>
-                  <a:srgbClr val="7A3B2E"/>
-                </a:solidFill>
-                <a:latin typeface="Cambria" pitchFamily="34" charset="0"/>
-                <a:ea typeface="Cambria" pitchFamily="34" charset="-122"/>
-                <a:cs typeface="Cambria" pitchFamily="34" charset="-120"/>
-              </a:rPr>
-              <a:t>Read work critically</a:t>
-            </a:r>
-            <a:endParaRPr lang="en-US" sz="1900" dirty="0"/>
-          </a:p>
-        </p:txBody>
-      </p:sp>
-      <p:sp>
-        <p:nvSpPr>
-          <p:cNvPr id="7" name="Text 5"/>
-          <p:cNvSpPr/>
-          <p:nvPr/>
-        </p:nvSpPr>
-        <p:spPr>
-          <a:xfrm>
-            <a:off x="1371600" y="2441448"/>
-            <a:ext cx="10332720" cy="914400"/>
+            <a:off x="1051560" y="1984248"/>
+            <a:ext cx="10424160" cy="731520"/>
           </a:xfrm>
           <a:prstGeom prst="rect">
             <a:avLst/>
@@ -5682,13 +5572,10 @@
           <a:lstStyle/>
           <a:p>
             <a:pPr indent="0" marL="0">
-              <a:lnSpc>
-                <a:spcPct val="112000"/>
-              </a:lnSpc>
-              <a:buNone/>
-            </a:pPr>
-            <a:r>
-              <a:rPr lang="en-US" sz="1450" dirty="0">
+              <a:buNone/>
+            </a:pPr>
+            <a:r>
+              <a:rPr lang="en-US" sz="1400" dirty="0">
                 <a:solidFill>
                   <a:srgbClr val="1A1A1A"/>
                 </a:solidFill>
@@ -5696,27 +5583,25 @@
                 <a:ea typeface="Calibri" pitchFamily="34" charset="-122"/>
                 <a:cs typeface="Calibri" pitchFamily="34" charset="-120"/>
               </a:rPr>
-              <a:t>She Giggles, He Gallops is excellent and its choices are debatable. Admiring and questioning at once is the habit the course is built on.</a:t>
-            </a:r>
-            <a:endParaRPr lang="en-US" sz="1450" dirty="0"/>
-          </a:p>
-        </p:txBody>
-      </p:sp>
-      <p:sp>
-        <p:nvSpPr>
-          <p:cNvPr id="8" name="Shape 6"/>
-          <p:cNvSpPr/>
-          <p:nvPr/>
-        </p:nvSpPr>
-        <p:spPr>
-          <a:xfrm>
-            <a:off x="640080" y="3520440"/>
-            <a:ext cx="457200" cy="457200"/>
-          </a:xfrm>
-          <a:prstGeom prst="roundRect">
-            <a:avLst>
-              <a:gd name="adj" fmla="val 16000"/>
-            </a:avLst>
+              <a:t>Bollen et al., the cognitive-distortions hockey stick (PNAS 2021), with the Schmidt et al. critique</a:t>
+            </a:r>
+            <a:endParaRPr lang="en-US" sz="1400" dirty="0"/>
+          </a:p>
+        </p:txBody>
+      </p:sp>
+      <p:sp>
+        <p:nvSpPr>
+          <p:cNvPr id="6" name="Shape 4"/>
+          <p:cNvSpPr/>
+          <p:nvPr/>
+        </p:nvSpPr>
+        <p:spPr>
+          <a:xfrm>
+            <a:off x="640080" y="2633472"/>
+            <a:ext cx="219456" cy="219456"/>
+          </a:xfrm>
+          <a:prstGeom prst="ellipse">
+            <a:avLst/>
           </a:prstGeom>
           <a:solidFill>
             <a:srgbClr val="3F6F5F"/>
@@ -5726,14 +5611,14 @@
       </p:sp>
       <p:sp>
         <p:nvSpPr>
-          <p:cNvPr id="9" name="Text 7"/>
-          <p:cNvSpPr/>
-          <p:nvPr/>
-        </p:nvSpPr>
-        <p:spPr>
-          <a:xfrm>
-            <a:off x="640080" y="3520440"/>
-            <a:ext cx="457200" cy="457200"/>
+          <p:cNvPr id="7" name="Text 5"/>
+          <p:cNvSpPr/>
+          <p:nvPr/>
+        </p:nvSpPr>
+        <p:spPr>
+          <a:xfrm>
+            <a:off x="1051560" y="2560320"/>
+            <a:ext cx="10424160" cy="365760"/>
           </a:xfrm>
           <a:prstGeom prst="rect">
             <a:avLst/>
@@ -5745,73 +5630,34 @@
           <a:bodyPr wrap="square" rtlCol="0" anchor="ctr"/>
           <a:lstStyle/>
           <a:p>
-            <a:pPr algn="ctr" indent="0" marL="0">
-              <a:buNone/>
-            </a:pPr>
-            <a:r>
-              <a:rPr lang="en-US" sz="2000" b="1" dirty="0">
-                <a:solidFill>
-                  <a:srgbClr val="FFFFFF"/>
-                </a:solidFill>
-                <a:latin typeface="Cambria" pitchFamily="34" charset="0"/>
-                <a:ea typeface="Cambria" pitchFamily="34" charset="-122"/>
-                <a:cs typeface="Cambria" pitchFamily="34" charset="-120"/>
-              </a:rPr>
-              <a:t>2</a:t>
-            </a:r>
-            <a:endParaRPr lang="en-US" sz="2000" dirty="0"/>
-          </a:p>
-        </p:txBody>
-      </p:sp>
-      <p:sp>
-        <p:nvSpPr>
-          <p:cNvPr id="10" name="Text 8"/>
-          <p:cNvSpPr/>
-          <p:nvPr/>
-        </p:nvSpPr>
-        <p:spPr>
-          <a:xfrm>
-            <a:off x="1371600" y="3483864"/>
-            <a:ext cx="10332720" cy="411480"/>
-          </a:xfrm>
-          <a:prstGeom prst="rect">
-            <a:avLst/>
-          </a:prstGeom>
-          <a:noFill/>
-          <a:ln/>
-        </p:spPr>
-        <p:txBody>
-          <a:bodyPr wrap="square" rtlCol="0" anchor="ctr"/>
-          <a:lstStyle/>
-          <a:p>
-            <a:pPr indent="0" marL="0">
-              <a:buNone/>
-            </a:pPr>
-            <a:r>
-              <a:rPr lang="en-US" sz="1900" b="1" dirty="0">
+            <a:pPr indent="0" marL="0">
+              <a:buNone/>
+            </a:pPr>
+            <a:r>
+              <a:rPr lang="en-US" sz="1500" b="1" dirty="0">
                 <a:solidFill>
                   <a:srgbClr val="3F6F5F"/>
                 </a:solidFill>
-                <a:latin typeface="Cambria" pitchFamily="34" charset="0"/>
-                <a:ea typeface="Cambria" pitchFamily="34" charset="-122"/>
-                <a:cs typeface="Cambria" pitchFamily="34" charset="-120"/>
-              </a:rPr>
-              <a:t>Make something real</a:t>
-            </a:r>
-            <a:endParaRPr lang="en-US" sz="1900" dirty="0"/>
-          </a:p>
-        </p:txBody>
-      </p:sp>
-      <p:sp>
-        <p:nvSpPr>
-          <p:cNvPr id="11" name="Text 9"/>
-          <p:cNvSpPr/>
-          <p:nvPr/>
-        </p:nvSpPr>
-        <p:spPr>
-          <a:xfrm>
-            <a:off x="1371600" y="3904488"/>
-            <a:ext cx="10332720" cy="914400"/>
+                <a:latin typeface="Calibri" pitchFamily="34" charset="0"/>
+                <a:ea typeface="Calibri" pitchFamily="34" charset="-122"/>
+                <a:cs typeface="Calibri" pitchFamily="34" charset="-120"/>
+              </a:rPr>
+              <a:t>Supplement</a:t>
+            </a:r>
+            <a:endParaRPr lang="en-US" sz="1500" dirty="0"/>
+          </a:p>
+        </p:txBody>
+      </p:sp>
+      <p:sp>
+        <p:nvSpPr>
+          <p:cNvPr id="8" name="Text 6"/>
+          <p:cNvSpPr/>
+          <p:nvPr/>
+        </p:nvSpPr>
+        <p:spPr>
+          <a:xfrm>
+            <a:off x="1051560" y="2944368"/>
+            <a:ext cx="10424160" cy="731520"/>
           </a:xfrm>
           <a:prstGeom prst="rect">
             <a:avLst/>
@@ -5826,13 +5672,10 @@
           <a:lstStyle/>
           <a:p>
             <a:pPr indent="0" marL="0">
-              <a:lnSpc>
-                <a:spcPct val="112000"/>
-              </a:lnSpc>
-              <a:buNone/>
-            </a:pPr>
-            <a:r>
-              <a:rPr lang="en-US" sz="1450" dirty="0">
+              <a:buNone/>
+            </a:pPr>
+            <a:r>
+              <a:rPr lang="en-US" sz="1400" dirty="0">
                 <a:solidFill>
                   <a:srgbClr val="1A1A1A"/>
                 </a:solidFill>
@@ -5840,27 +5683,25 @@
                 <a:ea typeface="Calibri" pitchFamily="34" charset="-122"/>
                 <a:cs typeface="Calibri" pitchFamily="34" charset="-120"/>
               </a:rPr>
-              <a:t>A complete investigation by the first break, before any theory.</a:t>
-            </a:r>
-            <a:endParaRPr lang="en-US" sz="1450" dirty="0"/>
-          </a:p>
-        </p:txBody>
-      </p:sp>
-      <p:sp>
-        <p:nvSpPr>
-          <p:cNvPr id="12" name="Shape 10"/>
-          <p:cNvSpPr/>
-          <p:nvPr/>
-        </p:nvSpPr>
-        <p:spPr>
-          <a:xfrm>
-            <a:off x="640080" y="4983480"/>
-            <a:ext cx="457200" cy="457200"/>
-          </a:xfrm>
-          <a:prstGeom prst="roundRect">
-            <a:avLst>
-              <a:gd name="adj" fmla="val 16000"/>
-            </a:avLst>
+              <a:t>Robin Sloan, Writing with the machine; Drucker, Humanities Approaches to Graphical Display (DHQ 2011), the case that all data is capta</a:t>
+            </a:r>
+            <a:endParaRPr lang="en-US" sz="1400" dirty="0"/>
+          </a:p>
+        </p:txBody>
+      </p:sp>
+      <p:sp>
+        <p:nvSpPr>
+          <p:cNvPr id="9" name="Shape 7"/>
+          <p:cNvSpPr/>
+          <p:nvPr/>
+        </p:nvSpPr>
+        <p:spPr>
+          <a:xfrm>
+            <a:off x="640080" y="3593592"/>
+            <a:ext cx="219456" cy="219456"/>
+          </a:xfrm>
+          <a:prstGeom prst="ellipse">
+            <a:avLst/>
           </a:prstGeom>
           <a:solidFill>
             <a:srgbClr val="B9852F"/>
@@ -5870,14 +5711,14 @@
       </p:sp>
       <p:sp>
         <p:nvSpPr>
-          <p:cNvPr id="13" name="Text 11"/>
-          <p:cNvSpPr/>
-          <p:nvPr/>
-        </p:nvSpPr>
-        <p:spPr>
-          <a:xfrm>
-            <a:off x="640080" y="4983480"/>
-            <a:ext cx="457200" cy="457200"/>
+          <p:cNvPr id="10" name="Text 8"/>
+          <p:cNvSpPr/>
+          <p:nvPr/>
+        </p:nvSpPr>
+        <p:spPr>
+          <a:xfrm>
+            <a:off x="1051560" y="3520440"/>
+            <a:ext cx="10424160" cy="365760"/>
           </a:xfrm>
           <a:prstGeom prst="rect">
             <a:avLst/>
@@ -5889,73 +5730,34 @@
           <a:bodyPr wrap="square" rtlCol="0" anchor="ctr"/>
           <a:lstStyle/>
           <a:p>
-            <a:pPr algn="ctr" indent="0" marL="0">
-              <a:buNone/>
-            </a:pPr>
-            <a:r>
-              <a:rPr lang="en-US" sz="2000" b="1" dirty="0">
-                <a:solidFill>
-                  <a:srgbClr val="FFFFFF"/>
-                </a:solidFill>
-                <a:latin typeface="Cambria" pitchFamily="34" charset="0"/>
-                <a:ea typeface="Cambria" pitchFamily="34" charset="-122"/>
-                <a:cs typeface="Cambria" pitchFamily="34" charset="-120"/>
-              </a:rPr>
-              <a:t>3</a:t>
-            </a:r>
-            <a:endParaRPr lang="en-US" sz="2000" dirty="0"/>
-          </a:p>
-        </p:txBody>
-      </p:sp>
-      <p:sp>
-        <p:nvSpPr>
-          <p:cNvPr id="14" name="Text 12"/>
-          <p:cNvSpPr/>
-          <p:nvPr/>
-        </p:nvSpPr>
-        <p:spPr>
-          <a:xfrm>
-            <a:off x="1371600" y="4946904"/>
-            <a:ext cx="10332720" cy="411480"/>
-          </a:xfrm>
-          <a:prstGeom prst="rect">
-            <a:avLst/>
-          </a:prstGeom>
-          <a:noFill/>
-          <a:ln/>
-        </p:spPr>
-        <p:txBody>
-          <a:bodyPr wrap="square" rtlCol="0" anchor="ctr"/>
-          <a:lstStyle/>
-          <a:p>
-            <a:pPr indent="0" marL="0">
-              <a:buNone/>
-            </a:pPr>
-            <a:r>
-              <a:rPr lang="en-US" sz="1900" b="1" dirty="0">
+            <a:pPr indent="0" marL="0">
+              <a:buNone/>
+            </a:pPr>
+            <a:r>
+              <a:rPr lang="en-US" sz="1500" b="1" dirty="0">
                 <a:solidFill>
                   <a:srgbClr val="B9852F"/>
                 </a:solidFill>
-                <a:latin typeface="Cambria" pitchFamily="34" charset="0"/>
-                <a:ea typeface="Cambria" pitchFamily="34" charset="-122"/>
-                <a:cs typeface="Cambria" pitchFamily="34" charset="-120"/>
-              </a:rPr>
-              <a:t>Images are culture too</a:t>
-            </a:r>
-            <a:endParaRPr lang="en-US" sz="1900" dirty="0"/>
-          </a:p>
-        </p:txBody>
-      </p:sp>
-      <p:sp>
-        <p:nvSpPr>
-          <p:cNvPr id="15" name="Text 13"/>
-          <p:cNvSpPr/>
-          <p:nvPr/>
-        </p:nvSpPr>
-        <p:spPr>
-          <a:xfrm>
-            <a:off x="1371600" y="5367528"/>
-            <a:ext cx="10332720" cy="914400"/>
+                <a:latin typeface="Calibri" pitchFamily="34" charset="0"/>
+                <a:ea typeface="Calibri" pitchFamily="34" charset="-122"/>
+                <a:cs typeface="Calibri" pitchFamily="34" charset="-120"/>
+              </a:rPr>
+              <a:t>Deeper (optional)</a:t>
+            </a:r>
+            <a:endParaRPr lang="en-US" sz="1500" dirty="0"/>
+          </a:p>
+        </p:txBody>
+      </p:sp>
+      <p:sp>
+        <p:nvSpPr>
+          <p:cNvPr id="11" name="Text 9"/>
+          <p:cNvSpPr/>
+          <p:nvPr/>
+        </p:nvSpPr>
+        <p:spPr>
+          <a:xfrm>
+            <a:off x="1051560" y="3904488"/>
+            <a:ext cx="10424160" cy="731520"/>
           </a:xfrm>
           <a:prstGeom prst="rect">
             <a:avLst/>
@@ -5970,13 +5772,10 @@
           <a:lstStyle/>
           <a:p>
             <a:pPr indent="0" marL="0">
-              <a:lnSpc>
-                <a:spcPct val="112000"/>
-              </a:lnSpc>
-              <a:buNone/>
-            </a:pPr>
-            <a:r>
-              <a:rPr lang="en-US" sz="1450" dirty="0">
+              <a:buNone/>
+            </a:pPr>
+            <a:r>
+              <a:rPr lang="en-US" sz="1400" dirty="0">
                 <a:solidFill>
                   <a:srgbClr val="1A1A1A"/>
                 </a:solidFill>
@@ -5984,9 +5783,209 @@
                 <a:ea typeface="Calibri" pitchFamily="34" charset="-122"/>
                 <a:cs typeface="Calibri" pitchFamily="34" charset="-120"/>
               </a:rPr>
-              <a:t>A picture is numbers: you counted pixels on day one, and images continue as a co-equal corpus through all ten weeks.</a:t>
-            </a:r>
-            <a:endParaRPr lang="en-US" sz="1450" dirty="0"/>
+              <a:t>Moretti, Conjectures on World Literature (NLR 2000), the founding argument for reading culture at scale</a:t>
+            </a:r>
+            <a:endParaRPr lang="en-US" sz="1400" dirty="0"/>
+          </a:p>
+        </p:txBody>
+      </p:sp>
+      <p:sp>
+        <p:nvSpPr>
+          <p:cNvPr id="12" name="Shape 10"/>
+          <p:cNvSpPr/>
+          <p:nvPr/>
+        </p:nvSpPr>
+        <p:spPr>
+          <a:xfrm>
+            <a:off x="640080" y="4553712"/>
+            <a:ext cx="219456" cy="219456"/>
+          </a:xfrm>
+          <a:prstGeom prst="ellipse">
+            <a:avLst/>
+          </a:prstGeom>
+          <a:solidFill>
+            <a:srgbClr val="3F6F5F"/>
+          </a:solidFill>
+          <a:ln/>
+        </p:spPr>
+      </p:sp>
+      <p:sp>
+        <p:nvSpPr>
+          <p:cNvPr id="13" name="Text 11"/>
+          <p:cNvSpPr/>
+          <p:nvPr/>
+        </p:nvSpPr>
+        <p:spPr>
+          <a:xfrm>
+            <a:off x="1051560" y="4480560"/>
+            <a:ext cx="10424160" cy="365760"/>
+          </a:xfrm>
+          <a:prstGeom prst="rect">
+            <a:avLst/>
+          </a:prstGeom>
+          <a:noFill/>
+          <a:ln/>
+        </p:spPr>
+        <p:txBody>
+          <a:bodyPr wrap="square" rtlCol="0" anchor="ctr"/>
+          <a:lstStyle/>
+          <a:p>
+            <a:pPr indent="0" marL="0">
+              <a:buNone/>
+            </a:pPr>
+            <a:r>
+              <a:rPr lang="en-US" sz="1500" b="1" dirty="0">
+                <a:solidFill>
+                  <a:srgbClr val="3F6F5F"/>
+                </a:solidFill>
+                <a:latin typeface="Calibri" pitchFamily="34" charset="0"/>
+                <a:ea typeface="Calibri" pitchFamily="34" charset="-122"/>
+                <a:cs typeface="Calibri" pitchFamily="34" charset="-120"/>
+              </a:rPr>
+              <a:t>Sketch</a:t>
+            </a:r>
+            <a:endParaRPr lang="en-US" sz="1500" dirty="0"/>
+          </a:p>
+        </p:txBody>
+      </p:sp>
+      <p:sp>
+        <p:nvSpPr>
+          <p:cNvPr id="14" name="Text 12"/>
+          <p:cNvSpPr/>
+          <p:nvPr/>
+        </p:nvSpPr>
+        <p:spPr>
+          <a:xfrm>
+            <a:off x="1051560" y="4864608"/>
+            <a:ext cx="10424160" cy="731520"/>
+          </a:xfrm>
+          <a:prstGeom prst="rect">
+            <a:avLst/>
+          </a:prstGeom>
+          <a:noFill/>
+          <a:ln/>
+        </p:spPr>
+        <p:txBody>
+          <a:bodyPr wrap="square" rtlCol="0" anchor="t">
+            <a:spAutoFit/>
+          </a:bodyPr>
+          <a:lstStyle/>
+          <a:p>
+            <a:pPr indent="0" marL="0">
+              <a:buNone/>
+            </a:pPr>
+            <a:r>
+              <a:rPr lang="en-US" sz="1400" dirty="0">
+                <a:solidFill>
+                  <a:srgbClr val="1A1A1A"/>
+                </a:solidFill>
+                <a:latin typeface="Calibri" pitchFamily="34" charset="0"/>
+                <a:ea typeface="Calibri" pitchFamily="34" charset="-122"/>
+                <a:cs typeface="Calibri" pitchFamily="34" charset="-120"/>
+              </a:rPr>
+              <a:t>One question from your life, answerable with data (three sentences), plus the notebook's after-class half (~20 minutes).</a:t>
+            </a:r>
+            <a:endParaRPr lang="en-US" sz="1400" dirty="0"/>
+          </a:p>
+        </p:txBody>
+      </p:sp>
+      <p:sp>
+        <p:nvSpPr>
+          <p:cNvPr id="15" name="Shape 13"/>
+          <p:cNvSpPr/>
+          <p:nvPr/>
+        </p:nvSpPr>
+        <p:spPr>
+          <a:xfrm>
+            <a:off x="640080" y="5513832"/>
+            <a:ext cx="219456" cy="219456"/>
+          </a:xfrm>
+          <a:prstGeom prst="ellipse">
+            <a:avLst/>
+          </a:prstGeom>
+          <a:solidFill>
+            <a:srgbClr val="7A3B2E"/>
+          </a:solidFill>
+          <a:ln/>
+        </p:spPr>
+      </p:sp>
+      <p:sp>
+        <p:nvSpPr>
+          <p:cNvPr id="16" name="Text 14"/>
+          <p:cNvSpPr/>
+          <p:nvPr/>
+        </p:nvSpPr>
+        <p:spPr>
+          <a:xfrm>
+            <a:off x="1051560" y="5440680"/>
+            <a:ext cx="10424160" cy="365760"/>
+          </a:xfrm>
+          <a:prstGeom prst="rect">
+            <a:avLst/>
+          </a:prstGeom>
+          <a:noFill/>
+          <a:ln/>
+        </p:spPr>
+        <p:txBody>
+          <a:bodyPr wrap="square" rtlCol="0" anchor="ctr"/>
+          <a:lstStyle/>
+          <a:p>
+            <a:pPr indent="0" marL="0">
+              <a:buNone/>
+            </a:pPr>
+            <a:r>
+              <a:rPr lang="en-US" sz="1500" b="1" dirty="0">
+                <a:solidFill>
+                  <a:srgbClr val="7A3B2E"/>
+                </a:solidFill>
+                <a:latin typeface="Calibri" pitchFamily="34" charset="0"/>
+                <a:ea typeface="Calibri" pitchFamily="34" charset="-122"/>
+                <a:cs typeface="Calibri" pitchFamily="34" charset="-120"/>
+              </a:rPr>
+              <a:t>Check (AI closed)</a:t>
+            </a:r>
+            <a:endParaRPr lang="en-US" sz="1500" dirty="0"/>
+          </a:p>
+        </p:txBody>
+      </p:sp>
+      <p:sp>
+        <p:nvSpPr>
+          <p:cNvPr id="17" name="Text 15"/>
+          <p:cNvSpPr/>
+          <p:nvPr/>
+        </p:nvSpPr>
+        <p:spPr>
+          <a:xfrm>
+            <a:off x="1051560" y="5824728"/>
+            <a:ext cx="10424160" cy="731520"/>
+          </a:xfrm>
+          <a:prstGeom prst="rect">
+            <a:avLst/>
+          </a:prstGeom>
+          <a:noFill/>
+          <a:ln/>
+        </p:spPr>
+        <p:txBody>
+          <a:bodyPr wrap="square" rtlCol="0" anchor="t">
+            <a:spAutoFit/>
+          </a:bodyPr>
+          <a:lstStyle/>
+          <a:p>
+            <a:pPr indent="0" marL="0">
+              <a:buNone/>
+            </a:pPr>
+            <a:r>
+              <a:rPr lang="en-US" sz="1400" dirty="0">
+                <a:solidFill>
+                  <a:srgbClr val="1A1A1A"/>
+                </a:solidFill>
+                <a:latin typeface="Calibri" pitchFamily="34" charset="0"/>
+                <a:ea typeface="Calibri" pitchFamily="34" charset="-122"/>
+                <a:cs typeface="Calibri" pitchFamily="34" charset="-120"/>
+              </a:rPr>
+              <a:t>Trace it: one written sentence predicting what your cell does before you run it. (Competency 1.)</a:t>
+            </a:r>
+            <a:endParaRPr lang="en-US" sz="1400" dirty="0"/>
           </a:p>
         </p:txBody>
       </p:sp>
@@ -6001,6 +6000,548 @@
 <file path=ppt/slides/slide16.xml><?xml version="1.0" encoding="utf-8"?>
 <p:sld xmlns:a="http://schemas.openxmlformats.org/drawingml/2006/main" xmlns:r="http://schemas.openxmlformats.org/officeDocument/2006/relationships" xmlns:p="http://schemas.openxmlformats.org/presentationml/2006/main">
   <p:cSld name="Slide 16">
+    <p:bg>
+      <p:bgPr>
+        <a:solidFill>
+          <a:srgbClr val="FFFFFF"/>
+        </a:solidFill>
+      </p:bgPr>
+    </p:bg>
+    <p:spTree>
+      <p:nvGrpSpPr>
+        <p:cNvPr id="1" name=""/>
+        <p:cNvGrpSpPr/>
+        <p:nvPr/>
+      </p:nvGrpSpPr>
+      <p:grpSpPr>
+        <a:xfrm>
+          <a:off x="0" y="0"/>
+          <a:ext cx="0" cy="0"/>
+          <a:chOff x="0" y="0"/>
+          <a:chExt cx="0" cy="0"/>
+        </a:xfrm>
+      </p:grpSpPr>
+      <p:sp>
+        <p:nvSpPr>
+          <p:cNvPr id="2" name="Text 0"/>
+          <p:cNvSpPr/>
+          <p:nvPr/>
+        </p:nvSpPr>
+        <p:spPr>
+          <a:xfrm>
+            <a:off x="640080" y="640080"/>
+            <a:ext cx="10058400" cy="320040"/>
+          </a:xfrm>
+          <a:prstGeom prst="rect">
+            <a:avLst/>
+          </a:prstGeom>
+          <a:noFill/>
+          <a:ln/>
+        </p:spPr>
+        <p:txBody>
+          <a:bodyPr wrap="square" rtlCol="0" anchor="ctr"/>
+          <a:lstStyle/>
+          <a:p>
+            <a:pPr indent="0" marL="0">
+              <a:buNone/>
+            </a:pPr>
+            <a:r>
+              <a:rPr lang="en-US" sz="1300" b="1" spc="300" kern="0" dirty="0">
+                <a:solidFill>
+                  <a:srgbClr val="7A3B2E"/>
+                </a:solidFill>
+                <a:latin typeface="Calibri" pitchFamily="34" charset="0"/>
+                <a:ea typeface="Calibri" pitchFamily="34" charset="-122"/>
+                <a:cs typeface="Calibri" pitchFamily="34" charset="-120"/>
+              </a:rPr>
+              <a:t>HOW THIS WEEK CONNECTS</a:t>
+            </a:r>
+            <a:endParaRPr lang="en-US" sz="1300" dirty="0"/>
+          </a:p>
+        </p:txBody>
+      </p:sp>
+      <p:sp>
+        <p:nvSpPr>
+          <p:cNvPr id="3" name="Text 1"/>
+          <p:cNvSpPr/>
+          <p:nvPr/>
+        </p:nvSpPr>
+        <p:spPr>
+          <a:xfrm>
+            <a:off x="640080" y="987552"/>
+            <a:ext cx="10058400" cy="640080"/>
+          </a:xfrm>
+          <a:prstGeom prst="rect">
+            <a:avLst/>
+          </a:prstGeom>
+          <a:noFill/>
+          <a:ln/>
+        </p:spPr>
+        <p:txBody>
+          <a:bodyPr wrap="square" rtlCol="0" anchor="ctr"/>
+          <a:lstStyle/>
+          <a:p>
+            <a:pPr indent="0" marL="0">
+              <a:buNone/>
+            </a:pPr>
+            <a:r>
+              <a:rPr lang="en-US" sz="2800" b="1" dirty="0">
+                <a:solidFill>
+                  <a:srgbClr val="1A1A1A"/>
+                </a:solidFill>
+                <a:latin typeface="Cambria" pitchFamily="34" charset="0"/>
+                <a:ea typeface="Cambria" pitchFamily="34" charset="-122"/>
+                <a:cs typeface="Cambria" pitchFamily="34" charset="-120"/>
+              </a:rPr>
+              <a:t>The course's through-lines</a:t>
+            </a:r>
+            <a:endParaRPr lang="en-US" sz="2800" dirty="0"/>
+          </a:p>
+        </p:txBody>
+      </p:sp>
+      <p:sp>
+        <p:nvSpPr>
+          <p:cNvPr id="4" name="Shape 2"/>
+          <p:cNvSpPr/>
+          <p:nvPr/>
+        </p:nvSpPr>
+        <p:spPr>
+          <a:xfrm>
+            <a:off x="640080" y="2057400"/>
+            <a:ext cx="457200" cy="457200"/>
+          </a:xfrm>
+          <a:prstGeom prst="roundRect">
+            <a:avLst>
+              <a:gd name="adj" fmla="val 16000"/>
+            </a:avLst>
+          </a:prstGeom>
+          <a:solidFill>
+            <a:srgbClr val="7A3B2E"/>
+          </a:solidFill>
+          <a:ln/>
+        </p:spPr>
+      </p:sp>
+      <p:sp>
+        <p:nvSpPr>
+          <p:cNvPr id="5" name="Text 3"/>
+          <p:cNvSpPr/>
+          <p:nvPr/>
+        </p:nvSpPr>
+        <p:spPr>
+          <a:xfrm>
+            <a:off x="640080" y="2057400"/>
+            <a:ext cx="457200" cy="457200"/>
+          </a:xfrm>
+          <a:prstGeom prst="rect">
+            <a:avLst/>
+          </a:prstGeom>
+          <a:noFill/>
+          <a:ln/>
+        </p:spPr>
+        <p:txBody>
+          <a:bodyPr wrap="square" rtlCol="0" anchor="ctr"/>
+          <a:lstStyle/>
+          <a:p>
+            <a:pPr algn="ctr" indent="0" marL="0">
+              <a:buNone/>
+            </a:pPr>
+            <a:r>
+              <a:rPr lang="en-US" sz="2000" b="1" dirty="0">
+                <a:solidFill>
+                  <a:srgbClr val="FFFFFF"/>
+                </a:solidFill>
+                <a:latin typeface="Cambria" pitchFamily="34" charset="0"/>
+                <a:ea typeface="Cambria" pitchFamily="34" charset="-122"/>
+                <a:cs typeface="Cambria" pitchFamily="34" charset="-120"/>
+              </a:rPr>
+              <a:t>1</a:t>
+            </a:r>
+            <a:endParaRPr lang="en-US" sz="2000" dirty="0"/>
+          </a:p>
+        </p:txBody>
+      </p:sp>
+      <p:sp>
+        <p:nvSpPr>
+          <p:cNvPr id="6" name="Text 4"/>
+          <p:cNvSpPr/>
+          <p:nvPr/>
+        </p:nvSpPr>
+        <p:spPr>
+          <a:xfrm>
+            <a:off x="1371600" y="2020824"/>
+            <a:ext cx="10332720" cy="411480"/>
+          </a:xfrm>
+          <a:prstGeom prst="rect">
+            <a:avLst/>
+          </a:prstGeom>
+          <a:noFill/>
+          <a:ln/>
+        </p:spPr>
+        <p:txBody>
+          <a:bodyPr wrap="square" rtlCol="0" anchor="ctr"/>
+          <a:lstStyle/>
+          <a:p>
+            <a:pPr indent="0" marL="0">
+              <a:buNone/>
+            </a:pPr>
+            <a:r>
+              <a:rPr lang="en-US" sz="1900" b="1" dirty="0">
+                <a:solidFill>
+                  <a:srgbClr val="7A3B2E"/>
+                </a:solidFill>
+                <a:latin typeface="Cambria" pitchFamily="34" charset="0"/>
+                <a:ea typeface="Cambria" pitchFamily="34" charset="-122"/>
+                <a:cs typeface="Cambria" pitchFamily="34" charset="-120"/>
+              </a:rPr>
+              <a:t>Read work critically</a:t>
+            </a:r>
+            <a:endParaRPr lang="en-US" sz="1900" dirty="0"/>
+          </a:p>
+        </p:txBody>
+      </p:sp>
+      <p:sp>
+        <p:nvSpPr>
+          <p:cNvPr id="7" name="Text 5"/>
+          <p:cNvSpPr/>
+          <p:nvPr/>
+        </p:nvSpPr>
+        <p:spPr>
+          <a:xfrm>
+            <a:off x="1371600" y="2441448"/>
+            <a:ext cx="10332720" cy="914400"/>
+          </a:xfrm>
+          <a:prstGeom prst="rect">
+            <a:avLst/>
+          </a:prstGeom>
+          <a:noFill/>
+          <a:ln/>
+        </p:spPr>
+        <p:txBody>
+          <a:bodyPr wrap="square" rtlCol="0" anchor="t">
+            <a:spAutoFit/>
+          </a:bodyPr>
+          <a:lstStyle/>
+          <a:p>
+            <a:pPr indent="0" marL="0">
+              <a:lnSpc>
+                <a:spcPct val="112000"/>
+              </a:lnSpc>
+              <a:buNone/>
+            </a:pPr>
+            <a:r>
+              <a:rPr lang="en-US" sz="1450" dirty="0">
+                <a:solidFill>
+                  <a:srgbClr val="1A1A1A"/>
+                </a:solidFill>
+                <a:latin typeface="Calibri" pitchFamily="34" charset="0"/>
+                <a:ea typeface="Calibri" pitchFamily="34" charset="-122"/>
+                <a:cs typeface="Calibri" pitchFamily="34" charset="-120"/>
+              </a:rPr>
+              <a:t>She Giggles, He Gallops is excellent and its choices are debatable. Admiring and questioning at once is the habit the course is built on.</a:t>
+            </a:r>
+            <a:endParaRPr lang="en-US" sz="1450" dirty="0"/>
+          </a:p>
+        </p:txBody>
+      </p:sp>
+      <p:sp>
+        <p:nvSpPr>
+          <p:cNvPr id="8" name="Shape 6"/>
+          <p:cNvSpPr/>
+          <p:nvPr/>
+        </p:nvSpPr>
+        <p:spPr>
+          <a:xfrm>
+            <a:off x="640080" y="3520440"/>
+            <a:ext cx="457200" cy="457200"/>
+          </a:xfrm>
+          <a:prstGeom prst="roundRect">
+            <a:avLst>
+              <a:gd name="adj" fmla="val 16000"/>
+            </a:avLst>
+          </a:prstGeom>
+          <a:solidFill>
+            <a:srgbClr val="3F6F5F"/>
+          </a:solidFill>
+          <a:ln/>
+        </p:spPr>
+      </p:sp>
+      <p:sp>
+        <p:nvSpPr>
+          <p:cNvPr id="9" name="Text 7"/>
+          <p:cNvSpPr/>
+          <p:nvPr/>
+        </p:nvSpPr>
+        <p:spPr>
+          <a:xfrm>
+            <a:off x="640080" y="3520440"/>
+            <a:ext cx="457200" cy="457200"/>
+          </a:xfrm>
+          <a:prstGeom prst="rect">
+            <a:avLst/>
+          </a:prstGeom>
+          <a:noFill/>
+          <a:ln/>
+        </p:spPr>
+        <p:txBody>
+          <a:bodyPr wrap="square" rtlCol="0" anchor="ctr"/>
+          <a:lstStyle/>
+          <a:p>
+            <a:pPr algn="ctr" indent="0" marL="0">
+              <a:buNone/>
+            </a:pPr>
+            <a:r>
+              <a:rPr lang="en-US" sz="2000" b="1" dirty="0">
+                <a:solidFill>
+                  <a:srgbClr val="FFFFFF"/>
+                </a:solidFill>
+                <a:latin typeface="Cambria" pitchFamily="34" charset="0"/>
+                <a:ea typeface="Cambria" pitchFamily="34" charset="-122"/>
+                <a:cs typeface="Cambria" pitchFamily="34" charset="-120"/>
+              </a:rPr>
+              <a:t>2</a:t>
+            </a:r>
+            <a:endParaRPr lang="en-US" sz="2000" dirty="0"/>
+          </a:p>
+        </p:txBody>
+      </p:sp>
+      <p:sp>
+        <p:nvSpPr>
+          <p:cNvPr id="10" name="Text 8"/>
+          <p:cNvSpPr/>
+          <p:nvPr/>
+        </p:nvSpPr>
+        <p:spPr>
+          <a:xfrm>
+            <a:off x="1371600" y="3483864"/>
+            <a:ext cx="10332720" cy="411480"/>
+          </a:xfrm>
+          <a:prstGeom prst="rect">
+            <a:avLst/>
+          </a:prstGeom>
+          <a:noFill/>
+          <a:ln/>
+        </p:spPr>
+        <p:txBody>
+          <a:bodyPr wrap="square" rtlCol="0" anchor="ctr"/>
+          <a:lstStyle/>
+          <a:p>
+            <a:pPr indent="0" marL="0">
+              <a:buNone/>
+            </a:pPr>
+            <a:r>
+              <a:rPr lang="en-US" sz="1900" b="1" dirty="0">
+                <a:solidFill>
+                  <a:srgbClr val="3F6F5F"/>
+                </a:solidFill>
+                <a:latin typeface="Cambria" pitchFamily="34" charset="0"/>
+                <a:ea typeface="Cambria" pitchFamily="34" charset="-122"/>
+                <a:cs typeface="Cambria" pitchFamily="34" charset="-120"/>
+              </a:rPr>
+              <a:t>Make something real</a:t>
+            </a:r>
+            <a:endParaRPr lang="en-US" sz="1900" dirty="0"/>
+          </a:p>
+        </p:txBody>
+      </p:sp>
+      <p:sp>
+        <p:nvSpPr>
+          <p:cNvPr id="11" name="Text 9"/>
+          <p:cNvSpPr/>
+          <p:nvPr/>
+        </p:nvSpPr>
+        <p:spPr>
+          <a:xfrm>
+            <a:off x="1371600" y="3904488"/>
+            <a:ext cx="10332720" cy="914400"/>
+          </a:xfrm>
+          <a:prstGeom prst="rect">
+            <a:avLst/>
+          </a:prstGeom>
+          <a:noFill/>
+          <a:ln/>
+        </p:spPr>
+        <p:txBody>
+          <a:bodyPr wrap="square" rtlCol="0" anchor="t">
+            <a:spAutoFit/>
+          </a:bodyPr>
+          <a:lstStyle/>
+          <a:p>
+            <a:pPr indent="0" marL="0">
+              <a:lnSpc>
+                <a:spcPct val="112000"/>
+              </a:lnSpc>
+              <a:buNone/>
+            </a:pPr>
+            <a:r>
+              <a:rPr lang="en-US" sz="1450" dirty="0">
+                <a:solidFill>
+                  <a:srgbClr val="1A1A1A"/>
+                </a:solidFill>
+                <a:latin typeface="Calibri" pitchFamily="34" charset="0"/>
+                <a:ea typeface="Calibri" pitchFamily="34" charset="-122"/>
+                <a:cs typeface="Calibri" pitchFamily="34" charset="-120"/>
+              </a:rPr>
+              <a:t>A complete investigation by the first break, before any theory.</a:t>
+            </a:r>
+            <a:endParaRPr lang="en-US" sz="1450" dirty="0"/>
+          </a:p>
+        </p:txBody>
+      </p:sp>
+      <p:sp>
+        <p:nvSpPr>
+          <p:cNvPr id="12" name="Shape 10"/>
+          <p:cNvSpPr/>
+          <p:nvPr/>
+        </p:nvSpPr>
+        <p:spPr>
+          <a:xfrm>
+            <a:off x="640080" y="4983480"/>
+            <a:ext cx="457200" cy="457200"/>
+          </a:xfrm>
+          <a:prstGeom prst="roundRect">
+            <a:avLst>
+              <a:gd name="adj" fmla="val 16000"/>
+            </a:avLst>
+          </a:prstGeom>
+          <a:solidFill>
+            <a:srgbClr val="B9852F"/>
+          </a:solidFill>
+          <a:ln/>
+        </p:spPr>
+      </p:sp>
+      <p:sp>
+        <p:nvSpPr>
+          <p:cNvPr id="13" name="Text 11"/>
+          <p:cNvSpPr/>
+          <p:nvPr/>
+        </p:nvSpPr>
+        <p:spPr>
+          <a:xfrm>
+            <a:off x="640080" y="4983480"/>
+            <a:ext cx="457200" cy="457200"/>
+          </a:xfrm>
+          <a:prstGeom prst="rect">
+            <a:avLst/>
+          </a:prstGeom>
+          <a:noFill/>
+          <a:ln/>
+        </p:spPr>
+        <p:txBody>
+          <a:bodyPr wrap="square" rtlCol="0" anchor="ctr"/>
+          <a:lstStyle/>
+          <a:p>
+            <a:pPr algn="ctr" indent="0" marL="0">
+              <a:buNone/>
+            </a:pPr>
+            <a:r>
+              <a:rPr lang="en-US" sz="2000" b="1" dirty="0">
+                <a:solidFill>
+                  <a:srgbClr val="FFFFFF"/>
+                </a:solidFill>
+                <a:latin typeface="Cambria" pitchFamily="34" charset="0"/>
+                <a:ea typeface="Cambria" pitchFamily="34" charset="-122"/>
+                <a:cs typeface="Cambria" pitchFamily="34" charset="-120"/>
+              </a:rPr>
+              <a:t>3</a:t>
+            </a:r>
+            <a:endParaRPr lang="en-US" sz="2000" dirty="0"/>
+          </a:p>
+        </p:txBody>
+      </p:sp>
+      <p:sp>
+        <p:nvSpPr>
+          <p:cNvPr id="14" name="Text 12"/>
+          <p:cNvSpPr/>
+          <p:nvPr/>
+        </p:nvSpPr>
+        <p:spPr>
+          <a:xfrm>
+            <a:off x="1371600" y="4946904"/>
+            <a:ext cx="10332720" cy="411480"/>
+          </a:xfrm>
+          <a:prstGeom prst="rect">
+            <a:avLst/>
+          </a:prstGeom>
+          <a:noFill/>
+          <a:ln/>
+        </p:spPr>
+        <p:txBody>
+          <a:bodyPr wrap="square" rtlCol="0" anchor="ctr"/>
+          <a:lstStyle/>
+          <a:p>
+            <a:pPr indent="0" marL="0">
+              <a:buNone/>
+            </a:pPr>
+            <a:r>
+              <a:rPr lang="en-US" sz="1900" b="1" dirty="0">
+                <a:solidFill>
+                  <a:srgbClr val="B9852F"/>
+                </a:solidFill>
+                <a:latin typeface="Cambria" pitchFamily="34" charset="0"/>
+                <a:ea typeface="Cambria" pitchFamily="34" charset="-122"/>
+                <a:cs typeface="Cambria" pitchFamily="34" charset="-120"/>
+              </a:rPr>
+              <a:t>Images are culture too</a:t>
+            </a:r>
+            <a:endParaRPr lang="en-US" sz="1900" dirty="0"/>
+          </a:p>
+        </p:txBody>
+      </p:sp>
+      <p:sp>
+        <p:nvSpPr>
+          <p:cNvPr id="15" name="Text 13"/>
+          <p:cNvSpPr/>
+          <p:nvPr/>
+        </p:nvSpPr>
+        <p:spPr>
+          <a:xfrm>
+            <a:off x="1371600" y="5367528"/>
+            <a:ext cx="10332720" cy="914400"/>
+          </a:xfrm>
+          <a:prstGeom prst="rect">
+            <a:avLst/>
+          </a:prstGeom>
+          <a:noFill/>
+          <a:ln/>
+        </p:spPr>
+        <p:txBody>
+          <a:bodyPr wrap="square" rtlCol="0" anchor="t">
+            <a:spAutoFit/>
+          </a:bodyPr>
+          <a:lstStyle/>
+          <a:p>
+            <a:pPr indent="0" marL="0">
+              <a:lnSpc>
+                <a:spcPct val="112000"/>
+              </a:lnSpc>
+              <a:buNone/>
+            </a:pPr>
+            <a:r>
+              <a:rPr lang="en-US" sz="1450" dirty="0">
+                <a:solidFill>
+                  <a:srgbClr val="1A1A1A"/>
+                </a:solidFill>
+                <a:latin typeface="Calibri" pitchFamily="34" charset="0"/>
+                <a:ea typeface="Calibri" pitchFamily="34" charset="-122"/>
+                <a:cs typeface="Calibri" pitchFamily="34" charset="-120"/>
+              </a:rPr>
+              <a:t>A picture is numbers: you counted pixels on day one, and images continue as a co-equal corpus through all ten weeks.</a:t>
+            </a:r>
+            <a:endParaRPr lang="en-US" sz="1450" dirty="0"/>
+          </a:p>
+        </p:txBody>
+      </p:sp>
+    </p:spTree>
+  </p:cSld>
+  <p:clrMapOvr>
+    <a:masterClrMapping/>
+  </p:clrMapOvr>
+</p:sld>
+</file>
+
+<file path=ppt/slides/slide17.xml><?xml version="1.0" encoding="utf-8"?>
+<p:sld xmlns:a="http://schemas.openxmlformats.org/drawingml/2006/main" xmlns:r="http://schemas.openxmlformats.org/officeDocument/2006/relationships" xmlns:p="http://schemas.openxmlformats.org/presentationml/2006/main">
+  <p:cSld name="Slide 17">
     <p:bg>
       <p:bgPr>
         <a:solidFill>

</xml_diff>

<commit_message>
Week 1: drop scrambling, full counts matrix with row/column sums and df plots, missing-data section on the manifest; remove em dashes across notebooks
</commit_message>
<xml_diff>
--- a/slides/pptx/week-01.pptx
+++ b/slides/pptx/week-01.pptx
@@ -3987,7 +3987,7 @@
                 <a:ea typeface="Cambria" pitchFamily="34" charset="-122"/>
                 <a:cs typeface="Cambria" pitchFamily="34" charset="-120"/>
               </a:rPr>
-              <a:t>Bags of words, bags of pixels, and what scrambling shows</a:t>
+              <a:t>Bags of words, bags of pixels, and what they miss</a:t>
             </a:r>
             <a:endParaRPr lang="en-US" sz="3000" dirty="0"/>
           </a:p>
@@ -4243,7 +4243,7 @@
                 <a:ea typeface="Calibri" pitchFamily="34" charset="-122"/>
                 <a:cs typeface="Calibri" pitchFamily="34" charset="-120"/>
               </a:rPr>
-              <a:t>A painting and its shuffled pixels share the brightness, the average color, and the palette. Composition is to images what order and negation are to sentences.</a:t>
+              <a:t>The manifest's date column reads "ca. 1520" and "1530s". Force it to numbers and pandas quietly turns those into NaN, and mean() skips NaN without telling you: the average drops half the paintings, the older half. Count your NaN before you average.</a:t>
             </a:r>
             <a:endParaRPr lang="en-US" sz="1500" dirty="0"/>
           </a:p>
@@ -6750,7 +6750,7 @@
                 <a:ea typeface="Calibri" pitchFamily="34" charset="-122"/>
                 <a:cs typeface="Calibri" pitchFamily="34" charset="-120"/>
               </a:rPr>
-              <a:t>Lab 2 (worked): count pixels. The manifest is the first CSV (rows are paintings, columns are the Met's choices); the 18 paintings rank darkest to brightest in a grid, and the corpus palette is a bar chart of defined color ranges. A painting beside its scrambled pixels shows what the bag cannot hold. The after-class half, the boundary experiment and Sonnet 130's bag against the poem itself, is this week's guided homework. Image projects begin here.</a:t>
+              <a:t>Lab 2 (worked): count pixels. The manifest is the first CSV (rows are paintings, columns are the Met's choices); the 18 paintings rank darkest to brightest in a grid, and the corpus palette is a bar chart of defined color ranges. The manifest's messy dates set the missing-data trap: forced to numbers, half become NaN, and the average quietly drops the older half of the corpus. The after-class half, the boundary experiment and Sonnet 130's bag against the poem itself, is this week's guided homework. Image projects begin here.</a:t>
             </a:r>
             <a:endParaRPr lang="en-US" sz="1100" dirty="0"/>
           </a:p>

</xml_diff>

<commit_message>
Python basics cells in Week 1; all notebooks pull live from source (Gutenberg, Met API), cached-data references removed
</commit_message>
<xml_diff>
--- a/slides/pptx/week-01.pptx
+++ b/slides/pptx/week-01.pptx
@@ -4955,7 +4955,7 @@
                 <a:ea typeface="Calibri" pitchFamily="34" charset="-122"/>
                 <a:cs typeface="Calibri" pitchFamily="34" charset="-120"/>
               </a:rPr>
-              <a:t>Rows: a manifest of 18 paintings, counted and ranked in one pipeline.</a:t>
+              <a:t>Rows: a manifest of paintings, downloaded live and ranked in one pipeline.</a:t>
             </a:r>
             <a:endParaRPr lang="en-US" sz="1650" dirty="0"/>
           </a:p>
@@ -5257,7 +5257,7 @@
                 <a:ea typeface="Cambria" pitchFamily="34" charset="-122"/>
                 <a:cs typeface="Cambria" pitchFamily="34" charset="-120"/>
               </a:rPr>
-              <a:t>Eighteen real paintings, public domain, snapshotted in the repo</a:t>
+              <a:t>Real CC0 paintings from the Met's open-access collection, downloaded live in the notebook</a:t>
             </a:r>
             <a:endParaRPr lang="en-US" sz="2600" dirty="0"/>
           </a:p>
@@ -5480,7 +5480,7 @@
                 <a:ea typeface="Calibri" pitchFamily="34" charset="-122"/>
                 <a:cs typeface="Calibri" pitchFamily="34" charset="-120"/>
               </a:rPr>
-              <a:t>Counted by brightness in the session; by defined color ranges after class.</a:t>
+              <a:t>Counted by brightness in the session; by defined color ranges after class. The notebook downloads its own set live.</a:t>
             </a:r>
             <a:endParaRPr lang="en-US" sz="1200" dirty="0"/>
           </a:p>
@@ -6750,7 +6750,7 @@
                 <a:ea typeface="Calibri" pitchFamily="34" charset="-122"/>
                 <a:cs typeface="Calibri" pitchFamily="34" charset="-120"/>
               </a:rPr>
-              <a:t>Lab 2 (worked): count pixels. The manifest is the first CSV (rows are paintings, columns are the Met's choices); the 18 paintings rank darkest to brightest in a grid, and the corpus palette is a bar chart of defined color ranges. The manifest's messy dates set the missing-data trap: forced to numbers, half become NaN, and the average quietly drops the older half of the corpus. The after-class half, the boundary experiment and Sonnet 130's bag against the poem itself, is this week's guided homework. Image projects begin here.</a:t>
+              <a:t>Lab 2 (worked): count pixels. The manifest is the first CSV (rows are paintings, columns are the Met's choices); a dozen paintings download live from the Met API and rank darkest to brightest in a grid, and the corpus palette is a bar chart of defined color ranges. The manifest's messy dates set the missing-data trap: forced to numbers, half become NaN, and the average quietly drops the older half of the corpus. The after-class half, the boundary experiment and Sonnet 130's bag against the poem itself, is this week's guided homework. Image projects begin here.</a:t>
             </a:r>
             <a:endParaRPr lang="en-US" sz="1100" dirty="0"/>
           </a:p>
@@ -10749,7 +10749,7 @@
                 <a:ea typeface="Calibri" pitchFamily="34" charset="-122"/>
                 <a:cs typeface="Calibri" pitchFamily="34" charset="-120"/>
               </a:rPr>
-              <a:t>A CSV: one row per thing, one column per recorded fact. Ours: 18 paintings, seven columns.</a:t>
+              <a:t>A CSV: one row per thing, one column per recorded fact. Ours: one row per painting, one column per fact the Met records.</a:t>
             </a:r>
             <a:endParaRPr lang="en-US" sz="1500" dirty="0"/>
           </a:p>

</xml_diff>